<commit_message>
Add Langdock as EU-native platform recommendation to ai-policy deck
Introduces the "platform vs. direct provider" structural choice for EU
companies. Langdock (German GmbH, Azure Frankfurt, EU data residency by
default) is now the recommended Option A for EU companies, replacing the
previous default of Google Workspace Gemini.

Changes across narrative, content outline, slide design, and generation:
- Slide 15: breather updated to frame the platform/direct provider choice
- Slide 16 (new): Langdock profile — ISO 27001, SOC 2, 30+ models,
  ~€23.20/user/month, Merck/Der Spiegel/Personio/Volksbank customers
- Slide 27: five questions updated — Q4 now explicitly mentions the
  platform approach (one DPA, all models)
- Slide 29: EU recommendations rebuilt from two-column EU/non-EU to
  three-path format (A: Langdock, B: Embedded AI, C: Direct provider)
- Total slides: 33 → 34

Co-Authored-By: Claude Sonnet 4.6 <noreply@anthropic.com>
</commit_message>
<xml_diff>
--- a/decks/ai-policy/ai-policy.pptx
+++ b/decks/ai-policy/ai-policy.pptx
@@ -38,9 +38,10 @@
     <p:sldId id="286" r:id="rId32"/>
     <p:sldId id="287" r:id="rId33"/>
     <p:sldId id="288" r:id="rId34"/>
+    <p:sldId id="289" r:id="rId35"/>
   </p:sldIdLst>
   <p:notesMasterIdLst>
-    <p:notesMasterId r:id="rId35"/>
+    <p:notesMasterId r:id="rId36"/>
   </p:notesMasterIdLst>
   <p:sldSz cx="9144000" cy="5143500"/>
   <p:notesSz cx="5143500" cy="9144000"/>
@@ -1062,7 +1063,7 @@
           <a:p>
             <a:r>
               <a:rPr lang="en-US" dirty="0"/>
-              <a:t>Transition to the provider comparison — the core reference section of the deck.</a:t>
+              <a:t>Transition. The audience has seen why tiers matter — now introduce the structural choice EU companies face: an EU-native platform that sits in front of multiple models (like Langdock), or a direct relationship with a US provider’s enterprise tier. The platform option is new to most readers — make this framing clear before the comparison slides.</a:t>
             </a:r>
             <a:endParaRPr lang="en-US" dirty="0"/>
           </a:p>
@@ -1150,7 +1151,7 @@
           <a:p>
             <a:r>
               <a:rPr lang="en-US" dirty="0"/>
-              <a:t>Four providers dominate. Each offers both general-use assistants and coding tools. The no-training guarantee is available from all four — but only at enterprise tiers. OpenAI rebranded “Team” to “Business” in 2025. Codex is now a full cloud-based agentic platform (GPT-5.3-Codex, Feb 2026), not just a coding tool. Gemini Code Assist comes in Standard and Enterprise editions. M365 Copilot is a paid add-on (~$30/user/month), not included with M365 subscriptions. Provider policies change frequently — verify current terms before acting.</a:t>
+              <a:t>Langdock is a German GmbH, hosted on Microsoft Azure in Frankfurt — EU data residency is the default on the standard tier, not an enterprise add-on to negotiate for. No training on customer data. One DPA with an EU company (not US-based providers relying on SCCs). Supports 30+ models: Claude Opus 4.6/Sonnet 4.6, GPT-5 series, Gemini 2.5 Pro/Flash, Mistral Large, Llama — with many available in EU regions. One interface for chat, agents, workflows, and integrations. Used by Merck (33,000 MAU), Der Spiegel, Personio, Volksbank, Eppendorf, SumUp, 5,000+ companies. Trade-off: adding a platform vendor, though it replaces multiple vendor relationships. If you have strong model preferences or existing enterprise contracts, a direct provider may be simpler — which is what the next two slides cover. Sources: langdock.com/security, trust.langdock.com/faq.</a:t>
             </a:r>
             <a:endParaRPr lang="en-US" dirty="0"/>
           </a:p>
@@ -1238,7 +1239,7 @@
           <a:p>
             <a:r>
               <a:rPr lang="en-US" dirty="0"/>
-              <a:t>EU data residency varies dramatically. Google: native across 10+ EU regions on Vertex AI with contractual data location commitments. OpenAI: added EU residency for Enterprise/Edu (storage at rest since Feb 2025, inference residency since Jan 2026). ChatGPT Business does NOT yet have EU residency. Microsoft: EU Data Boundary applies for M365 Copilot EU users, but Anthropic model calls and Bing web search queries are excluded (as of Jan 2026). Azure OpenAI offers EU residency via Standard/DataZone deployment. Anthropic: no direct EU residency, but Claude models available on Vertex AI and Bedrock in EU regions. Transfer mechanisms: OpenAI uses SCCs and is notably NOT DPF-certified. Anthropic uses SCCs via Anthropic Ireland Limited. Google uses its CDPA. Microsoft uses DPA + EU Data Boundary. Certification highlights: Anthropic has the broadest pure-play AI certification matrix (SOC 2 Type II, ISO 27001, ISO 42001, HIPAA, CSA STAR, NIST 800-171, FedRAMP High). All four hold ISO 42001.</a:t>
+              <a:t>Four providers dominate. Each offers both general-use assistants and coding tools. The no-training guarantee is available from all four — but only at enterprise tiers. OpenAI rebranded “Team” to “Business” in 2025. Codex is now a full cloud-based agentic platform (GPT-5.3-Codex, Feb 2026), not just a coding tool. Gemini Code Assist comes in Standard and Enterprise editions. M365 Copilot is a paid add-on (~$30/user/month), not included with M365 subscriptions. Provider policies change frequently — verify current terms before acting.</a:t>
             </a:r>
             <a:endParaRPr lang="en-US" dirty="0"/>
           </a:p>
@@ -1326,7 +1327,7 @@
           <a:p>
             <a:r>
               <a:rPr lang="en-US" dirty="0"/>
-              <a:t>A DPA (Data Processing Agreement) says: “you won’t train on my data” and “you’ll help me with deletion requests.” It does NOT control where data is physically processed. It’s a governance document, not a geography document. This distinction matters because most decision makers assume “we signed a DPA, we’re compliant.” A DPA is necessary but not sufficient for full compliance posture.</a:t>
+              <a:t>EU data residency varies dramatically. Google: native across 10+ EU regions on Vertex AI with contractual data location commitments. OpenAI: added EU residency for Enterprise/Edu (storage at rest since Feb 2025, inference residency since Jan 2026). ChatGPT Business does NOT yet have EU residency. Microsoft: EU Data Boundary applies for M365 Copilot EU users, but Anthropic model calls and Bing web search queries are excluded (as of Jan 2026). Azure OpenAI offers EU residency via Standard/DataZone deployment. Anthropic: no direct EU residency, but Claude models available on Vertex AI and Bedrock in EU regions. Transfer mechanisms: OpenAI uses SCCs and is notably NOT DPF-certified. Anthropic uses SCCs via Anthropic Ireland Limited. Google uses its CDPA. Microsoft uses DPA + EU Data Boundary. Certification highlights: Anthropic has the broadest pure-play AI certification matrix (SOC 2 Type II, ISO 27001, ISO 42001, HIPAA, CSA STAR, NIST 800-171, FedRAMP High). All four hold ISO 42001.</a:t>
             </a:r>
             <a:endParaRPr lang="en-US" dirty="0"/>
           </a:p>
@@ -1414,7 +1415,7 @@
           <a:p>
             <a:r>
               <a:rPr lang="en-US" dirty="0"/>
-              <a:t>DPA + SCCs is the standard practice for EU companies using US SaaS — legally valid, widely used, same posture as Microsoft 365 or Salesforce. The residual risk: SCCs have been invalidated before (Schrems I in 2015, Schrems II in 2020) and AI tools are under heightened regulatory scrutiny (EUR 15M OpenAI fine, EDPB ChatGPT Taskforce). EU data residency removes this risk entirely — data never leaves the EU, no Chapter V transfer to justify. Both are GDPR-legal. The difference is risk profile under supervisory authority scrutiny and whether your sector requires actual data localisation.</a:t>
+              <a:t>A DPA (Data Processing Agreement) says: “you won’t train on my data” and “you’ll help me with deletion requests.” It does NOT control where data is physically processed. It’s a governance document, not a geography document. This distinction matters because most decision makers assume “we signed a DPA, we’re compliant.” A DPA is necessary but not sufficient for full compliance posture.</a:t>
             </a:r>
             <a:endParaRPr lang="en-US" dirty="0"/>
           </a:p>
@@ -1590,7 +1591,7 @@
           <a:p>
             <a:r>
               <a:rPr lang="en-US" dirty="0"/>
-              <a:t>Cyberhaven research found that 11% of what employees copy and paste into ChatGPT is sensitive data — customer names, financial information, proprietary content. This is not malice; it’s muscle memory. Someone drafts a customer email, pastes the thread for context, and now a real name + email + complaint details are on US servers. You cannot policy your way around human behaviour at this scale.</a:t>
+              <a:t>DPA + SCCs is the standard practice for EU companies using US SaaS — legally valid, widely used, same posture as Microsoft 365 or Salesforce. The residual risk: SCCs have been invalidated before (Schrems I in 2015, Schrems II in 2020) and AI tools are under heightened regulatory scrutiny (EUR 15M OpenAI fine, EDPB ChatGPT Taskforce). EU data residency removes this risk entirely — data never leaves the EU, no Chapter V transfer to justify. Both are GDPR-legal. The difference is risk profile under supervisory authority scrutiny and whether your sector requires actual data localisation.</a:t>
             </a:r>
             <a:endParaRPr lang="en-US" dirty="0"/>
           </a:p>
@@ -1678,7 +1679,7 @@
           <a:p>
             <a:r>
               <a:rPr lang="en-US" dirty="0"/>
-              <a:t>The honest starting point for EU companies: you cannot prevent PII from entering AI tools. A customer name in an email draft, a real account number in a data analysis, a client’s project details in a brainstorm. Instead of relying on unenforceable “don’t paste PII” policies, make the default path safe enough that accidental PII exposure is already covered. This means EU data residency as the default for EU companies, not a secondary path.</a:t>
+              <a:t>Cyberhaven research found that 11% of what employees copy and paste into ChatGPT is sensitive data — customer names, financial information, proprietary content. This is not malice; it’s muscle memory. Someone drafts a customer email, pastes the thread for context, and now a real name + email + complaint details are on US servers. You cannot policy your way around human behaviour at this scale.</a:t>
             </a:r>
             <a:endParaRPr lang="en-US" dirty="0"/>
           </a:p>
@@ -1766,7 +1767,7 @@
           <a:p>
             <a:r>
               <a:rPr lang="en-US" dirty="0"/>
-              <a:t>Claude Code on GCP: CLAUDE_CODE_USE_VERTEX=1 with EU region. Google’s CDPA. 10+ EU regions (Belgium, Netherlands, Frankfurt, Zurich, Paris, Milan, Finland, Warsaw, Madrid, London). Full model lineup: Opus 4.6, Sonnet 4.6, Haiku 4.5. Claude Code on AWS: CLAUDE_CODE_USE_BEDROCK=1 with EU region (Ireland, Frankfurt). Azure OpenAI (Microsoft Foundry): Standard or DataZone deployment in EU — avoid Global deployment. M365 Copilot: EU Data Boundary automatic for EU users, but Anthropic model calls and Bing web search queries currently excluded.</a:t>
+              <a:t>The honest starting point for EU companies: you cannot prevent PII from entering AI tools. A customer name in an email draft, a real account number in a data analysis, a client’s project details in a brainstorm. Instead of relying on unenforceable “don’t paste PII” policies, make the default path safe enough that accidental PII exposure is already covered. This means EU data residency as the default for EU companies, not a secondary path.</a:t>
             </a:r>
             <a:endParaRPr lang="en-US" dirty="0"/>
           </a:p>
@@ -1854,7 +1855,7 @@
           <a:p>
             <a:r>
               <a:rPr lang="en-US" dirty="0"/>
-              <a:t>The two-path split only works where the data boundary is enforceable — and that’s coding. For everyday use (email drafting, research, analysis), PII will enter regardless: customer names in email threads, real account numbers in analysis, client details in brainstorms. You cannot policy your way around this. For coding, the boundary is enforceable: test data vs production data is a clear technical distinction. Engineering coding new features with test data doesn’t need EU residency. Debugging a production issue with real customer data does. For EU companies: default everyday use tools to EU-resident. Only coding has a practical two-path split.</a:t>
+              <a:t>Claude Code on GCP: CLAUDE_CODE_USE_VERTEX=1 with EU region. Google’s CDPA. 10+ EU regions (Belgium, Netherlands, Frankfurt, Zurich, Paris, Milan, Finland, Warsaw, Madrid, London). Full model lineup: Opus 4.6, Sonnet 4.6, Haiku 4.5. Claude Code on AWS: CLAUDE_CODE_USE_BEDROCK=1 with EU region (Ireland, Frankfurt). Azure OpenAI (Microsoft Foundry): Standard or DataZone deployment in EU — avoid Global deployment. M365 Copilot: EU Data Boundary automatic for EU users, but Anthropic model calls and Bing web search queries currently excluded.</a:t>
             </a:r>
             <a:endParaRPr lang="en-US" dirty="0"/>
           </a:p>
@@ -1942,7 +1943,7 @@
           <a:p>
             <a:r>
               <a:rPr lang="en-US" dirty="0"/>
-              <a:t>Only one of these four scenarios has an enforceable PII boundary: engineering coding with test data. In every other case, PII will enter the tool — customer names in marketing emails, real account details in ops claims, production customer data in debugging. The two-path split is a coding architecture decision, not a company-wide policy. For everything else, assume PII enters and choose your tools accordingly.</a:t>
+              <a:t>The two-path split only works where the data boundary is enforceable — and that’s coding. For everyday use (email drafting, research, analysis), PII will enter regardless: customer names in email threads, real account numbers in analysis, client details in brainstorms. You cannot policy your way around this. For coding, the boundary is enforceable: test data vs production data is a clear technical distinction. Engineering coding new features with test data doesn’t need EU residency. Debugging a production issue with real customer data does. For EU companies: default everyday use tools to EU-resident. Only coding has a practical two-path split.</a:t>
             </a:r>
             <a:endParaRPr lang="en-US" dirty="0"/>
           </a:p>
@@ -2030,7 +2031,7 @@
           <a:p>
             <a:r>
               <a:rPr lang="en-US" dirty="0"/>
-              <a:t>Transition. The audience has the landscape, the rules, the comparison, and the architecture. Now give them the decision framework and the concrete answer.</a:t>
+              <a:t>Only one of these four scenarios has an enforceable PII boundary: engineering coding with test data. In every other case, PII will enter the tool — customer names in marketing emails, real account details in ops claims, production customer data in debugging. The two-path split is a coding architecture decision, not a company-wide policy. For everything else, assume PII enters and choose your tools accordingly.</a:t>
             </a:r>
             <a:endParaRPr lang="en-US" dirty="0"/>
           </a:p>
@@ -2118,7 +2119,7 @@
           <a:p>
             <a:r>
               <a:rPr lang="en-US" dirty="0"/>
-              <a:t>1. What data touches the tool? PII = enterprise tier minimum. Sensitive + EU = EU residency. 2. Where are your customers? EU customers = GDPR applies. Consider residency, not just SCCs. 3. Engineering vs everyone else? Different departments = different risk profiles. 4. How many tools can you manage? Every tool = a DPA, a policy, training. Sweet spot: 2–3. 5. What’s your compliance maturity? No DPO? Pick the simplest path. Question 1 is the most important — it determines minimum tier and whether EU residency matters. Question 4 is the most underestimated. Question 5 is about honesty: startups with no compliance function should pick one enterprise-tier tool with a signed DPA and keep it simple.</a:t>
+              <a:t>Transition. The audience has the landscape, the rules, the comparison, and the architecture. Now give them the decision framework and the concrete answer.</a:t>
             </a:r>
             <a:endParaRPr lang="en-US" dirty="0"/>
           </a:p>
@@ -2206,7 +2207,7 @@
           <a:p>
             <a:r>
               <a:rPr lang="en-US" dirty="0"/>
-              <a:t>This section provides an opinionated starting point for both EU and non-EU companies. These are informed suggestions based on the research in this deck — not legal advice. Have your legal team review before implementing.</a:t>
+              <a:t>Question 1 is the most important — it determines minimum tier and whether EU residency matters. Question 2: EU customers = GDPR applies. Consider residency, not just SCCs. Question 3: Different departments = different risk profiles. Question 4 is what most companies underestimate: each direct provider relationship is a DPA to sign, a tier distinction to communicate to employees, and a training programme to run. For EU companies, the platform approach (Langdock) collapses this: one DPA with an EU company, one interface for employees, one admin dashboard for policy. Question 5 is about honesty — if you don’t have a DPO, pick the simplest path: Langdock or one provider at enterprise tier with a signed DPA.</a:t>
             </a:r>
             <a:endParaRPr lang="en-US" dirty="0"/>
           </a:p>
@@ -2294,7 +2295,7 @@
           <a:p>
             <a:r>
               <a:rPr lang="en-US" dirty="0"/>
-              <a:t>EU recommendation: the two-path split only applies to coding — general use tools will inevitably handle PII (customer names in emails, real data in analysis), so default to EU-resident for everything non-coding. Google Workspace Gemini is the strongest default: native EU data handling under the CDPA, no training, ISO 42001. Alternatives: M365 Copilot (EU Data Boundary, ~$30/user/month add-on — note Anthropic model calls excluded from EU Boundary), or ChatGPT Enterprise (EU residency for storage + inference). Claude Team is viable via SCCs but weaker posture — no direct EU residency. For coding: Claude Code via Vertex AI (EU region) for any work that touches production data or could encounter PII. General coding with test data can use Claude Code directly on Team/Enterprise/API plan. GitHub Copilot Business is an alternative for coding (no training, no prompt retention). Non-EU companies: Claude Team or ChatGPT Business with a signed DPA. If already paying for M365, evaluate Copilot before adding another tool.</a:t>
+              <a:t>This section provides an opinionated starting point for both EU and non-EU companies. These are informed suggestions based on the research in this deck — not legal advice. Have your legal team review before implementing.</a:t>
             </a:r>
             <a:endParaRPr lang="en-US" dirty="0"/>
           </a:p>
@@ -2382,7 +2383,7 @@
           <a:p>
             <a:r>
               <a:rPr lang="en-US" dirty="0"/>
-              <a:t>The single highest-impact policy decision: free and consumer tiers of ANY provider are not approved for work use. This includes: free ChatGPT, Claude Free/Pro/Max (Consumer Terms — training allowed), ChatGPT Plus (trains by default), GitHub Copilot Free (training allowed), consumer Copilot without M365 login. No DPA, potential training on your data, no way to honour deletion requests.</a:t>
+              <a:t>Option A (Langdock) is the recommended starting point for EU companies evaluating from scratch: EU-native, EU data residency out of the box, no tier complexity, one DPA with an EU company, access to 30+ models. Option B is genuinely compelling regardless of your current stack — particularly if you want to minimise vendor count and already have a Microsoft or Google enterprise agreement. Option C for companies with a strong model preference or existing contract — ChatGPT Enterprise now has full EU data residency; Claude Team is legally defensible via SCCs but has no EU data residency from Anthropic directly (use Claude models via Langdock or Claude Code on Vertex/Bedrock for EU residency). Non-EU companies: Claude Team or ChatGPT Business with DPA remains the simple default. Coding: Claude Code via Vertex AI or Bedrock in EU region; GitHub Copilot Business/Enterprise. These are informed suggestions, not legal advice.</a:t>
             </a:r>
             <a:endParaRPr lang="en-US" dirty="0"/>
           </a:p>
@@ -2558,7 +2559,7 @@
           <a:p>
             <a:r>
               <a:rPr lang="en-US" dirty="0"/>
-              <a:t>This is a starting point, not an exhaustive policy. Have your legal team review and adapt it. Templates: GDPR Local offers a free AI literacy policy template, FRSecure has an AI acceptable use policy template. The most overlooked component is incident reporting — employees need to know what to do if they accidentally paste PII into an unapproved tool. Treat it as a potential data breach (72-hour GDPR notification requirement). AI literacy training is enforceable under EU AI Act Article 4 — not optional. Make it clear: the company is liable (not individual employees), but individuals must follow the policy.</a:t>
+              <a:t>The single highest-impact policy decision: free and consumer tiers of ANY provider are not approved for work use. This includes: free ChatGPT, Claude Free/Pro/Max (Consumer Terms — training allowed), ChatGPT Plus (trains by default), GitHub Copilot Free (training allowed), consumer Copilot without M365 login. No DPA, potential training on your data, no way to honour deletion requests.</a:t>
             </a:r>
             <a:endParaRPr lang="en-US" dirty="0"/>
           </a:p>
@@ -2646,7 +2647,7 @@
           <a:p>
             <a:r>
               <a:rPr lang="en-US" dirty="0"/>
-              <a:t>Pause before the closing. The audience has the framework, the comparison, the recommendation, and the policy checklist. Now tie it together.</a:t>
+              <a:t>This is a starting point, not an exhaustive policy. Have your legal team review and adapt it. Templates: GDPR Local offers a free AI literacy policy template, FRSecure has an AI acceptable use policy template. The most overlooked component is incident reporting — employees need to know what to do if they accidentally paste PII into an unapproved tool. Treat it as a potential data breach (72-hour GDPR notification requirement). AI literacy training is enforceable under EU AI Act Article 4 — not optional. Make it clear: the company is liable (not individual employees), but individuals must follow the policy.</a:t>
             </a:r>
             <a:endParaRPr lang="en-US" dirty="0"/>
           </a:p>
@@ -2734,7 +2735,7 @@
           <a:p>
             <a:r>
               <a:rPr lang="en-US" dirty="0"/>
-              <a:t>Let this land. The deck has given the reader everything they need. This closing reframes the entire deck as an empowering choice, not a restrictive burden.</a:t>
+              <a:t>Pause before the closing. The audience has the framework, the comparison, the recommendation, and the policy checklist. Now tie it together.</a:t>
             </a:r>
             <a:endParaRPr lang="en-US" dirty="0"/>
           </a:p>
@@ -2822,7 +2823,7 @@
           <a:p>
             <a:r>
               <a:rPr lang="en-US" dirty="0"/>
-              <a:t>The final line. The audience should leave feeling confident that they can make this decision — not that they need to hire a compliance consultancy first (though legal review of the final policy is always recommended). Callback to the opening: “Just ChatGPT” and “Wild West” both stem from the same gap — the absence of a deliberate choice.</a:t>
+              <a:t>Let this land. The deck has given the reader everything they need. This closing reframes the entire deck as an empowering choice, not a restrictive burden.</a:t>
             </a:r>
             <a:endParaRPr lang="en-US" dirty="0"/>
           </a:p>
@@ -2846,6 +2847,94 @@
             <a:fld id="{F7021451-1387-4CA6-816F-3879F97B5CBC}" type="slidenum">
               <a:rPr lang="en-US"/>
               <a:t>33</a:t>
+            </a:fld>
+            <a:endParaRPr lang="en-US"/>
+          </a:p>
+        </p:txBody>
+      </p:sp>
+    </p:spTree>
+    <p:extLst>
+      <p:ext uri="{BB962C8B-B14F-4D97-AF65-F5344CB8AC3E}">
+        <p14:creationId xmlns:p14="http://schemas.microsoft.com/office/powerpoint/2010/main" val="1024086991"/>
+      </p:ext>
+    </p:extLst>
+  </p:cSld>
+  <p:clrMapOvr>
+    <a:masterClrMapping/>
+  </p:clrMapOvr>
+</p:notes>
+</file>
+
+<file path=ppt/notesSlides/notesSlide34.xml><?xml version="1.0" encoding="utf-8"?>
+<p:notes xmlns:a="http://schemas.openxmlformats.org/drawingml/2006/main" xmlns:r="http://schemas.openxmlformats.org/officeDocument/2006/relationships" xmlns:p="http://schemas.openxmlformats.org/presentationml/2006/main">
+  <p:cSld>
+    <p:spTree>
+      <p:nvGrpSpPr>
+        <p:cNvPr id="1" name=""/>
+        <p:cNvGrpSpPr/>
+        <p:nvPr/>
+      </p:nvGrpSpPr>
+      <p:grpSpPr>
+        <a:xfrm>
+          <a:off x="0" y="0"/>
+          <a:ext cx="0" cy="0"/>
+          <a:chOff x="0" y="0"/>
+          <a:chExt cx="0" cy="0"/>
+        </a:xfrm>
+      </p:grpSpPr>
+      <p:sp>
+        <p:nvSpPr>
+          <p:cNvPr id="2" name="Slide Image Placeholder 1"/>
+          <p:cNvSpPr>
+            <a:spLocks noGrp="1" noRot="1" noChangeAspect="1"/>
+          </p:cNvSpPr>
+          <p:nvPr>
+            <p:ph type="sldImg"/>
+          </p:nvPr>
+        </p:nvSpPr>
+        <p:spPr/>
+      </p:sp>
+      <p:sp>
+        <p:nvSpPr>
+          <p:cNvPr id="3" name="Notes Placeholder 2"/>
+          <p:cNvSpPr>
+            <a:spLocks noGrp="1"/>
+          </p:cNvSpPr>
+          <p:nvPr>
+            <p:ph type="body" idx="1"/>
+          </p:nvPr>
+        </p:nvSpPr>
+        <p:spPr/>
+        <p:txBody>
+          <a:bodyPr/>
+          <a:lstStyle/>
+          <a:p>
+            <a:r>
+              <a:rPr lang="en-US" dirty="0"/>
+              <a:t>The final line. The audience should leave feeling confident that they can make this decision — not that they need to hire a compliance consultancy first (though legal review of the final policy is always recommended). Callback to the opening: “Just ChatGPT” and “Wild West” both stem from the same gap — the absence of a deliberate choice.</a:t>
+            </a:r>
+            <a:endParaRPr lang="en-US" dirty="0"/>
+          </a:p>
+        </p:txBody>
+      </p:sp>
+      <p:sp>
+        <p:nvSpPr>
+          <p:cNvPr id="4" name="Slide Number Placeholder 3"/>
+          <p:cNvSpPr>
+            <a:spLocks noGrp="1"/>
+          </p:cNvSpPr>
+          <p:nvPr>
+            <p:ph type="sldNum" sz="quarter" idx="10"/>
+          </p:nvPr>
+        </p:nvSpPr>
+        <p:spPr/>
+        <p:txBody>
+          <a:bodyPr/>
+          <a:lstStyle/>
+          <a:p>
+            <a:fld id="{F7021451-1387-4CA6-816F-3879F97B5CBC}" type="slidenum">
+              <a:rPr lang="en-US"/>
+              <a:t>34</a:t>
             </a:fld>
             <a:endParaRPr lang="en-US"/>
           </a:p>
@@ -5019,7 +5108,7 @@
                 <a:ea typeface="Georgia" pitchFamily="34" charset="-122"/>
                 <a:cs typeface="Georgia" pitchFamily="34" charset="-120"/>
               </a:rPr>
-              <a:t>So which tiers,</a:t>
+              <a:t>Platform or direct provider?</a:t>
             </a:r>
             <a:endParaRPr lang="en-US" sz="2800" dirty="0"/>
           </a:p>
@@ -5036,7 +5125,7 @@
                 <a:ea typeface="Georgia" pitchFamily="34" charset="-122"/>
                 <a:cs typeface="Georgia" pitchFamily="34" charset="-120"/>
               </a:rPr>
-              <a:t>from which providers?</a:t>
+              <a:t>Two paths. One structural choice.</a:t>
             </a:r>
             <a:endParaRPr lang="en-US" sz="2800" dirty="0"/>
           </a:p>
@@ -5083,6 +5172,332 @@
         <p:spPr>
           <a:xfrm>
             <a:off x="457200" y="182880"/>
+            <a:ext cx="8229600" cy="1097280"/>
+          </a:xfrm>
+          <a:prstGeom prst="rect">
+            <a:avLst/>
+          </a:prstGeom>
+          <a:noFill/>
+          <a:ln/>
+        </p:spPr>
+        <p:txBody>
+          <a:bodyPr wrap="square" lIns="0" tIns="0" rIns="0" bIns="0" rtlCol="0" anchor="ctr"/>
+          <a:lstStyle/>
+          <a:p>
+            <a:pPr indent="0" marL="0">
+              <a:buNone/>
+            </a:pPr>
+            <a:r>
+              <a:rPr lang="en-US" sz="4000" b="1" dirty="0">
+                <a:solidFill>
+                  <a:srgbClr val="1A1F36"/>
+                </a:solidFill>
+                <a:latin typeface="Georgia" pitchFamily="34" charset="0"/>
+                <a:ea typeface="Georgia" pitchFamily="34" charset="-122"/>
+                <a:cs typeface="Georgia" pitchFamily="34" charset="-120"/>
+              </a:rPr>
+              <a:t>Consider an EU-native platform first</a:t>
+            </a:r>
+            <a:endParaRPr lang="en-US" sz="4000" dirty="0"/>
+          </a:p>
+        </p:txBody>
+      </p:sp>
+      <p:sp>
+        <p:nvSpPr>
+          <p:cNvPr id="3" name="Text 1"/>
+          <p:cNvSpPr/>
+          <p:nvPr/>
+        </p:nvSpPr>
+        <p:spPr>
+          <a:xfrm>
+            <a:off x="457200" y="1463040"/>
+            <a:ext cx="8229600" cy="411480"/>
+          </a:xfrm>
+          <a:prstGeom prst="rect">
+            <a:avLst/>
+          </a:prstGeom>
+          <a:noFill/>
+          <a:ln/>
+        </p:spPr>
+        <p:txBody>
+          <a:bodyPr wrap="square" lIns="0" tIns="0" rIns="0" bIns="0" rtlCol="0" anchor="ctr"/>
+          <a:lstStyle/>
+          <a:p>
+            <a:pPr indent="0" marL="0">
+              <a:buNone/>
+            </a:pPr>
+            <a:r>
+              <a:rPr lang="en-US" sz="1800" dirty="0">
+                <a:solidFill>
+                  <a:srgbClr val="635BFF"/>
+                </a:solidFill>
+                <a:latin typeface="Verdana" pitchFamily="34" charset="0"/>
+                <a:ea typeface="Verdana" pitchFamily="34" charset="-122"/>
+                <a:cs typeface="Verdana" pitchFamily="34" charset="-120"/>
+              </a:rPr>
+              <a:t>One DPA with an EU company. EU data residency by default. Every major model.</a:t>
+            </a:r>
+            <a:endParaRPr lang="en-US" sz="1800" dirty="0"/>
+          </a:p>
+        </p:txBody>
+      </p:sp>
+      <p:sp>
+        <p:nvSpPr>
+          <p:cNvPr id="4" name="Text 2"/>
+          <p:cNvSpPr/>
+          <p:nvPr/>
+        </p:nvSpPr>
+        <p:spPr>
+          <a:xfrm>
+            <a:off x="457200" y="1965960"/>
+            <a:ext cx="8229600" cy="502920"/>
+          </a:xfrm>
+          <a:prstGeom prst="rect">
+            <a:avLst/>
+          </a:prstGeom>
+          <a:noFill/>
+          <a:ln/>
+        </p:spPr>
+        <p:txBody>
+          <a:bodyPr wrap="square" lIns="0" tIns="0" rIns="0" bIns="0" rtlCol="0" anchor="t"/>
+          <a:lstStyle/>
+          <a:p>
+            <a:pPr indent="0" marL="0">
+              <a:buNone/>
+            </a:pPr>
+            <a:r>
+              <a:rPr lang="en-US" sz="2000" b="1" dirty="0">
+                <a:solidFill>
+                  <a:srgbClr val="1A1F36"/>
+                </a:solidFill>
+                <a:latin typeface="Verdana" pitchFamily="34" charset="0"/>
+                <a:ea typeface="Verdana" pitchFamily="34" charset="-122"/>
+                <a:cs typeface="Verdana" pitchFamily="34" charset="-120"/>
+              </a:rPr>
+              <a:t>Langdock</a:t>
+            </a:r>
+            <a:pPr indent="0" marL="0">
+              <a:buNone/>
+            </a:pPr>
+            <a:r>
+              <a:rPr lang="en-US" sz="2000" dirty="0">
+                <a:solidFill>
+                  <a:srgbClr val="1A1F36"/>
+                </a:solidFill>
+                <a:latin typeface="Verdana" pitchFamily="34" charset="0"/>
+                <a:ea typeface="Verdana" pitchFamily="34" charset="-122"/>
+                <a:cs typeface="Verdana" pitchFamily="34" charset="-120"/>
+              </a:rPr>
+              <a:t> — German GmbH, hosted on Azure Frankfurt</a:t>
+            </a:r>
+            <a:endParaRPr lang="en-US" sz="2000" dirty="0"/>
+          </a:p>
+        </p:txBody>
+      </p:sp>
+      <p:sp>
+        <p:nvSpPr>
+          <p:cNvPr id="5" name="Text 3"/>
+          <p:cNvSpPr/>
+          <p:nvPr/>
+        </p:nvSpPr>
+        <p:spPr>
+          <a:xfrm>
+            <a:off x="457200" y="2560320"/>
+            <a:ext cx="8229600" cy="365760"/>
+          </a:xfrm>
+          <a:prstGeom prst="rect">
+            <a:avLst/>
+          </a:prstGeom>
+          <a:noFill/>
+          <a:ln/>
+        </p:spPr>
+        <p:txBody>
+          <a:bodyPr wrap="square" lIns="0" tIns="0" rIns="0" bIns="0" rtlCol="0" anchor="ctr"/>
+          <a:lstStyle/>
+          <a:p>
+            <a:pPr indent="0" marL="0">
+              <a:buNone/>
+            </a:pPr>
+            <a:r>
+              <a:rPr lang="en-US" sz="1800" dirty="0">
+                <a:solidFill>
+                  <a:srgbClr val="8B95A5"/>
+                </a:solidFill>
+                <a:latin typeface="Verdana" pitchFamily="34" charset="0"/>
+                <a:ea typeface="Verdana" pitchFamily="34" charset="-122"/>
+                <a:cs typeface="Verdana" pitchFamily="34" charset="-120"/>
+              </a:rPr>
+              <a:t>ISO 27001 · SOC 2 Type II · GDPR-native DPA · No model training</a:t>
+            </a:r>
+            <a:endParaRPr lang="en-US" sz="1800" dirty="0"/>
+          </a:p>
+        </p:txBody>
+      </p:sp>
+      <p:sp>
+        <p:nvSpPr>
+          <p:cNvPr id="6" name="Text 4"/>
+          <p:cNvSpPr/>
+          <p:nvPr/>
+        </p:nvSpPr>
+        <p:spPr>
+          <a:xfrm>
+            <a:off x="457200" y="3017520"/>
+            <a:ext cx="8229600" cy="457200"/>
+          </a:xfrm>
+          <a:prstGeom prst="rect">
+            <a:avLst/>
+          </a:prstGeom>
+          <a:noFill/>
+          <a:ln/>
+        </p:spPr>
+        <p:txBody>
+          <a:bodyPr wrap="square" lIns="0" tIns="0" rIns="0" bIns="0" rtlCol="0" anchor="ctr"/>
+          <a:lstStyle/>
+          <a:p>
+            <a:pPr indent="0" marL="0">
+              <a:buNone/>
+            </a:pPr>
+            <a:r>
+              <a:rPr lang="en-US" sz="1800" dirty="0">
+                <a:solidFill>
+                  <a:srgbClr val="1A1F36"/>
+                </a:solidFill>
+                <a:latin typeface="Verdana" pitchFamily="34" charset="0"/>
+                <a:ea typeface="Verdana" pitchFamily="34" charset="-122"/>
+                <a:cs typeface="Verdana" pitchFamily="34" charset="-120"/>
+              </a:rPr>
+              <a:t>30+ models: Claude Opus 4.6, GPT-5, Gemini 2.5 Pro, Mistral — many in EU regions</a:t>
+            </a:r>
+            <a:endParaRPr lang="en-US" sz="1800" dirty="0"/>
+          </a:p>
+        </p:txBody>
+      </p:sp>
+      <p:sp>
+        <p:nvSpPr>
+          <p:cNvPr id="7" name="Text 5"/>
+          <p:cNvSpPr/>
+          <p:nvPr/>
+        </p:nvSpPr>
+        <p:spPr>
+          <a:xfrm>
+            <a:off x="457200" y="3547872"/>
+            <a:ext cx="8229600" cy="365760"/>
+          </a:xfrm>
+          <a:prstGeom prst="rect">
+            <a:avLst/>
+          </a:prstGeom>
+          <a:noFill/>
+          <a:ln/>
+        </p:spPr>
+        <p:txBody>
+          <a:bodyPr wrap="square" lIns="0" tIns="0" rIns="0" bIns="0" rtlCol="0" anchor="ctr"/>
+          <a:lstStyle/>
+          <a:p>
+            <a:pPr indent="0" marL="0">
+              <a:buNone/>
+            </a:pPr>
+            <a:r>
+              <a:rPr lang="en-US" sz="1600" dirty="0">
+                <a:solidFill>
+                  <a:srgbClr val="8B95A5"/>
+                </a:solidFill>
+                <a:latin typeface="Verdana" pitchFamily="34" charset="0"/>
+                <a:ea typeface="Verdana" pitchFamily="34" charset="-122"/>
+                <a:cs typeface="Verdana" pitchFamily="34" charset="-120"/>
+              </a:rPr>
+              <a:t>~€23.20/user/month · Merck, Der Spiegel, Personio, Volksbank</a:t>
+            </a:r>
+            <a:endParaRPr lang="en-US" sz="1600" dirty="0"/>
+          </a:p>
+        </p:txBody>
+      </p:sp>
+      <p:sp>
+        <p:nvSpPr>
+          <p:cNvPr id="8" name="Text 6"/>
+          <p:cNvSpPr/>
+          <p:nvPr/>
+        </p:nvSpPr>
+        <p:spPr>
+          <a:xfrm>
+            <a:off x="457200" y="4572000"/>
+            <a:ext cx="8229600" cy="365760"/>
+          </a:xfrm>
+          <a:prstGeom prst="rect">
+            <a:avLst/>
+          </a:prstGeom>
+          <a:noFill/>
+          <a:ln/>
+        </p:spPr>
+        <p:txBody>
+          <a:bodyPr wrap="square" lIns="0" tIns="0" rIns="0" bIns="0" rtlCol="0" anchor="b"/>
+          <a:lstStyle/>
+          <a:p>
+            <a:pPr algn="r" indent="0" marL="0">
+              <a:buNone/>
+            </a:pPr>
+            <a:r>
+              <a:rPr lang="en-US" sz="1100" u="sng" dirty="0">
+                <a:solidFill>
+                  <a:srgbClr val="8B95A5"/>
+                </a:solidFill>
+                <a:latin typeface="Verdana" pitchFamily="34" charset="0"/>
+                <a:ea typeface="Verdana" pitchFamily="34" charset="-122"/>
+                <a:cs typeface="Verdana" pitchFamily="34" charset="-120"/>
+                <a:hlinkClick r:id="rId1" invalidUrl="" action="" tgtFrame="" tooltip="" history="1" highlightClick="0" endSnd="0">
+                  <a:extLst>
+                    <a:ext uri="{A12FA001-AC4F-418D-AE19-62706E023703}">
+                      <ahyp:hlinkClr xmlns:ahyp="http://schemas.microsoft.com/office/drawing/2018/hyperlinkcolor" val="tx"/>
+                    </a:ext>
+                  </a:extLst>
+                </a:hlinkClick>
+              </a:rPr>
+              <a:t>langdock.com/security</a:t>
+            </a:r>
+            <a:endParaRPr lang="en-US" sz="1100" dirty="0"/>
+          </a:p>
+        </p:txBody>
+      </p:sp>
+    </p:spTree>
+  </p:cSld>
+  <p:clrMapOvr>
+    <a:masterClrMapping/>
+  </p:clrMapOvr>
+</p:sld>
+</file>
+
+<file path=ppt/slides/slide17.xml><?xml version="1.0" encoding="utf-8"?>
+<p:sld xmlns:a="http://schemas.openxmlformats.org/drawingml/2006/main" xmlns:r="http://schemas.openxmlformats.org/officeDocument/2006/relationships" xmlns:p="http://schemas.openxmlformats.org/presentationml/2006/main">
+  <p:cSld name="Slide 17">
+    <p:bg>
+      <p:bgPr>
+        <a:solidFill>
+          <a:srgbClr val="FFFFFF"/>
+        </a:solidFill>
+      </p:bgPr>
+    </p:bg>
+    <p:spTree>
+      <p:nvGrpSpPr>
+        <p:cNvPr id="1" name=""/>
+        <p:cNvGrpSpPr/>
+        <p:nvPr/>
+      </p:nvGrpSpPr>
+      <p:grpSpPr>
+        <a:xfrm>
+          <a:off x="0" y="0"/>
+          <a:ext cx="0" cy="0"/>
+          <a:chOff x="0" y="0"/>
+          <a:chExt cx="0" cy="0"/>
+        </a:xfrm>
+      </p:grpSpPr>
+      <p:sp>
+        <p:nvSpPr>
+          <p:cNvPr id="2" name="Text 0"/>
+          <p:cNvSpPr/>
+          <p:nvPr/>
+        </p:nvSpPr>
+        <p:spPr>
+          <a:xfrm>
+            <a:off x="457200" y="182880"/>
             <a:ext cx="6400800" cy="731520"/>
           </a:xfrm>
           <a:prstGeom prst="rect">
@@ -5154,7 +5569,7 @@
       </p:sp>
       <p:graphicFrame>
         <p:nvGraphicFramePr>
-          <p:cNvPr id="17" name="Table 0"/>
+          <p:cNvPr id="18" name="Table 0"/>
           <p:cNvGraphicFramePr>
             <a:graphicFrameLocks noGrp="1"/>
           </p:cNvGraphicFramePr>
@@ -6589,9 +7004,9 @@
 </p:sld>
 </file>
 
-<file path=ppt/slides/slide17.xml><?xml version="1.0" encoding="utf-8"?>
+<file path=ppt/slides/slide18.xml><?xml version="1.0" encoding="utf-8"?>
 <p:sld xmlns:a="http://schemas.openxmlformats.org/drawingml/2006/main" xmlns:r="http://schemas.openxmlformats.org/officeDocument/2006/relationships" xmlns:p="http://schemas.openxmlformats.org/presentationml/2006/main">
-  <p:cSld name="Slide 17">
+  <p:cSld name="Slide 18">
     <p:bg>
       <p:bgPr>
         <a:solidFill>
@@ -6654,7 +7069,7 @@
       </p:sp>
       <p:graphicFrame>
         <p:nvGraphicFramePr>
-          <p:cNvPr id="18" name="Table 0"/>
+          <p:cNvPr id="19" name="Table 0"/>
           <p:cNvGraphicFramePr>
             <a:graphicFrameLocks noGrp="1"/>
           </p:cNvGraphicFramePr>
@@ -8236,155 +8651,6 @@
 </p:sld>
 </file>
 
-<file path=ppt/slides/slide18.xml><?xml version="1.0" encoding="utf-8"?>
-<p:sld xmlns:a="http://schemas.openxmlformats.org/drawingml/2006/main" xmlns:r="http://schemas.openxmlformats.org/officeDocument/2006/relationships" xmlns:p="http://schemas.openxmlformats.org/presentationml/2006/main">
-  <p:cSld name="Slide 18">
-    <p:bg>
-      <p:bgPr>
-        <a:solidFill>
-          <a:srgbClr val="0A2540"/>
-        </a:solidFill>
-      </p:bgPr>
-    </p:bg>
-    <p:spTree>
-      <p:nvGrpSpPr>
-        <p:cNvPr id="1" name=""/>
-        <p:cNvGrpSpPr/>
-        <p:nvPr/>
-      </p:nvGrpSpPr>
-      <p:grpSpPr>
-        <a:xfrm>
-          <a:off x="0" y="0"/>
-          <a:ext cx="0" cy="0"/>
-          <a:chOff x="0" y="0"/>
-          <a:chExt cx="0" cy="0"/>
-        </a:xfrm>
-      </p:grpSpPr>
-      <p:sp>
-        <p:nvSpPr>
-          <p:cNvPr id="2" name="Shape 0"/>
-          <p:cNvSpPr/>
-          <p:nvPr/>
-        </p:nvSpPr>
-        <p:spPr>
-          <a:xfrm>
-            <a:off x="4572000" y="2286000"/>
-            <a:ext cx="7315200" cy="5486400"/>
-          </a:xfrm>
-          <a:prstGeom prst="ellipse">
-            <a:avLst/>
-          </a:prstGeom>
-          <a:solidFill>
-            <a:srgbClr val="635BFF">
-              <a:alpha val="4000"/>
-            </a:srgbClr>
-          </a:solidFill>
-          <a:ln/>
-        </p:spPr>
-      </p:sp>
-      <p:sp>
-        <p:nvSpPr>
-          <p:cNvPr id="3" name="Text 1"/>
-          <p:cNvSpPr/>
-          <p:nvPr/>
-        </p:nvSpPr>
-        <p:spPr>
-          <a:xfrm>
-            <a:off x="914400" y="731520"/>
-            <a:ext cx="7315200" cy="2560320"/>
-          </a:xfrm>
-          <a:prstGeom prst="rect">
-            <a:avLst/>
-          </a:prstGeom>
-          <a:noFill/>
-          <a:ln/>
-        </p:spPr>
-        <p:txBody>
-          <a:bodyPr wrap="square" lIns="0" tIns="0" rIns="0" bIns="0" rtlCol="0" anchor="ctr"/>
-          <a:lstStyle/>
-          <a:p>
-            <a:pPr algn="ctr" indent="0" marL="0">
-              <a:buNone/>
-            </a:pPr>
-            <a:r>
-              <a:rPr lang="en-US" sz="5400" b="1" dirty="0">
-                <a:solidFill>
-                  <a:srgbClr val="FFFFFF"/>
-                </a:solidFill>
-                <a:latin typeface="Georgia" pitchFamily="34" charset="0"/>
-                <a:ea typeface="Georgia" pitchFamily="34" charset="-122"/>
-                <a:cs typeface="Georgia" pitchFamily="34" charset="-120"/>
-              </a:rPr>
-              <a:t>A DPA ≠ data residency.</a:t>
-            </a:r>
-            <a:endParaRPr lang="en-US" sz="5400" dirty="0"/>
-          </a:p>
-        </p:txBody>
-      </p:sp>
-      <p:sp>
-        <p:nvSpPr>
-          <p:cNvPr id="4" name="Text 2"/>
-          <p:cNvSpPr/>
-          <p:nvPr/>
-        </p:nvSpPr>
-        <p:spPr>
-          <a:xfrm>
-            <a:off x="1371600" y="3840480"/>
-            <a:ext cx="6400800" cy="731520"/>
-          </a:xfrm>
-          <a:prstGeom prst="rect">
-            <a:avLst/>
-          </a:prstGeom>
-          <a:noFill/>
-          <a:ln/>
-        </p:spPr>
-        <p:txBody>
-          <a:bodyPr wrap="square" lIns="0" tIns="0" rIns="0" bIns="0" rtlCol="0" anchor="t"/>
-          <a:lstStyle/>
-          <a:p>
-            <a:pPr algn="ctr" indent="0" marL="0">
-              <a:buNone/>
-            </a:pPr>
-            <a:r>
-              <a:rPr lang="en-US" sz="2400" dirty="0">
-                <a:solidFill>
-                  <a:srgbClr val="8B95A5"/>
-                </a:solidFill>
-                <a:latin typeface="Verdana" pitchFamily="34" charset="0"/>
-                <a:ea typeface="Verdana" pitchFamily="34" charset="-122"/>
-                <a:cs typeface="Verdana" pitchFamily="34" charset="-120"/>
-              </a:rPr>
-              <a:t>One governs the relationship.</a:t>
-            </a:r>
-            <a:endParaRPr lang="en-US" sz="2400" dirty="0"/>
-          </a:p>
-          <a:p>
-            <a:pPr algn="ctr" indent="0" marL="0">
-              <a:buNone/>
-            </a:pPr>
-            <a:r>
-              <a:rPr lang="en-US" sz="2400" dirty="0">
-                <a:solidFill>
-                  <a:srgbClr val="8B95A5"/>
-                </a:solidFill>
-                <a:latin typeface="Verdana" pitchFamily="34" charset="0"/>
-                <a:ea typeface="Verdana" pitchFamily="34" charset="-122"/>
-                <a:cs typeface="Verdana" pitchFamily="34" charset="-120"/>
-              </a:rPr>
-              <a:t>The other controls the geography.</a:t>
-            </a:r>
-            <a:endParaRPr lang="en-US" sz="2400" dirty="0"/>
-          </a:p>
-        </p:txBody>
-      </p:sp>
-    </p:spTree>
-  </p:cSld>
-  <p:clrMapOvr>
-    <a:masterClrMapping/>
-  </p:clrMapOvr>
-</p:sld>
-</file>
-
 <file path=ppt/slides/slide19.xml><?xml version="1.0" encoding="utf-8"?>
 <p:sld xmlns:a="http://schemas.openxmlformats.org/drawingml/2006/main" xmlns:r="http://schemas.openxmlformats.org/officeDocument/2006/relationships" xmlns:p="http://schemas.openxmlformats.org/presentationml/2006/main">
   <p:cSld name="Slide 19">
@@ -8439,8 +8705,8 @@
         </p:nvSpPr>
         <p:spPr>
           <a:xfrm>
-            <a:off x="457200" y="731520"/>
-            <a:ext cx="3840480" cy="640080"/>
+            <a:off x="914400" y="731520"/>
+            <a:ext cx="7315200" cy="2560320"/>
           </a:xfrm>
           <a:prstGeom prst="rect">
             <a:avLst/>
@@ -8456,17 +8722,17 @@
               <a:buNone/>
             </a:pPr>
             <a:r>
-              <a:rPr lang="en-US" sz="3600" b="1" dirty="0">
-                <a:solidFill>
-                  <a:srgbClr val="635BFF"/>
+              <a:rPr lang="en-US" sz="5400" b="1" dirty="0">
+                <a:solidFill>
+                  <a:srgbClr val="FFFFFF"/>
                 </a:solidFill>
                 <a:latin typeface="Georgia" pitchFamily="34" charset="0"/>
                 <a:ea typeface="Georgia" pitchFamily="34" charset="-122"/>
                 <a:cs typeface="Georgia" pitchFamily="34" charset="-120"/>
               </a:rPr>
-              <a:t>DPA + SCCs</a:t>
-            </a:r>
-            <a:endParaRPr lang="en-US" sz="3600" dirty="0"/>
+              <a:t>A DPA ≠ data residency.</a:t>
+            </a:r>
+            <a:endParaRPr lang="en-US" sz="5400" dirty="0"/>
           </a:p>
         </p:txBody>
       </p:sp>
@@ -8478,8 +8744,8 @@
         </p:nvSpPr>
         <p:spPr>
           <a:xfrm>
-            <a:off x="457200" y="1737360"/>
-            <a:ext cx="3840480" cy="2286000"/>
+            <a:off x="1371600" y="3840480"/>
+            <a:ext cx="6400800" cy="731520"/>
           </a:xfrm>
           <a:prstGeom prst="rect">
             <a:avLst/>
@@ -8495,7 +8761,7 @@
               <a:buNone/>
             </a:pPr>
             <a:r>
-              <a:rPr lang="en-US" sz="2200" dirty="0">
+              <a:rPr lang="en-US" sz="2400" dirty="0">
                 <a:solidFill>
                   <a:srgbClr val="8B95A5"/>
                 </a:solidFill>
@@ -8503,16 +8769,16 @@
                 <a:ea typeface="Verdana" pitchFamily="34" charset="-122"/>
                 <a:cs typeface="Verdana" pitchFamily="34" charset="-120"/>
               </a:rPr>
-              <a:t>Legally defensible</a:t>
-            </a:r>
-            <a:endParaRPr lang="en-US" sz="2200" dirty="0"/>
+              <a:t>One governs the relationship.</a:t>
+            </a:r>
+            <a:endParaRPr lang="en-US" sz="2400" dirty="0"/>
           </a:p>
           <a:p>
             <a:pPr algn="ctr" indent="0" marL="0">
               <a:buNone/>
             </a:pPr>
             <a:r>
-              <a:rPr lang="en-US" sz="2200" dirty="0">
+              <a:rPr lang="en-US" sz="2400" dirty="0">
                 <a:solidFill>
                   <a:srgbClr val="8B95A5"/>
                 </a:solidFill>
@@ -8520,195 +8786,9 @@
                 <a:ea typeface="Verdana" pitchFamily="34" charset="-122"/>
                 <a:cs typeface="Verdana" pitchFamily="34" charset="-120"/>
               </a:rPr>
-              <a:t>Same as Salesforce, M365</a:t>
-            </a:r>
-            <a:endParaRPr lang="en-US" sz="2200" dirty="0"/>
-          </a:p>
-          <a:p>
-            <a:pPr algn="ctr" indent="0" marL="0">
-              <a:buNone/>
-            </a:pPr>
-            <a:r>
-              <a:rPr lang="en-US" sz="2200" dirty="0">
-                <a:solidFill>
-                  <a:srgbClr val="8B95A5"/>
-                </a:solidFill>
-                <a:latin typeface="Verdana" pitchFamily="34" charset="0"/>
-                <a:ea typeface="Verdana" pitchFamily="34" charset="-122"/>
-                <a:cs typeface="Verdana" pitchFamily="34" charset="-120"/>
-              </a:rPr>
-              <a:t>Data goes to US servers</a:t>
-            </a:r>
-            <a:endParaRPr lang="en-US" sz="2200" dirty="0"/>
-          </a:p>
-          <a:p>
-            <a:pPr algn="ctr" indent="0" marL="0">
-              <a:buNone/>
-            </a:pPr>
-            <a:r>
-              <a:rPr lang="en-US" sz="2200" dirty="0">
-                <a:solidFill>
-                  <a:srgbClr val="8B95A5"/>
-                </a:solidFill>
-                <a:latin typeface="Verdana" pitchFamily="34" charset="0"/>
-                <a:ea typeface="Verdana" pitchFamily="34" charset="-122"/>
-                <a:cs typeface="Verdana" pitchFamily="34" charset="-120"/>
-              </a:rPr>
-              <a:t>SCCs invalidated twice before</a:t>
-            </a:r>
-            <a:endParaRPr lang="en-US" sz="2200" dirty="0"/>
-          </a:p>
-        </p:txBody>
-      </p:sp>
-      <p:sp>
-        <p:nvSpPr>
-          <p:cNvPr id="5" name="Shape 3"/>
-          <p:cNvSpPr/>
-          <p:nvPr/>
-        </p:nvSpPr>
-        <p:spPr>
-          <a:xfrm>
-            <a:off x="4572000" y="731520"/>
-            <a:ext cx="0" cy="3291840"/>
-          </a:xfrm>
-          <a:prstGeom prst="line">
-            <a:avLst/>
-          </a:prstGeom>
-          <a:noFill/>
-          <a:ln w="12700">
-            <a:solidFill>
-              <a:srgbClr val="635BFF"/>
-            </a:solidFill>
-            <a:prstDash val="solid"/>
-          </a:ln>
-        </p:spPr>
-      </p:sp>
-      <p:sp>
-        <p:nvSpPr>
-          <p:cNvPr id="6" name="Text 4"/>
-          <p:cNvSpPr/>
-          <p:nvPr/>
-        </p:nvSpPr>
-        <p:spPr>
-          <a:xfrm>
-            <a:off x="4846320" y="731520"/>
-            <a:ext cx="3840480" cy="640080"/>
-          </a:xfrm>
-          <a:prstGeom prst="rect">
-            <a:avLst/>
-          </a:prstGeom>
-          <a:noFill/>
-          <a:ln/>
-        </p:spPr>
-        <p:txBody>
-          <a:bodyPr wrap="square" lIns="0" tIns="0" rIns="0" bIns="0" rtlCol="0" anchor="ctr"/>
-          <a:lstStyle/>
-          <a:p>
-            <a:pPr algn="ctr" indent="0" marL="0">
-              <a:buNone/>
-            </a:pPr>
-            <a:r>
-              <a:rPr lang="en-US" sz="3600" b="1" dirty="0">
-                <a:solidFill>
-                  <a:srgbClr val="FFFFFF"/>
-                </a:solidFill>
-                <a:latin typeface="Georgia" pitchFamily="34" charset="0"/>
-                <a:ea typeface="Georgia" pitchFamily="34" charset="-122"/>
-                <a:cs typeface="Georgia" pitchFamily="34" charset="-120"/>
-              </a:rPr>
-              <a:t>EU Data Residency</a:t>
-            </a:r>
-            <a:endParaRPr lang="en-US" sz="3600" dirty="0"/>
-          </a:p>
-        </p:txBody>
-      </p:sp>
-      <p:sp>
-        <p:nvSpPr>
-          <p:cNvPr id="7" name="Text 5"/>
-          <p:cNvSpPr/>
-          <p:nvPr/>
-        </p:nvSpPr>
-        <p:spPr>
-          <a:xfrm>
-            <a:off x="4846320" y="1737360"/>
-            <a:ext cx="3840480" cy="2286000"/>
-          </a:xfrm>
-          <a:prstGeom prst="rect">
-            <a:avLst/>
-          </a:prstGeom>
-          <a:noFill/>
-          <a:ln/>
-        </p:spPr>
-        <p:txBody>
-          <a:bodyPr wrap="square" lIns="0" tIns="0" rIns="0" bIns="0" rtlCol="0" anchor="t"/>
-          <a:lstStyle/>
-          <a:p>
-            <a:pPr algn="ctr" indent="0" marL="0">
-              <a:buNone/>
-            </a:pPr>
-            <a:r>
-              <a:rPr lang="en-US" sz="2200" dirty="0">
-                <a:solidFill>
-                  <a:srgbClr val="8B95A5"/>
-                </a:solidFill>
-                <a:latin typeface="Verdana" pitchFamily="34" charset="0"/>
-                <a:ea typeface="Verdana" pitchFamily="34" charset="-122"/>
-                <a:cs typeface="Verdana" pitchFamily="34" charset="-120"/>
-              </a:rPr>
-              <a:t>Data never leaves the EU</a:t>
-            </a:r>
-            <a:endParaRPr lang="en-US" sz="2200" dirty="0"/>
-          </a:p>
-          <a:p>
-            <a:pPr algn="ctr" indent="0" marL="0">
-              <a:buNone/>
-            </a:pPr>
-            <a:r>
-              <a:rPr lang="en-US" sz="2200" dirty="0">
-                <a:solidFill>
-                  <a:srgbClr val="8B95A5"/>
-                </a:solidFill>
-                <a:latin typeface="Verdana" pitchFamily="34" charset="0"/>
-                <a:ea typeface="Verdana" pitchFamily="34" charset="-122"/>
-                <a:cs typeface="Verdana" pitchFamily="34" charset="-120"/>
-              </a:rPr>
-              <a:t>No cross-border transfer</a:t>
-            </a:r>
-            <a:endParaRPr lang="en-US" sz="2200" dirty="0"/>
-          </a:p>
-          <a:p>
-            <a:pPr algn="ctr" indent="0" marL="0">
-              <a:buNone/>
-            </a:pPr>
-            <a:r>
-              <a:rPr lang="en-US" sz="2200" dirty="0">
-                <a:solidFill>
-                  <a:srgbClr val="8B95A5"/>
-                </a:solidFill>
-                <a:latin typeface="Verdana" pitchFamily="34" charset="0"/>
-                <a:ea typeface="Verdana" pitchFamily="34" charset="-122"/>
-                <a:cs typeface="Verdana" pitchFamily="34" charset="-120"/>
-              </a:rPr>
-              <a:t>No Schrems-style risk</a:t>
-            </a:r>
-            <a:endParaRPr lang="en-US" sz="2200" dirty="0"/>
-          </a:p>
-          <a:p>
-            <a:pPr algn="ctr" indent="0" marL="0">
-              <a:buNone/>
-            </a:pPr>
-            <a:r>
-              <a:rPr lang="en-US" sz="2200" dirty="0">
-                <a:solidFill>
-                  <a:srgbClr val="8B95A5"/>
-                </a:solidFill>
-                <a:latin typeface="Verdana" pitchFamily="34" charset="0"/>
-                <a:ea typeface="Verdana" pitchFamily="34" charset="-122"/>
-                <a:cs typeface="Verdana" pitchFamily="34" charset="-120"/>
-              </a:rPr>
-              <a:t>Stronger regulatory posture</a:t>
-            </a:r>
-            <a:endParaRPr lang="en-US" sz="2200" dirty="0"/>
+              <a:t>The other controls the geography.</a:t>
+            </a:r>
+            <a:endParaRPr lang="en-US" sz="2400" dirty="0"/>
           </a:p>
         </p:txBody>
       </p:sp>
@@ -8906,8 +8986,8 @@
         </p:nvSpPr>
         <p:spPr>
           <a:xfrm>
-            <a:off x="457200" y="914400"/>
-            <a:ext cx="8229600" cy="2286000"/>
+            <a:off x="457200" y="731520"/>
+            <a:ext cx="3840480" cy="640080"/>
           </a:xfrm>
           <a:prstGeom prst="rect">
             <a:avLst/>
@@ -8916,24 +8996,24 @@
           <a:ln/>
         </p:spPr>
         <p:txBody>
-          <a:bodyPr wrap="square" lIns="0" tIns="0" rIns="0" bIns="0" rtlCol="0" anchor="b"/>
+          <a:bodyPr wrap="square" lIns="0" tIns="0" rIns="0" bIns="0" rtlCol="0" anchor="ctr"/>
           <a:lstStyle/>
           <a:p>
             <a:pPr algn="ctr" indent="0" marL="0">
               <a:buNone/>
             </a:pPr>
             <a:r>
-              <a:rPr lang="en-US" sz="12000" b="1" dirty="0">
-                <a:solidFill>
-                  <a:srgbClr val="FF6B8A"/>
+              <a:rPr lang="en-US" sz="3600" b="1" dirty="0">
+                <a:solidFill>
+                  <a:srgbClr val="635BFF"/>
                 </a:solidFill>
                 <a:latin typeface="Georgia" pitchFamily="34" charset="0"/>
                 <a:ea typeface="Georgia" pitchFamily="34" charset="-122"/>
                 <a:cs typeface="Georgia" pitchFamily="34" charset="-120"/>
               </a:rPr>
-              <a:t>11%</a:t>
-            </a:r>
-            <a:endParaRPr lang="en-US" sz="12000" dirty="0"/>
+              <a:t>DPA + SCCs</a:t>
+            </a:r>
+            <a:endParaRPr lang="en-US" sz="3600" dirty="0"/>
           </a:p>
         </p:txBody>
       </p:sp>
@@ -8945,8 +9025,8 @@
         </p:nvSpPr>
         <p:spPr>
           <a:xfrm>
-            <a:off x="1371600" y="3291840"/>
-            <a:ext cx="6400800" cy="731520"/>
+            <a:off x="457200" y="1737360"/>
+            <a:ext cx="3840480" cy="2286000"/>
           </a:xfrm>
           <a:prstGeom prst="rect">
             <a:avLst/>
@@ -8962,7 +9042,7 @@
               <a:buNone/>
             </a:pPr>
             <a:r>
-              <a:rPr lang="en-US" sz="2800" dirty="0">
+              <a:rPr lang="en-US" sz="2200" dirty="0">
                 <a:solidFill>
                   <a:srgbClr val="8B95A5"/>
                 </a:solidFill>
@@ -8970,16 +9050,16 @@
                 <a:ea typeface="Verdana" pitchFamily="34" charset="-122"/>
                 <a:cs typeface="Verdana" pitchFamily="34" charset="-120"/>
               </a:rPr>
-              <a:t>of data pasted into ChatGPT</a:t>
-            </a:r>
-            <a:endParaRPr lang="en-US" sz="2800" dirty="0"/>
+              <a:t>Legally defensible</a:t>
+            </a:r>
+            <a:endParaRPr lang="en-US" sz="2200" dirty="0"/>
           </a:p>
           <a:p>
             <a:pPr algn="ctr" indent="0" marL="0">
               <a:buNone/>
             </a:pPr>
             <a:r>
-              <a:rPr lang="en-US" sz="2800" dirty="0">
+              <a:rPr lang="en-US" sz="2200" dirty="0">
                 <a:solidFill>
                   <a:srgbClr val="8B95A5"/>
                 </a:solidFill>
@@ -8987,22 +9067,79 @@
                 <a:ea typeface="Verdana" pitchFamily="34" charset="-122"/>
                 <a:cs typeface="Verdana" pitchFamily="34" charset="-120"/>
               </a:rPr>
-              <a:t>is sensitive</a:t>
-            </a:r>
-            <a:endParaRPr lang="en-US" sz="2800" dirty="0"/>
-          </a:p>
-        </p:txBody>
-      </p:sp>
-      <p:sp>
-        <p:nvSpPr>
-          <p:cNvPr id="5" name="Text 3"/>
+              <a:t>Same as Salesforce, M365</a:t>
+            </a:r>
+            <a:endParaRPr lang="en-US" sz="2200" dirty="0"/>
+          </a:p>
+          <a:p>
+            <a:pPr algn="ctr" indent="0" marL="0">
+              <a:buNone/>
+            </a:pPr>
+            <a:r>
+              <a:rPr lang="en-US" sz="2200" dirty="0">
+                <a:solidFill>
+                  <a:srgbClr val="8B95A5"/>
+                </a:solidFill>
+                <a:latin typeface="Verdana" pitchFamily="34" charset="0"/>
+                <a:ea typeface="Verdana" pitchFamily="34" charset="-122"/>
+                <a:cs typeface="Verdana" pitchFamily="34" charset="-120"/>
+              </a:rPr>
+              <a:t>Data goes to US servers</a:t>
+            </a:r>
+            <a:endParaRPr lang="en-US" sz="2200" dirty="0"/>
+          </a:p>
+          <a:p>
+            <a:pPr algn="ctr" indent="0" marL="0">
+              <a:buNone/>
+            </a:pPr>
+            <a:r>
+              <a:rPr lang="en-US" sz="2200" dirty="0">
+                <a:solidFill>
+                  <a:srgbClr val="8B95A5"/>
+                </a:solidFill>
+                <a:latin typeface="Verdana" pitchFamily="34" charset="0"/>
+                <a:ea typeface="Verdana" pitchFamily="34" charset="-122"/>
+                <a:cs typeface="Verdana" pitchFamily="34" charset="-120"/>
+              </a:rPr>
+              <a:t>SCCs invalidated twice before</a:t>
+            </a:r>
+            <a:endParaRPr lang="en-US" sz="2200" dirty="0"/>
+          </a:p>
+        </p:txBody>
+      </p:sp>
+      <p:sp>
+        <p:nvSpPr>
+          <p:cNvPr id="5" name="Shape 3"/>
           <p:cNvSpPr/>
           <p:nvPr/>
         </p:nvSpPr>
         <p:spPr>
           <a:xfrm>
-            <a:off x="457200" y="4572000"/>
-            <a:ext cx="8229600" cy="365760"/>
+            <a:off x="4572000" y="731520"/>
+            <a:ext cx="0" cy="3291840"/>
+          </a:xfrm>
+          <a:prstGeom prst="line">
+            <a:avLst/>
+          </a:prstGeom>
+          <a:noFill/>
+          <a:ln w="12700">
+            <a:solidFill>
+              <a:srgbClr val="635BFF"/>
+            </a:solidFill>
+            <a:prstDash val="solid"/>
+          </a:ln>
+        </p:spPr>
+      </p:sp>
+      <p:sp>
+        <p:nvSpPr>
+          <p:cNvPr id="6" name="Text 4"/>
+          <p:cNvSpPr/>
+          <p:nvPr/>
+        </p:nvSpPr>
+        <p:spPr>
+          <a:xfrm>
+            <a:off x="4846320" y="731520"/>
+            <a:ext cx="3840480" cy="640080"/>
           </a:xfrm>
           <a:prstGeom prst="rect">
             <a:avLst/>
@@ -9011,31 +9148,114 @@
           <a:ln/>
         </p:spPr>
         <p:txBody>
-          <a:bodyPr wrap="square" lIns="0" tIns="0" rIns="0" bIns="0" rtlCol="0" anchor="b"/>
-          <a:lstStyle/>
-          <a:p>
-            <a:pPr algn="r" indent="0" marL="0">
-              <a:buNone/>
-            </a:pPr>
-            <a:r>
-              <a:rPr lang="en-US" sz="1100" u="sng" dirty="0">
+          <a:bodyPr wrap="square" lIns="0" tIns="0" rIns="0" bIns="0" rtlCol="0" anchor="ctr"/>
+          <a:lstStyle/>
+          <a:p>
+            <a:pPr algn="ctr" indent="0" marL="0">
+              <a:buNone/>
+            </a:pPr>
+            <a:r>
+              <a:rPr lang="en-US" sz="3600" b="1" dirty="0">
+                <a:solidFill>
+                  <a:srgbClr val="FFFFFF"/>
+                </a:solidFill>
+                <a:latin typeface="Georgia" pitchFamily="34" charset="0"/>
+                <a:ea typeface="Georgia" pitchFamily="34" charset="-122"/>
+                <a:cs typeface="Georgia" pitchFamily="34" charset="-120"/>
+              </a:rPr>
+              <a:t>EU Data Residency</a:t>
+            </a:r>
+            <a:endParaRPr lang="en-US" sz="3600" dirty="0"/>
+          </a:p>
+        </p:txBody>
+      </p:sp>
+      <p:sp>
+        <p:nvSpPr>
+          <p:cNvPr id="7" name="Text 5"/>
+          <p:cNvSpPr/>
+          <p:nvPr/>
+        </p:nvSpPr>
+        <p:spPr>
+          <a:xfrm>
+            <a:off x="4846320" y="1737360"/>
+            <a:ext cx="3840480" cy="2286000"/>
+          </a:xfrm>
+          <a:prstGeom prst="rect">
+            <a:avLst/>
+          </a:prstGeom>
+          <a:noFill/>
+          <a:ln/>
+        </p:spPr>
+        <p:txBody>
+          <a:bodyPr wrap="square" lIns="0" tIns="0" rIns="0" bIns="0" rtlCol="0" anchor="t"/>
+          <a:lstStyle/>
+          <a:p>
+            <a:pPr algn="ctr" indent="0" marL="0">
+              <a:buNone/>
+            </a:pPr>
+            <a:r>
+              <a:rPr lang="en-US" sz="2200" dirty="0">
                 <a:solidFill>
                   <a:srgbClr val="8B95A5"/>
                 </a:solidFill>
                 <a:latin typeface="Verdana" pitchFamily="34" charset="0"/>
                 <a:ea typeface="Verdana" pitchFamily="34" charset="-122"/>
                 <a:cs typeface="Verdana" pitchFamily="34" charset="-120"/>
-                <a:hlinkClick r:id="rId1" invalidUrl="" action="" tgtFrame="" tooltip="" history="1" highlightClick="0" endSnd="0">
-                  <a:extLst>
-                    <a:ext uri="{A12FA001-AC4F-418D-AE19-62706E023703}">
-                      <ahyp:hlinkClr xmlns:ahyp="http://schemas.microsoft.com/office/drawing/2018/hyperlinkcolor" val="tx"/>
-                    </a:ext>
-                  </a:extLst>
-                </a:hlinkClick>
-              </a:rPr>
-              <a:t>Cyberhaven</a:t>
-            </a:r>
-            <a:endParaRPr lang="en-US" sz="1100" dirty="0"/>
+              </a:rPr>
+              <a:t>Data never leaves the EU</a:t>
+            </a:r>
+            <a:endParaRPr lang="en-US" sz="2200" dirty="0"/>
+          </a:p>
+          <a:p>
+            <a:pPr algn="ctr" indent="0" marL="0">
+              <a:buNone/>
+            </a:pPr>
+            <a:r>
+              <a:rPr lang="en-US" sz="2200" dirty="0">
+                <a:solidFill>
+                  <a:srgbClr val="8B95A5"/>
+                </a:solidFill>
+                <a:latin typeface="Verdana" pitchFamily="34" charset="0"/>
+                <a:ea typeface="Verdana" pitchFamily="34" charset="-122"/>
+                <a:cs typeface="Verdana" pitchFamily="34" charset="-120"/>
+              </a:rPr>
+              <a:t>No cross-border transfer</a:t>
+            </a:r>
+            <a:endParaRPr lang="en-US" sz="2200" dirty="0"/>
+          </a:p>
+          <a:p>
+            <a:pPr algn="ctr" indent="0" marL="0">
+              <a:buNone/>
+            </a:pPr>
+            <a:r>
+              <a:rPr lang="en-US" sz="2200" dirty="0">
+                <a:solidFill>
+                  <a:srgbClr val="8B95A5"/>
+                </a:solidFill>
+                <a:latin typeface="Verdana" pitchFamily="34" charset="0"/>
+                <a:ea typeface="Verdana" pitchFamily="34" charset="-122"/>
+                <a:cs typeface="Verdana" pitchFamily="34" charset="-120"/>
+              </a:rPr>
+              <a:t>No Schrems-style risk</a:t>
+            </a:r>
+            <a:endParaRPr lang="en-US" sz="2200" dirty="0"/>
+          </a:p>
+          <a:p>
+            <a:pPr algn="ctr" indent="0" marL="0">
+              <a:buNone/>
+            </a:pPr>
+            <a:r>
+              <a:rPr lang="en-US" sz="2200" dirty="0">
+                <a:solidFill>
+                  <a:srgbClr val="8B95A5"/>
+                </a:solidFill>
+                <a:latin typeface="Verdana" pitchFamily="34" charset="0"/>
+                <a:ea typeface="Verdana" pitchFamily="34" charset="-122"/>
+                <a:cs typeface="Verdana" pitchFamily="34" charset="-120"/>
+              </a:rPr>
+              <a:t>Stronger regulatory posture</a:t>
+            </a:r>
+            <a:endParaRPr lang="en-US" sz="2200" dirty="0"/>
           </a:p>
         </p:txBody>
       </p:sp>
@@ -9101,8 +9321,8 @@
         </p:nvSpPr>
         <p:spPr>
           <a:xfrm>
-            <a:off x="914400" y="731520"/>
-            <a:ext cx="7315200" cy="2560320"/>
+            <a:off x="457200" y="914400"/>
+            <a:ext cx="8229600" cy="2286000"/>
           </a:xfrm>
           <a:prstGeom prst="rect">
             <a:avLst/>
@@ -9111,41 +9331,24 @@
           <a:ln/>
         </p:spPr>
         <p:txBody>
-          <a:bodyPr wrap="square" lIns="0" tIns="0" rIns="0" bIns="0" rtlCol="0" anchor="ctr"/>
+          <a:bodyPr wrap="square" lIns="0" tIns="0" rIns="0" bIns="0" rtlCol="0" anchor="b"/>
           <a:lstStyle/>
           <a:p>
             <a:pPr algn="ctr" indent="0" marL="0">
               <a:buNone/>
             </a:pPr>
             <a:r>
-              <a:rPr lang="en-US" sz="5400" b="1" dirty="0">
-                <a:solidFill>
-                  <a:srgbClr val="635BFF"/>
+              <a:rPr lang="en-US" sz="12000" b="1" dirty="0">
+                <a:solidFill>
+                  <a:srgbClr val="FF6B8A"/>
                 </a:solidFill>
                 <a:latin typeface="Georgia" pitchFamily="34" charset="0"/>
                 <a:ea typeface="Georgia" pitchFamily="34" charset="-122"/>
                 <a:cs typeface="Georgia" pitchFamily="34" charset="-120"/>
               </a:rPr>
-              <a:t>Assume PII will enter</a:t>
-            </a:r>
-            <a:endParaRPr lang="en-US" sz="5400" dirty="0"/>
-          </a:p>
-          <a:p>
-            <a:pPr algn="ctr" indent="0" marL="0">
-              <a:buNone/>
-            </a:pPr>
-            <a:r>
-              <a:rPr lang="en-US" sz="5400" b="1" dirty="0">
-                <a:solidFill>
-                  <a:srgbClr val="635BFF"/>
-                </a:solidFill>
-                <a:latin typeface="Georgia" pitchFamily="34" charset="0"/>
-                <a:ea typeface="Georgia" pitchFamily="34" charset="-122"/>
-                <a:cs typeface="Georgia" pitchFamily="34" charset="-120"/>
-              </a:rPr>
-              <a:t>your tools.</a:t>
-            </a:r>
-            <a:endParaRPr lang="en-US" sz="5400" dirty="0"/>
+              <a:t>11%</a:t>
+            </a:r>
+            <a:endParaRPr lang="en-US" sz="12000" dirty="0"/>
           </a:p>
         </p:txBody>
       </p:sp>
@@ -9157,7 +9360,7 @@
         </p:nvSpPr>
         <p:spPr>
           <a:xfrm>
-            <a:off x="1371600" y="3840480"/>
+            <a:off x="1371600" y="3291840"/>
             <a:ext cx="6400800" cy="731520"/>
           </a:xfrm>
           <a:prstGeom prst="rect">
@@ -9174,7 +9377,7 @@
               <a:buNone/>
             </a:pPr>
             <a:r>
-              <a:rPr lang="en-US" sz="2400" dirty="0">
+              <a:rPr lang="en-US" sz="2800" dirty="0">
                 <a:solidFill>
                   <a:srgbClr val="8B95A5"/>
                 </a:solidFill>
@@ -9182,16 +9385,16 @@
                 <a:ea typeface="Verdana" pitchFamily="34" charset="-122"/>
                 <a:cs typeface="Verdana" pitchFamily="34" charset="-120"/>
               </a:rPr>
-              <a:t>Make the default path safe enough</a:t>
-            </a:r>
-            <a:endParaRPr lang="en-US" sz="2400" dirty="0"/>
+              <a:t>of data pasted into ChatGPT</a:t>
+            </a:r>
+            <a:endParaRPr lang="en-US" sz="2800" dirty="0"/>
           </a:p>
           <a:p>
             <a:pPr algn="ctr" indent="0" marL="0">
               <a:buNone/>
             </a:pPr>
             <a:r>
-              <a:rPr lang="en-US" sz="2400" dirty="0">
+              <a:rPr lang="en-US" sz="2800" dirty="0">
                 <a:solidFill>
                   <a:srgbClr val="8B95A5"/>
                 </a:solidFill>
@@ -9199,9 +9402,55 @@
                 <a:ea typeface="Verdana" pitchFamily="34" charset="-122"/>
                 <a:cs typeface="Verdana" pitchFamily="34" charset="-120"/>
               </a:rPr>
-              <a:t>that it doesn’t matter.</a:t>
-            </a:r>
-            <a:endParaRPr lang="en-US" sz="2400" dirty="0"/>
+              <a:t>is sensitive</a:t>
+            </a:r>
+            <a:endParaRPr lang="en-US" sz="2800" dirty="0"/>
+          </a:p>
+        </p:txBody>
+      </p:sp>
+      <p:sp>
+        <p:nvSpPr>
+          <p:cNvPr id="5" name="Text 3"/>
+          <p:cNvSpPr/>
+          <p:nvPr/>
+        </p:nvSpPr>
+        <p:spPr>
+          <a:xfrm>
+            <a:off x="457200" y="4572000"/>
+            <a:ext cx="8229600" cy="365760"/>
+          </a:xfrm>
+          <a:prstGeom prst="rect">
+            <a:avLst/>
+          </a:prstGeom>
+          <a:noFill/>
+          <a:ln/>
+        </p:spPr>
+        <p:txBody>
+          <a:bodyPr wrap="square" lIns="0" tIns="0" rIns="0" bIns="0" rtlCol="0" anchor="b"/>
+          <a:lstStyle/>
+          <a:p>
+            <a:pPr algn="r" indent="0" marL="0">
+              <a:buNone/>
+            </a:pPr>
+            <a:r>
+              <a:rPr lang="en-US" sz="1100" u="sng" dirty="0">
+                <a:solidFill>
+                  <a:srgbClr val="8B95A5"/>
+                </a:solidFill>
+                <a:latin typeface="Verdana" pitchFamily="34" charset="0"/>
+                <a:ea typeface="Verdana" pitchFamily="34" charset="-122"/>
+                <a:cs typeface="Verdana" pitchFamily="34" charset="-120"/>
+                <a:hlinkClick r:id="rId1" invalidUrl="" action="" tgtFrame="" tooltip="" history="1" highlightClick="0" endSnd="0">
+                  <a:extLst>
+                    <a:ext uri="{A12FA001-AC4F-418D-AE19-62706E023703}">
+                      <ahyp:hlinkClr xmlns:ahyp="http://schemas.microsoft.com/office/drawing/2018/hyperlinkcolor" val="tx"/>
+                    </a:ext>
+                  </a:extLst>
+                </a:hlinkClick>
+              </a:rPr>
+              <a:t>Cyberhaven</a:t>
+            </a:r>
+            <a:endParaRPr lang="en-US" sz="1100" dirty="0"/>
           </a:p>
         </p:txBody>
       </p:sp>
@@ -9286,13 +9535,13 @@
             <a:r>
               <a:rPr lang="en-US" sz="5400" b="1" dirty="0">
                 <a:solidFill>
-                  <a:srgbClr val="FFFFFF"/>
+                  <a:srgbClr val="635BFF"/>
                 </a:solidFill>
                 <a:latin typeface="Georgia" pitchFamily="34" charset="0"/>
                 <a:ea typeface="Georgia" pitchFamily="34" charset="-122"/>
                 <a:cs typeface="Georgia" pitchFamily="34" charset="-120"/>
               </a:rPr>
-              <a:t>Any model, any cloud,</a:t>
+              <a:t>Assume PII will enter</a:t>
             </a:r>
             <a:endParaRPr lang="en-US" sz="5400" dirty="0"/>
           </a:p>
@@ -9303,13 +9552,13 @@
             <a:r>
               <a:rPr lang="en-US" sz="5400" b="1" dirty="0">
                 <a:solidFill>
-                  <a:srgbClr val="FFFFFF"/>
+                  <a:srgbClr val="635BFF"/>
                 </a:solidFill>
                 <a:latin typeface="Georgia" pitchFamily="34" charset="0"/>
                 <a:ea typeface="Georgia" pitchFamily="34" charset="-122"/>
                 <a:cs typeface="Georgia" pitchFamily="34" charset="-120"/>
               </a:rPr>
-              <a:t>EU-resident.</a:t>
+              <a:t>your tools.</a:t>
             </a:r>
             <a:endParaRPr lang="en-US" sz="5400" dirty="0"/>
           </a:p>
@@ -9348,7 +9597,24 @@
                 <a:ea typeface="Verdana" pitchFamily="34" charset="-122"/>
                 <a:cs typeface="Verdana" pitchFamily="34" charset="-120"/>
               </a:rPr>
-              <a:t>Claude on GCP · Claude on AWS · Azure OpenAI · M365 Copilot</a:t>
+              <a:t>Make the default path safe enough</a:t>
+            </a:r>
+            <a:endParaRPr lang="en-US" sz="2400" dirty="0"/>
+          </a:p>
+          <a:p>
+            <a:pPr algn="ctr" indent="0" marL="0">
+              <a:buNone/>
+            </a:pPr>
+            <a:r>
+              <a:rPr lang="en-US" sz="2400" dirty="0">
+                <a:solidFill>
+                  <a:srgbClr val="8B95A5"/>
+                </a:solidFill>
+                <a:latin typeface="Verdana" pitchFamily="34" charset="0"/>
+                <a:ea typeface="Verdana" pitchFamily="34" charset="-122"/>
+                <a:cs typeface="Verdana" pitchFamily="34" charset="-120"/>
+              </a:rPr>
+              <a:t>that it doesn’t matter.</a:t>
             </a:r>
             <a:endParaRPr lang="en-US" sz="2400" dirty="0"/>
           </a:p>
@@ -9416,8 +9682,8 @@
         </p:nvSpPr>
         <p:spPr>
           <a:xfrm>
-            <a:off x="457200" y="731520"/>
-            <a:ext cx="3840480" cy="640080"/>
+            <a:off x="914400" y="731520"/>
+            <a:ext cx="7315200" cy="2560320"/>
           </a:xfrm>
           <a:prstGeom prst="rect">
             <a:avLst/>
@@ -9433,17 +9699,34 @@
               <a:buNone/>
             </a:pPr>
             <a:r>
-              <a:rPr lang="en-US" sz="3600" b="1" dirty="0">
-                <a:solidFill>
-                  <a:srgbClr val="635BFF"/>
+              <a:rPr lang="en-US" sz="5400" b="1" dirty="0">
+                <a:solidFill>
+                  <a:srgbClr val="FFFFFF"/>
                 </a:solidFill>
                 <a:latin typeface="Georgia" pitchFamily="34" charset="0"/>
                 <a:ea typeface="Georgia" pitchFamily="34" charset="-122"/>
                 <a:cs typeface="Georgia" pitchFamily="34" charset="-120"/>
               </a:rPr>
-              <a:t>Everyday Use</a:t>
-            </a:r>
-            <a:endParaRPr lang="en-US" sz="3600" dirty="0"/>
+              <a:t>Any model, any cloud,</a:t>
+            </a:r>
+            <a:endParaRPr lang="en-US" sz="5400" dirty="0"/>
+          </a:p>
+          <a:p>
+            <a:pPr algn="ctr" indent="0" marL="0">
+              <a:buNone/>
+            </a:pPr>
+            <a:r>
+              <a:rPr lang="en-US" sz="5400" b="1" dirty="0">
+                <a:solidFill>
+                  <a:srgbClr val="FFFFFF"/>
+                </a:solidFill>
+                <a:latin typeface="Georgia" pitchFamily="34" charset="0"/>
+                <a:ea typeface="Georgia" pitchFamily="34" charset="-122"/>
+                <a:cs typeface="Georgia" pitchFamily="34" charset="-120"/>
+              </a:rPr>
+              <a:t>EU-resident.</a:t>
+            </a:r>
+            <a:endParaRPr lang="en-US" sz="5400" dirty="0"/>
           </a:p>
         </p:txBody>
       </p:sp>
@@ -9455,8 +9738,8 @@
         </p:nvSpPr>
         <p:spPr>
           <a:xfrm>
-            <a:off x="457200" y="1737360"/>
-            <a:ext cx="3840480" cy="2286000"/>
+            <a:off x="1371600" y="3840480"/>
+            <a:ext cx="6400800" cy="731520"/>
           </a:xfrm>
           <a:prstGeom prst="rect">
             <a:avLst/>
@@ -9472,7 +9755,7 @@
               <a:buNone/>
             </a:pPr>
             <a:r>
-              <a:rPr lang="en-US" sz="2200" dirty="0">
+              <a:rPr lang="en-US" sz="2400" dirty="0">
                 <a:solidFill>
                   <a:srgbClr val="8B95A5"/>
                 </a:solidFill>
@@ -9480,224 +9763,9 @@
                 <a:ea typeface="Verdana" pitchFamily="34" charset="-122"/>
                 <a:cs typeface="Verdana" pitchFamily="34" charset="-120"/>
               </a:rPr>
-              <a:t>Email, research, analysis</a:t>
-            </a:r>
-            <a:endParaRPr lang="en-US" sz="2200" dirty="0"/>
-          </a:p>
-          <a:p>
-            <a:pPr algn="ctr" indent="0" marL="0">
-              <a:buNone/>
-            </a:pPr>
-            <a:r>
-              <a:rPr lang="en-US" sz="2200" dirty="0">
-                <a:solidFill>
-                  <a:srgbClr val="8B95A5"/>
-                </a:solidFill>
-                <a:latin typeface="Verdana" pitchFamily="34" charset="0"/>
-                <a:ea typeface="Verdana" pitchFamily="34" charset="-122"/>
-                <a:cs typeface="Verdana" pitchFamily="34" charset="-120"/>
-              </a:rPr>
-              <a:t>Customer names will enter</a:t>
-            </a:r>
-            <a:endParaRPr lang="en-US" sz="2200" dirty="0"/>
-          </a:p>
-          <a:p>
-            <a:pPr algn="ctr" indent="0" marL="0">
-              <a:buNone/>
-            </a:pPr>
-            <a:r>
-              <a:rPr lang="en-US" sz="2200" dirty="0">
-                <a:solidFill>
-                  <a:srgbClr val="8B95A5"/>
-                </a:solidFill>
-                <a:latin typeface="Verdana" pitchFamily="34" charset="0"/>
-                <a:ea typeface="Verdana" pitchFamily="34" charset="-122"/>
-                <a:cs typeface="Verdana" pitchFamily="34" charset="-120"/>
-              </a:rPr>
-              <a:t>No enforceable boundary</a:t>
-            </a:r>
-            <a:endParaRPr lang="en-US" sz="2200" dirty="0"/>
-          </a:p>
-          <a:p>
-            <a:pPr algn="ctr" indent="0" marL="0">
-              <a:buNone/>
-            </a:pPr>
-            <a:endParaRPr lang="en-US" sz="2200" dirty="0"/>
-          </a:p>
-          <a:p>
-            <a:pPr algn="ctr" indent="0" marL="0">
-              <a:buNone/>
-            </a:pPr>
-            <a:r>
-              <a:rPr lang="en-US" sz="2200" dirty="0">
-                <a:solidFill>
-                  <a:srgbClr val="8B95A5"/>
-                </a:solidFill>
-                <a:latin typeface="Verdana" pitchFamily="34" charset="0"/>
-                <a:ea typeface="Verdana" pitchFamily="34" charset="-122"/>
-                <a:cs typeface="Verdana" pitchFamily="34" charset="-120"/>
-              </a:rPr>
-              <a:t>→ Default to EU-resident</a:t>
-            </a:r>
-            <a:endParaRPr lang="en-US" sz="2200" dirty="0"/>
-          </a:p>
-        </p:txBody>
-      </p:sp>
-      <p:sp>
-        <p:nvSpPr>
-          <p:cNvPr id="5" name="Shape 3"/>
-          <p:cNvSpPr/>
-          <p:nvPr/>
-        </p:nvSpPr>
-        <p:spPr>
-          <a:xfrm>
-            <a:off x="4572000" y="731520"/>
-            <a:ext cx="0" cy="3291840"/>
-          </a:xfrm>
-          <a:prstGeom prst="line">
-            <a:avLst/>
-          </a:prstGeom>
-          <a:noFill/>
-          <a:ln w="12700">
-            <a:solidFill>
-              <a:srgbClr val="635BFF"/>
-            </a:solidFill>
-            <a:prstDash val="solid"/>
-          </a:ln>
-        </p:spPr>
-      </p:sp>
-      <p:sp>
-        <p:nvSpPr>
-          <p:cNvPr id="6" name="Text 4"/>
-          <p:cNvSpPr/>
-          <p:nvPr/>
-        </p:nvSpPr>
-        <p:spPr>
-          <a:xfrm>
-            <a:off x="4846320" y="731520"/>
-            <a:ext cx="3840480" cy="640080"/>
-          </a:xfrm>
-          <a:prstGeom prst="rect">
-            <a:avLst/>
-          </a:prstGeom>
-          <a:noFill/>
-          <a:ln/>
-        </p:spPr>
-        <p:txBody>
-          <a:bodyPr wrap="square" lIns="0" tIns="0" rIns="0" bIns="0" rtlCol="0" anchor="ctr"/>
-          <a:lstStyle/>
-          <a:p>
-            <a:pPr algn="ctr" indent="0" marL="0">
-              <a:buNone/>
-            </a:pPr>
-            <a:r>
-              <a:rPr lang="en-US" sz="3600" b="1" dirty="0">
-                <a:solidFill>
-                  <a:srgbClr val="635BFF"/>
-                </a:solidFill>
-                <a:latin typeface="Georgia" pitchFamily="34" charset="0"/>
-                <a:ea typeface="Georgia" pitchFamily="34" charset="-122"/>
-                <a:cs typeface="Georgia" pitchFamily="34" charset="-120"/>
-              </a:rPr>
-              <a:t>Coding</a:t>
-            </a:r>
-            <a:endParaRPr lang="en-US" sz="3600" dirty="0"/>
-          </a:p>
-        </p:txBody>
-      </p:sp>
-      <p:sp>
-        <p:nvSpPr>
-          <p:cNvPr id="7" name="Text 5"/>
-          <p:cNvSpPr/>
-          <p:nvPr/>
-        </p:nvSpPr>
-        <p:spPr>
-          <a:xfrm>
-            <a:off x="4846320" y="1737360"/>
-            <a:ext cx="3840480" cy="2286000"/>
-          </a:xfrm>
-          <a:prstGeom prst="rect">
-            <a:avLst/>
-          </a:prstGeom>
-          <a:noFill/>
-          <a:ln/>
-        </p:spPr>
-        <p:txBody>
-          <a:bodyPr wrap="square" lIns="0" tIns="0" rIns="0" bIns="0" rtlCol="0" anchor="t"/>
-          <a:lstStyle/>
-          <a:p>
-            <a:pPr algn="ctr" indent="0" marL="0">
-              <a:buNone/>
-            </a:pPr>
-            <a:r>
-              <a:rPr lang="en-US" sz="2200" dirty="0">
-                <a:solidFill>
-                  <a:srgbClr val="8B95A5"/>
-                </a:solidFill>
-                <a:latin typeface="Verdana" pitchFamily="34" charset="0"/>
-                <a:ea typeface="Verdana" pitchFamily="34" charset="-122"/>
-                <a:cs typeface="Verdana" pitchFamily="34" charset="-120"/>
-              </a:rPr>
-              <a:t>You control the data</a:t>
-            </a:r>
-            <a:endParaRPr lang="en-US" sz="2200" dirty="0"/>
-          </a:p>
-          <a:p>
-            <a:pPr algn="ctr" indent="0" marL="0">
-              <a:buNone/>
-            </a:pPr>
-            <a:r>
-              <a:rPr lang="en-US" sz="2200" dirty="0">
-                <a:solidFill>
-                  <a:srgbClr val="8B95A5"/>
-                </a:solidFill>
-                <a:latin typeface="Verdana" pitchFamily="34" charset="0"/>
-                <a:ea typeface="Verdana" pitchFamily="34" charset="-122"/>
-                <a:cs typeface="Verdana" pitchFamily="34" charset="-120"/>
-              </a:rPr>
-              <a:t>Test data → enterprise tier</a:t>
-            </a:r>
-            <a:endParaRPr lang="en-US" sz="2200" dirty="0"/>
-          </a:p>
-          <a:p>
-            <a:pPr algn="ctr" indent="0" marL="0">
-              <a:buNone/>
-            </a:pPr>
-            <a:r>
-              <a:rPr lang="en-US" sz="2200" dirty="0">
-                <a:solidFill>
-                  <a:srgbClr val="8B95A5"/>
-                </a:solidFill>
-                <a:latin typeface="Verdana" pitchFamily="34" charset="0"/>
-                <a:ea typeface="Verdana" pitchFamily="34" charset="-122"/>
-                <a:cs typeface="Verdana" pitchFamily="34" charset="-120"/>
-              </a:rPr>
-              <a:t>Production data → EU-resident</a:t>
-            </a:r>
-            <a:endParaRPr lang="en-US" sz="2200" dirty="0"/>
-          </a:p>
-          <a:p>
-            <a:pPr algn="ctr" indent="0" marL="0">
-              <a:buNone/>
-            </a:pPr>
-            <a:endParaRPr lang="en-US" sz="2200" dirty="0"/>
-          </a:p>
-          <a:p>
-            <a:pPr algn="ctr" indent="0" marL="0">
-              <a:buNone/>
-            </a:pPr>
-            <a:r>
-              <a:rPr lang="en-US" sz="2200" dirty="0">
-                <a:solidFill>
-                  <a:srgbClr val="8B95A5"/>
-                </a:solidFill>
-                <a:latin typeface="Verdana" pitchFamily="34" charset="0"/>
-                <a:ea typeface="Verdana" pitchFamily="34" charset="-122"/>
-                <a:cs typeface="Verdana" pitchFamily="34" charset="-120"/>
-              </a:rPr>
-              <a:t>→ Two paths possible</a:t>
-            </a:r>
-            <a:endParaRPr lang="en-US" sz="2200" dirty="0"/>
+              <a:t>Claude on GCP · Claude on AWS · Azure OpenAI · M365 Copilot</a:t>
+            </a:r>
+            <a:endParaRPr lang="en-US" sz="2400" dirty="0"/>
           </a:p>
         </p:txBody>
       </p:sp>
@@ -9763,8 +9831,8 @@
         </p:nvSpPr>
         <p:spPr>
           <a:xfrm>
-            <a:off x="457200" y="274320"/>
-            <a:ext cx="8229600" cy="822960"/>
+            <a:off x="457200" y="731520"/>
+            <a:ext cx="3840480" cy="640080"/>
           </a:xfrm>
           <a:prstGeom prst="rect">
             <a:avLst/>
@@ -9776,19 +9844,19 @@
           <a:bodyPr wrap="square" lIns="0" tIns="0" rIns="0" bIns="0" rtlCol="0" anchor="ctr"/>
           <a:lstStyle/>
           <a:p>
-            <a:pPr indent="0" marL="0">
+            <a:pPr algn="ctr" indent="0" marL="0">
               <a:buNone/>
             </a:pPr>
             <a:r>
               <a:rPr lang="en-US" sz="3600" b="1" dirty="0">
                 <a:solidFill>
-                  <a:srgbClr val="FFFFFF"/>
+                  <a:srgbClr val="635BFF"/>
                 </a:solidFill>
                 <a:latin typeface="Georgia" pitchFamily="34" charset="0"/>
                 <a:ea typeface="Georgia" pitchFamily="34" charset="-122"/>
                 <a:cs typeface="Georgia" pitchFamily="34" charset="-120"/>
               </a:rPr>
-              <a:t>The boundary only works for code.</a:t>
+              <a:t>Everyday Use</a:t>
             </a:r>
             <a:endParaRPr lang="en-US" sz="3600" dirty="0"/>
           </a:p>
@@ -9802,8 +9870,8 @@
         </p:nvSpPr>
         <p:spPr>
           <a:xfrm>
-            <a:off x="640080" y="1371600"/>
-            <a:ext cx="7863840" cy="3200400"/>
+            <a:off x="457200" y="1737360"/>
+            <a:ext cx="3840480" cy="2286000"/>
           </a:xfrm>
           <a:prstGeom prst="rect">
             <a:avLst/>
@@ -9815,21 +9883,24 @@
           <a:bodyPr wrap="square" lIns="0" tIns="0" rIns="0" bIns="0" rtlCol="0" anchor="t"/>
           <a:lstStyle/>
           <a:p>
-            <a:pPr indent="0" marL="0">
+            <a:pPr algn="ctr" indent="0" marL="0">
               <a:buNone/>
             </a:pPr>
             <a:r>
               <a:rPr lang="en-US" sz="2200" dirty="0">
                 <a:solidFill>
-                  <a:srgbClr val="EDEDED"/>
+                  <a:srgbClr val="8B95A5"/>
                 </a:solidFill>
                 <a:latin typeface="Verdana" pitchFamily="34" charset="0"/>
                 <a:ea typeface="Verdana" pitchFamily="34" charset="-122"/>
                 <a:cs typeface="Verdana" pitchFamily="34" charset="-120"/>
               </a:rPr>
-              <a:t>Marketing drafting a client email</a:t>
-            </a:r>
-            <a:pPr indent="0" marL="0">
+              <a:t>Email, research, analysis</a:t>
+            </a:r>
+            <a:endParaRPr lang="en-US" sz="2200" dirty="0"/>
+          </a:p>
+          <a:p>
+            <a:pPr algn="ctr" indent="0" marL="0">
               <a:buNone/>
             </a:pPr>
             <a:r>
@@ -9841,46 +9912,136 @@
                 <a:ea typeface="Verdana" pitchFamily="34" charset="-122"/>
                 <a:cs typeface="Verdana" pitchFamily="34" charset="-120"/>
               </a:rPr>
-              <a:t>  →  </a:t>
-            </a:r>
-            <a:pPr indent="0" marL="0">
-              <a:buNone/>
-            </a:pPr>
-            <a:r>
-              <a:rPr lang="en-US" sz="2200" b="1" dirty="0">
-                <a:solidFill>
-                  <a:srgbClr val="FF6B8A"/>
+              <a:t>Customer names will enter</a:t>
+            </a:r>
+            <a:endParaRPr lang="en-US" sz="2200" dirty="0"/>
+          </a:p>
+          <a:p>
+            <a:pPr algn="ctr" indent="0" marL="0">
+              <a:buNone/>
+            </a:pPr>
+            <a:r>
+              <a:rPr lang="en-US" sz="2200" dirty="0">
+                <a:solidFill>
+                  <a:srgbClr val="8B95A5"/>
                 </a:solidFill>
                 <a:latin typeface="Verdana" pitchFamily="34" charset="0"/>
                 <a:ea typeface="Verdana" pitchFamily="34" charset="-122"/>
                 <a:cs typeface="Verdana" pitchFamily="34" charset="-120"/>
               </a:rPr>
-              <a:t>PII enters</a:t>
+              <a:t>No enforceable boundary</a:t>
             </a:r>
             <a:endParaRPr lang="en-US" sz="2200" dirty="0"/>
           </a:p>
           <a:p>
-            <a:pPr indent="0" marL="0">
+            <a:pPr algn="ctr" indent="0" marL="0">
               <a:buNone/>
             </a:pPr>
             <a:endParaRPr lang="en-US" sz="2200" dirty="0"/>
           </a:p>
           <a:p>
-            <a:pPr indent="0" marL="0">
+            <a:pPr algn="ctr" indent="0" marL="0">
               <a:buNone/>
             </a:pPr>
             <a:r>
               <a:rPr lang="en-US" sz="2200" dirty="0">
                 <a:solidFill>
-                  <a:srgbClr val="EDEDED"/>
+                  <a:srgbClr val="8B95A5"/>
                 </a:solidFill>
                 <a:latin typeface="Verdana" pitchFamily="34" charset="0"/>
                 <a:ea typeface="Verdana" pitchFamily="34" charset="-122"/>
                 <a:cs typeface="Verdana" pitchFamily="34" charset="-120"/>
               </a:rPr>
-              <a:t>Ops evaluating a customer claim</a:t>
-            </a:r>
-            <a:pPr indent="0" marL="0">
+              <a:t>→ Default to EU-resident</a:t>
+            </a:r>
+            <a:endParaRPr lang="en-US" sz="2200" dirty="0"/>
+          </a:p>
+        </p:txBody>
+      </p:sp>
+      <p:sp>
+        <p:nvSpPr>
+          <p:cNvPr id="5" name="Shape 3"/>
+          <p:cNvSpPr/>
+          <p:nvPr/>
+        </p:nvSpPr>
+        <p:spPr>
+          <a:xfrm>
+            <a:off x="4572000" y="731520"/>
+            <a:ext cx="0" cy="3291840"/>
+          </a:xfrm>
+          <a:prstGeom prst="line">
+            <a:avLst/>
+          </a:prstGeom>
+          <a:noFill/>
+          <a:ln w="12700">
+            <a:solidFill>
+              <a:srgbClr val="635BFF"/>
+            </a:solidFill>
+            <a:prstDash val="solid"/>
+          </a:ln>
+        </p:spPr>
+      </p:sp>
+      <p:sp>
+        <p:nvSpPr>
+          <p:cNvPr id="6" name="Text 4"/>
+          <p:cNvSpPr/>
+          <p:nvPr/>
+        </p:nvSpPr>
+        <p:spPr>
+          <a:xfrm>
+            <a:off x="4846320" y="731520"/>
+            <a:ext cx="3840480" cy="640080"/>
+          </a:xfrm>
+          <a:prstGeom prst="rect">
+            <a:avLst/>
+          </a:prstGeom>
+          <a:noFill/>
+          <a:ln/>
+        </p:spPr>
+        <p:txBody>
+          <a:bodyPr wrap="square" lIns="0" tIns="0" rIns="0" bIns="0" rtlCol="0" anchor="ctr"/>
+          <a:lstStyle/>
+          <a:p>
+            <a:pPr algn="ctr" indent="0" marL="0">
+              <a:buNone/>
+            </a:pPr>
+            <a:r>
+              <a:rPr lang="en-US" sz="3600" b="1" dirty="0">
+                <a:solidFill>
+                  <a:srgbClr val="635BFF"/>
+                </a:solidFill>
+                <a:latin typeface="Georgia" pitchFamily="34" charset="0"/>
+                <a:ea typeface="Georgia" pitchFamily="34" charset="-122"/>
+                <a:cs typeface="Georgia" pitchFamily="34" charset="-120"/>
+              </a:rPr>
+              <a:t>Coding</a:t>
+            </a:r>
+            <a:endParaRPr lang="en-US" sz="3600" dirty="0"/>
+          </a:p>
+        </p:txBody>
+      </p:sp>
+      <p:sp>
+        <p:nvSpPr>
+          <p:cNvPr id="7" name="Text 5"/>
+          <p:cNvSpPr/>
+          <p:nvPr/>
+        </p:nvSpPr>
+        <p:spPr>
+          <a:xfrm>
+            <a:off x="4846320" y="1737360"/>
+            <a:ext cx="3840480" cy="2286000"/>
+          </a:xfrm>
+          <a:prstGeom prst="rect">
+            <a:avLst/>
+          </a:prstGeom>
+          <a:noFill/>
+          <a:ln/>
+        </p:spPr>
+        <p:txBody>
+          <a:bodyPr wrap="square" lIns="0" tIns="0" rIns="0" bIns="0" rtlCol="0" anchor="t"/>
+          <a:lstStyle/>
+          <a:p>
+            <a:pPr algn="ctr" indent="0" marL="0">
               <a:buNone/>
             </a:pPr>
             <a:r>
@@ -9892,46 +10053,52 @@
                 <a:ea typeface="Verdana" pitchFamily="34" charset="-122"/>
                 <a:cs typeface="Verdana" pitchFamily="34" charset="-120"/>
               </a:rPr>
-              <a:t>  →  </a:t>
-            </a:r>
-            <a:pPr indent="0" marL="0">
-              <a:buNone/>
-            </a:pPr>
-            <a:r>
-              <a:rPr lang="en-US" sz="2200" b="1" dirty="0">
-                <a:solidFill>
-                  <a:srgbClr val="FF6B8A"/>
+              <a:t>You control the data</a:t>
+            </a:r>
+            <a:endParaRPr lang="en-US" sz="2200" dirty="0"/>
+          </a:p>
+          <a:p>
+            <a:pPr algn="ctr" indent="0" marL="0">
+              <a:buNone/>
+            </a:pPr>
+            <a:r>
+              <a:rPr lang="en-US" sz="2200" dirty="0">
+                <a:solidFill>
+                  <a:srgbClr val="8B95A5"/>
                 </a:solidFill>
                 <a:latin typeface="Verdana" pitchFamily="34" charset="0"/>
                 <a:ea typeface="Verdana" pitchFamily="34" charset="-122"/>
                 <a:cs typeface="Verdana" pitchFamily="34" charset="-120"/>
               </a:rPr>
-              <a:t>PII enters</a:t>
+              <a:t>Test data → enterprise tier</a:t>
             </a:r>
             <a:endParaRPr lang="en-US" sz="2200" dirty="0"/>
           </a:p>
           <a:p>
-            <a:pPr indent="0" marL="0">
-              <a:buNone/>
-            </a:pPr>
-            <a:endParaRPr lang="en-US" sz="2200" dirty="0"/>
-          </a:p>
-          <a:p>
-            <a:pPr indent="0" marL="0">
+            <a:pPr algn="ctr" indent="0" marL="0">
               <a:buNone/>
             </a:pPr>
             <a:r>
               <a:rPr lang="en-US" sz="2200" dirty="0">
                 <a:solidFill>
-                  <a:srgbClr val="EDEDED"/>
+                  <a:srgbClr val="8B95A5"/>
                 </a:solidFill>
                 <a:latin typeface="Verdana" pitchFamily="34" charset="0"/>
                 <a:ea typeface="Verdana" pitchFamily="34" charset="-122"/>
                 <a:cs typeface="Verdana" pitchFamily="34" charset="-120"/>
               </a:rPr>
-              <a:t>Engineering coding with test data</a:t>
-            </a:r>
-            <a:pPr indent="0" marL="0">
+              <a:t>Production data → EU-resident</a:t>
+            </a:r>
+            <a:endParaRPr lang="en-US" sz="2200" dirty="0"/>
+          </a:p>
+          <a:p>
+            <a:pPr algn="ctr" indent="0" marL="0">
+              <a:buNone/>
+            </a:pPr>
+            <a:endParaRPr lang="en-US" sz="2200" dirty="0"/>
+          </a:p>
+          <a:p>
+            <a:pPr algn="ctr" indent="0" marL="0">
               <a:buNone/>
             </a:pPr>
             <a:r>
@@ -9943,72 +10110,7 @@
                 <a:ea typeface="Verdana" pitchFamily="34" charset="-122"/>
                 <a:cs typeface="Verdana" pitchFamily="34" charset="-120"/>
               </a:rPr>
-              <a:t>  →  </a:t>
-            </a:r>
-            <a:pPr indent="0" marL="0">
-              <a:buNone/>
-            </a:pPr>
-            <a:r>
-              <a:rPr lang="en-US" sz="2200" b="1" dirty="0">
-                <a:solidFill>
-                  <a:srgbClr val="09825D"/>
-                </a:solidFill>
-                <a:latin typeface="Verdana" pitchFamily="34" charset="0"/>
-                <a:ea typeface="Verdana" pitchFamily="34" charset="-122"/>
-                <a:cs typeface="Verdana" pitchFamily="34" charset="-120"/>
-              </a:rPr>
-              <a:t>no PII</a:t>
-            </a:r>
-            <a:endParaRPr lang="en-US" sz="2200" dirty="0"/>
-          </a:p>
-          <a:p>
-            <a:pPr indent="0" marL="0">
-              <a:buNone/>
-            </a:pPr>
-            <a:endParaRPr lang="en-US" sz="2200" dirty="0"/>
-          </a:p>
-          <a:p>
-            <a:pPr indent="0" marL="0">
-              <a:buNone/>
-            </a:pPr>
-            <a:r>
-              <a:rPr lang="en-US" sz="2200" dirty="0">
-                <a:solidFill>
-                  <a:srgbClr val="EDEDED"/>
-                </a:solidFill>
-                <a:latin typeface="Verdana" pitchFamily="34" charset="0"/>
-                <a:ea typeface="Verdana" pitchFamily="34" charset="-122"/>
-                <a:cs typeface="Verdana" pitchFamily="34" charset="-120"/>
-              </a:rPr>
-              <a:t>Engineering debugging production</a:t>
-            </a:r>
-            <a:pPr indent="0" marL="0">
-              <a:buNone/>
-            </a:pPr>
-            <a:r>
-              <a:rPr lang="en-US" sz="2200" dirty="0">
-                <a:solidFill>
-                  <a:srgbClr val="8B95A5"/>
-                </a:solidFill>
-                <a:latin typeface="Verdana" pitchFamily="34" charset="0"/>
-                <a:ea typeface="Verdana" pitchFamily="34" charset="-122"/>
-                <a:cs typeface="Verdana" pitchFamily="34" charset="-120"/>
-              </a:rPr>
-              <a:t>  →  </a:t>
-            </a:r>
-            <a:pPr indent="0" marL="0">
-              <a:buNone/>
-            </a:pPr>
-            <a:r>
-              <a:rPr lang="en-US" sz="2200" b="1" dirty="0">
-                <a:solidFill>
-                  <a:srgbClr val="FF6B8A"/>
-                </a:solidFill>
-                <a:latin typeface="Verdana" pitchFamily="34" charset="0"/>
-                <a:ea typeface="Verdana" pitchFamily="34" charset="-122"/>
-                <a:cs typeface="Verdana" pitchFamily="34" charset="-120"/>
-              </a:rPr>
-              <a:t>PII enters</a:t>
+              <a:t>→ Two paths possible</a:t>
             </a:r>
             <a:endParaRPr lang="en-US" sz="2200" dirty="0"/>
           </a:p>
@@ -10076,8 +10178,8 @@
         </p:nvSpPr>
         <p:spPr>
           <a:xfrm>
-            <a:off x="1371600" y="1828800"/>
-            <a:ext cx="6400800" cy="1463040"/>
+            <a:off x="457200" y="274320"/>
+            <a:ext cx="8229600" cy="822960"/>
           </a:xfrm>
           <a:prstGeom prst="rect">
             <a:avLst/>
@@ -10089,21 +10191,241 @@
           <a:bodyPr wrap="square" lIns="0" tIns="0" rIns="0" bIns="0" rtlCol="0" anchor="ctr"/>
           <a:lstStyle/>
           <a:p>
-            <a:pPr algn="ctr" indent="0" marL="0">
-              <a:buNone/>
-            </a:pPr>
-            <a:r>
-              <a:rPr lang="en-US" sz="2800" i="1" dirty="0">
-                <a:solidFill>
-                  <a:srgbClr val="635BFF"/>
+            <a:pPr indent="0" marL="0">
+              <a:buNone/>
+            </a:pPr>
+            <a:r>
+              <a:rPr lang="en-US" sz="3600" b="1" dirty="0">
+                <a:solidFill>
+                  <a:srgbClr val="FFFFFF"/>
                 </a:solidFill>
                 <a:latin typeface="Georgia" pitchFamily="34" charset="0"/>
                 <a:ea typeface="Georgia" pitchFamily="34" charset="-122"/>
                 <a:cs typeface="Georgia" pitchFamily="34" charset="-120"/>
               </a:rPr>
-              <a:t>Time for the actual decision.</a:t>
-            </a:r>
-            <a:endParaRPr lang="en-US" sz="2800" dirty="0"/>
+              <a:t>The boundary only works for code.</a:t>
+            </a:r>
+            <a:endParaRPr lang="en-US" sz="3600" dirty="0"/>
+          </a:p>
+        </p:txBody>
+      </p:sp>
+      <p:sp>
+        <p:nvSpPr>
+          <p:cNvPr id="4" name="Text 2"/>
+          <p:cNvSpPr/>
+          <p:nvPr/>
+        </p:nvSpPr>
+        <p:spPr>
+          <a:xfrm>
+            <a:off x="640080" y="1371600"/>
+            <a:ext cx="7863840" cy="3200400"/>
+          </a:xfrm>
+          <a:prstGeom prst="rect">
+            <a:avLst/>
+          </a:prstGeom>
+          <a:noFill/>
+          <a:ln/>
+        </p:spPr>
+        <p:txBody>
+          <a:bodyPr wrap="square" lIns="0" tIns="0" rIns="0" bIns="0" rtlCol="0" anchor="t"/>
+          <a:lstStyle/>
+          <a:p>
+            <a:pPr indent="0" marL="0">
+              <a:buNone/>
+            </a:pPr>
+            <a:r>
+              <a:rPr lang="en-US" sz="2200" dirty="0">
+                <a:solidFill>
+                  <a:srgbClr val="EDEDED"/>
+                </a:solidFill>
+                <a:latin typeface="Verdana" pitchFamily="34" charset="0"/>
+                <a:ea typeface="Verdana" pitchFamily="34" charset="-122"/>
+                <a:cs typeface="Verdana" pitchFamily="34" charset="-120"/>
+              </a:rPr>
+              <a:t>Marketing drafting a client email</a:t>
+            </a:r>
+            <a:pPr indent="0" marL="0">
+              <a:buNone/>
+            </a:pPr>
+            <a:r>
+              <a:rPr lang="en-US" sz="2200" dirty="0">
+                <a:solidFill>
+                  <a:srgbClr val="8B95A5"/>
+                </a:solidFill>
+                <a:latin typeface="Verdana" pitchFamily="34" charset="0"/>
+                <a:ea typeface="Verdana" pitchFamily="34" charset="-122"/>
+                <a:cs typeface="Verdana" pitchFamily="34" charset="-120"/>
+              </a:rPr>
+              <a:t>  →  </a:t>
+            </a:r>
+            <a:pPr indent="0" marL="0">
+              <a:buNone/>
+            </a:pPr>
+            <a:r>
+              <a:rPr lang="en-US" sz="2200" b="1" dirty="0">
+                <a:solidFill>
+                  <a:srgbClr val="FF6B8A"/>
+                </a:solidFill>
+                <a:latin typeface="Verdana" pitchFamily="34" charset="0"/>
+                <a:ea typeface="Verdana" pitchFamily="34" charset="-122"/>
+                <a:cs typeface="Verdana" pitchFamily="34" charset="-120"/>
+              </a:rPr>
+              <a:t>PII enters</a:t>
+            </a:r>
+            <a:endParaRPr lang="en-US" sz="2200" dirty="0"/>
+          </a:p>
+          <a:p>
+            <a:pPr indent="0" marL="0">
+              <a:buNone/>
+            </a:pPr>
+            <a:endParaRPr lang="en-US" sz="2200" dirty="0"/>
+          </a:p>
+          <a:p>
+            <a:pPr indent="0" marL="0">
+              <a:buNone/>
+            </a:pPr>
+            <a:r>
+              <a:rPr lang="en-US" sz="2200" dirty="0">
+                <a:solidFill>
+                  <a:srgbClr val="EDEDED"/>
+                </a:solidFill>
+                <a:latin typeface="Verdana" pitchFamily="34" charset="0"/>
+                <a:ea typeface="Verdana" pitchFamily="34" charset="-122"/>
+                <a:cs typeface="Verdana" pitchFamily="34" charset="-120"/>
+              </a:rPr>
+              <a:t>Ops evaluating a customer claim</a:t>
+            </a:r>
+            <a:pPr indent="0" marL="0">
+              <a:buNone/>
+            </a:pPr>
+            <a:r>
+              <a:rPr lang="en-US" sz="2200" dirty="0">
+                <a:solidFill>
+                  <a:srgbClr val="8B95A5"/>
+                </a:solidFill>
+                <a:latin typeface="Verdana" pitchFamily="34" charset="0"/>
+                <a:ea typeface="Verdana" pitchFamily="34" charset="-122"/>
+                <a:cs typeface="Verdana" pitchFamily="34" charset="-120"/>
+              </a:rPr>
+              <a:t>  →  </a:t>
+            </a:r>
+            <a:pPr indent="0" marL="0">
+              <a:buNone/>
+            </a:pPr>
+            <a:r>
+              <a:rPr lang="en-US" sz="2200" b="1" dirty="0">
+                <a:solidFill>
+                  <a:srgbClr val="FF6B8A"/>
+                </a:solidFill>
+                <a:latin typeface="Verdana" pitchFamily="34" charset="0"/>
+                <a:ea typeface="Verdana" pitchFamily="34" charset="-122"/>
+                <a:cs typeface="Verdana" pitchFamily="34" charset="-120"/>
+              </a:rPr>
+              <a:t>PII enters</a:t>
+            </a:r>
+            <a:endParaRPr lang="en-US" sz="2200" dirty="0"/>
+          </a:p>
+          <a:p>
+            <a:pPr indent="0" marL="0">
+              <a:buNone/>
+            </a:pPr>
+            <a:endParaRPr lang="en-US" sz="2200" dirty="0"/>
+          </a:p>
+          <a:p>
+            <a:pPr indent="0" marL="0">
+              <a:buNone/>
+            </a:pPr>
+            <a:r>
+              <a:rPr lang="en-US" sz="2200" dirty="0">
+                <a:solidFill>
+                  <a:srgbClr val="EDEDED"/>
+                </a:solidFill>
+                <a:latin typeface="Verdana" pitchFamily="34" charset="0"/>
+                <a:ea typeface="Verdana" pitchFamily="34" charset="-122"/>
+                <a:cs typeface="Verdana" pitchFamily="34" charset="-120"/>
+              </a:rPr>
+              <a:t>Engineering coding with test data</a:t>
+            </a:r>
+            <a:pPr indent="0" marL="0">
+              <a:buNone/>
+            </a:pPr>
+            <a:r>
+              <a:rPr lang="en-US" sz="2200" dirty="0">
+                <a:solidFill>
+                  <a:srgbClr val="8B95A5"/>
+                </a:solidFill>
+                <a:latin typeface="Verdana" pitchFamily="34" charset="0"/>
+                <a:ea typeface="Verdana" pitchFamily="34" charset="-122"/>
+                <a:cs typeface="Verdana" pitchFamily="34" charset="-120"/>
+              </a:rPr>
+              <a:t>  →  </a:t>
+            </a:r>
+            <a:pPr indent="0" marL="0">
+              <a:buNone/>
+            </a:pPr>
+            <a:r>
+              <a:rPr lang="en-US" sz="2200" b="1" dirty="0">
+                <a:solidFill>
+                  <a:srgbClr val="09825D"/>
+                </a:solidFill>
+                <a:latin typeface="Verdana" pitchFamily="34" charset="0"/>
+                <a:ea typeface="Verdana" pitchFamily="34" charset="-122"/>
+                <a:cs typeface="Verdana" pitchFamily="34" charset="-120"/>
+              </a:rPr>
+              <a:t>no PII</a:t>
+            </a:r>
+            <a:endParaRPr lang="en-US" sz="2200" dirty="0"/>
+          </a:p>
+          <a:p>
+            <a:pPr indent="0" marL="0">
+              <a:buNone/>
+            </a:pPr>
+            <a:endParaRPr lang="en-US" sz="2200" dirty="0"/>
+          </a:p>
+          <a:p>
+            <a:pPr indent="0" marL="0">
+              <a:buNone/>
+            </a:pPr>
+            <a:r>
+              <a:rPr lang="en-US" sz="2200" dirty="0">
+                <a:solidFill>
+                  <a:srgbClr val="EDEDED"/>
+                </a:solidFill>
+                <a:latin typeface="Verdana" pitchFamily="34" charset="0"/>
+                <a:ea typeface="Verdana" pitchFamily="34" charset="-122"/>
+                <a:cs typeface="Verdana" pitchFamily="34" charset="-120"/>
+              </a:rPr>
+              <a:t>Engineering debugging production</a:t>
+            </a:r>
+            <a:pPr indent="0" marL="0">
+              <a:buNone/>
+            </a:pPr>
+            <a:r>
+              <a:rPr lang="en-US" sz="2200" dirty="0">
+                <a:solidFill>
+                  <a:srgbClr val="8B95A5"/>
+                </a:solidFill>
+                <a:latin typeface="Verdana" pitchFamily="34" charset="0"/>
+                <a:ea typeface="Verdana" pitchFamily="34" charset="-122"/>
+                <a:cs typeface="Verdana" pitchFamily="34" charset="-120"/>
+              </a:rPr>
+              <a:t>  →  </a:t>
+            </a:r>
+            <a:pPr indent="0" marL="0">
+              <a:buNone/>
+            </a:pPr>
+            <a:r>
+              <a:rPr lang="en-US" sz="2200" b="1" dirty="0">
+                <a:solidFill>
+                  <a:srgbClr val="FF6B8A"/>
+                </a:solidFill>
+                <a:latin typeface="Verdana" pitchFamily="34" charset="0"/>
+                <a:ea typeface="Verdana" pitchFamily="34" charset="-122"/>
+                <a:cs typeface="Verdana" pitchFamily="34" charset="-120"/>
+              </a:rPr>
+              <a:t>PII enters</a:t>
+            </a:r>
+            <a:endParaRPr lang="en-US" sz="2200" dirty="0"/>
           </a:p>
         </p:txBody>
       </p:sp>
@@ -10169,8 +10491,8 @@
         </p:nvSpPr>
         <p:spPr>
           <a:xfrm>
-            <a:off x="457200" y="274320"/>
-            <a:ext cx="8229600" cy="1005840"/>
+            <a:off x="1371600" y="1828800"/>
+            <a:ext cx="6400800" cy="1463040"/>
           </a:xfrm>
           <a:prstGeom prst="rect">
             <a:avLst/>
@@ -10182,239 +10504,21 @@
           <a:bodyPr wrap="square" lIns="0" tIns="0" rIns="0" bIns="0" rtlCol="0" anchor="ctr"/>
           <a:lstStyle/>
           <a:p>
-            <a:pPr indent="0" marL="0">
-              <a:buNone/>
-            </a:pPr>
-            <a:r>
-              <a:rPr lang="en-US" sz="3400" b="1" dirty="0">
-                <a:solidFill>
-                  <a:srgbClr val="FFFFFF"/>
+            <a:pPr algn="ctr" indent="0" marL="0">
+              <a:buNone/>
+            </a:pPr>
+            <a:r>
+              <a:rPr lang="en-US" sz="2800" i="1" dirty="0">
+                <a:solidFill>
+                  <a:srgbClr val="635BFF"/>
                 </a:solidFill>
                 <a:latin typeface="Georgia" pitchFamily="34" charset="0"/>
                 <a:ea typeface="Georgia" pitchFamily="34" charset="-122"/>
                 <a:cs typeface="Georgia" pitchFamily="34" charset="-120"/>
               </a:rPr>
-              <a:t>Five questions to ask</a:t>
-            </a:r>
-            <a:endParaRPr lang="en-US" sz="3400" dirty="0"/>
-          </a:p>
-          <a:p>
-            <a:pPr indent="0" marL="0">
-              <a:buNone/>
-            </a:pPr>
-            <a:r>
-              <a:rPr lang="en-US" sz="3400" b="1" dirty="0">
-                <a:solidFill>
-                  <a:srgbClr val="FFFFFF"/>
-                </a:solidFill>
-                <a:latin typeface="Georgia" pitchFamily="34" charset="0"/>
-                <a:ea typeface="Georgia" pitchFamily="34" charset="-122"/>
-                <a:cs typeface="Georgia" pitchFamily="34" charset="-120"/>
-              </a:rPr>
-              <a:t>before any vendor conversation</a:t>
-            </a:r>
-            <a:endParaRPr lang="en-US" sz="3400" dirty="0"/>
-          </a:p>
-        </p:txBody>
-      </p:sp>
-      <p:sp>
-        <p:nvSpPr>
-          <p:cNvPr id="4" name="Text 2"/>
-          <p:cNvSpPr/>
-          <p:nvPr/>
-        </p:nvSpPr>
-        <p:spPr>
-          <a:xfrm>
-            <a:off x="640080" y="1463040"/>
-            <a:ext cx="7863840" cy="3383280"/>
-          </a:xfrm>
-          <a:prstGeom prst="rect">
-            <a:avLst/>
-          </a:prstGeom>
-          <a:noFill/>
-          <a:ln/>
-        </p:spPr>
-        <p:txBody>
-          <a:bodyPr wrap="square" lIns="0" tIns="0" rIns="0" bIns="0" rtlCol="0" anchor="t"/>
-          <a:lstStyle/>
-          <a:p>
-            <a:pPr indent="0" marL="0">
-              <a:buNone/>
-            </a:pPr>
-            <a:r>
-              <a:rPr lang="en-US" sz="2400" b="1" dirty="0">
-                <a:solidFill>
-                  <a:srgbClr val="635BFF"/>
-                </a:solidFill>
-                <a:latin typeface="Verdana" pitchFamily="34" charset="0"/>
-                <a:ea typeface="Verdana" pitchFamily="34" charset="-122"/>
-                <a:cs typeface="Verdana" pitchFamily="34" charset="-120"/>
-              </a:rPr>
-              <a:t>1  </a:t>
-            </a:r>
-            <a:pPr indent="0" marL="0">
-              <a:buNone/>
-            </a:pPr>
-            <a:r>
-              <a:rPr lang="en-US" sz="2400" dirty="0">
-                <a:solidFill>
-                  <a:srgbClr val="EDEDED"/>
-                </a:solidFill>
-                <a:latin typeface="Verdana" pitchFamily="34" charset="0"/>
-                <a:ea typeface="Verdana" pitchFamily="34" charset="-122"/>
-                <a:cs typeface="Verdana" pitchFamily="34" charset="-120"/>
-              </a:rPr>
-              <a:t>What data touches the tool?</a:t>
-            </a:r>
-            <a:endParaRPr lang="en-US" sz="2400" dirty="0"/>
-          </a:p>
-          <a:p>
-            <a:pPr indent="0" marL="0">
-              <a:buNone/>
-            </a:pPr>
-            <a:endParaRPr lang="en-US" sz="2400" dirty="0"/>
-          </a:p>
-          <a:p>
-            <a:pPr indent="0" marL="0">
-              <a:buNone/>
-            </a:pPr>
-            <a:r>
-              <a:rPr lang="en-US" sz="2400" b="1" dirty="0">
-                <a:solidFill>
-                  <a:srgbClr val="635BFF"/>
-                </a:solidFill>
-                <a:latin typeface="Verdana" pitchFamily="34" charset="0"/>
-                <a:ea typeface="Verdana" pitchFamily="34" charset="-122"/>
-                <a:cs typeface="Verdana" pitchFamily="34" charset="-120"/>
-              </a:rPr>
-              <a:t>2  </a:t>
-            </a:r>
-            <a:pPr indent="0" marL="0">
-              <a:buNone/>
-            </a:pPr>
-            <a:r>
-              <a:rPr lang="en-US" sz="2400" dirty="0">
-                <a:solidFill>
-                  <a:srgbClr val="EDEDED"/>
-                </a:solidFill>
-                <a:latin typeface="Verdana" pitchFamily="34" charset="0"/>
-                <a:ea typeface="Verdana" pitchFamily="34" charset="-122"/>
-                <a:cs typeface="Verdana" pitchFamily="34" charset="-120"/>
-              </a:rPr>
-              <a:t>Where are your customers?</a:t>
-            </a:r>
-            <a:endParaRPr lang="en-US" sz="2400" dirty="0"/>
-          </a:p>
-          <a:p>
-            <a:pPr indent="0" marL="0">
-              <a:buNone/>
-            </a:pPr>
-            <a:endParaRPr lang="en-US" sz="2400" dirty="0"/>
-          </a:p>
-          <a:p>
-            <a:pPr indent="0" marL="0">
-              <a:buNone/>
-            </a:pPr>
-            <a:r>
-              <a:rPr lang="en-US" sz="2400" b="1" dirty="0">
-                <a:solidFill>
-                  <a:srgbClr val="635BFF"/>
-                </a:solidFill>
-                <a:latin typeface="Verdana" pitchFamily="34" charset="0"/>
-                <a:ea typeface="Verdana" pitchFamily="34" charset="-122"/>
-                <a:cs typeface="Verdana" pitchFamily="34" charset="-120"/>
-              </a:rPr>
-              <a:t>3  </a:t>
-            </a:r>
-            <a:pPr indent="0" marL="0">
-              <a:buNone/>
-            </a:pPr>
-            <a:r>
-              <a:rPr lang="en-US" sz="2400" dirty="0">
-                <a:solidFill>
-                  <a:srgbClr val="EDEDED"/>
-                </a:solidFill>
-                <a:latin typeface="Verdana" pitchFamily="34" charset="0"/>
-                <a:ea typeface="Verdana" pitchFamily="34" charset="-122"/>
-                <a:cs typeface="Verdana" pitchFamily="34" charset="-120"/>
-              </a:rPr>
-              <a:t>Engineering vs everyone else?</a:t>
-            </a:r>
-            <a:endParaRPr lang="en-US" sz="2400" dirty="0"/>
-          </a:p>
-          <a:p>
-            <a:pPr indent="0" marL="0">
-              <a:buNone/>
-            </a:pPr>
-            <a:endParaRPr lang="en-US" sz="2400" dirty="0"/>
-          </a:p>
-          <a:p>
-            <a:pPr indent="0" marL="0">
-              <a:buNone/>
-            </a:pPr>
-            <a:r>
-              <a:rPr lang="en-US" sz="2400" b="1" dirty="0">
-                <a:solidFill>
-                  <a:srgbClr val="635BFF"/>
-                </a:solidFill>
-                <a:latin typeface="Verdana" pitchFamily="34" charset="0"/>
-                <a:ea typeface="Verdana" pitchFamily="34" charset="-122"/>
-                <a:cs typeface="Verdana" pitchFamily="34" charset="-120"/>
-              </a:rPr>
-              <a:t>4  </a:t>
-            </a:r>
-            <a:pPr indent="0" marL="0">
-              <a:buNone/>
-            </a:pPr>
-            <a:r>
-              <a:rPr lang="en-US" sz="2400" dirty="0">
-                <a:solidFill>
-                  <a:srgbClr val="EDEDED"/>
-                </a:solidFill>
-                <a:latin typeface="Verdana" pitchFamily="34" charset="0"/>
-                <a:ea typeface="Verdana" pitchFamily="34" charset="-122"/>
-                <a:cs typeface="Verdana" pitchFamily="34" charset="-120"/>
-              </a:rPr>
-              <a:t>How many tools can you manage?</a:t>
-            </a:r>
-            <a:endParaRPr lang="en-US" sz="2400" dirty="0"/>
-          </a:p>
-          <a:p>
-            <a:pPr indent="0" marL="0">
-              <a:buNone/>
-            </a:pPr>
-            <a:endParaRPr lang="en-US" sz="2400" dirty="0"/>
-          </a:p>
-          <a:p>
-            <a:pPr indent="0" marL="0">
-              <a:buNone/>
-            </a:pPr>
-            <a:r>
-              <a:rPr lang="en-US" sz="2400" b="1" dirty="0">
-                <a:solidFill>
-                  <a:srgbClr val="635BFF"/>
-                </a:solidFill>
-                <a:latin typeface="Verdana" pitchFamily="34" charset="0"/>
-                <a:ea typeface="Verdana" pitchFamily="34" charset="-122"/>
-                <a:cs typeface="Verdana" pitchFamily="34" charset="-120"/>
-              </a:rPr>
-              <a:t>5  </a:t>
-            </a:r>
-            <a:pPr indent="0" marL="0">
-              <a:buNone/>
-            </a:pPr>
-            <a:r>
-              <a:rPr lang="en-US" sz="2400" dirty="0">
-                <a:solidFill>
-                  <a:srgbClr val="EDEDED"/>
-                </a:solidFill>
-                <a:latin typeface="Verdana" pitchFamily="34" charset="0"/>
-                <a:ea typeface="Verdana" pitchFamily="34" charset="-122"/>
-                <a:cs typeface="Verdana" pitchFamily="34" charset="-120"/>
-              </a:rPr>
-              <a:t>What’s your compliance maturity?</a:t>
-            </a:r>
-            <a:endParaRPr lang="en-US" sz="2400" dirty="0"/>
+              <a:t>Time for the actual decision.</a:t>
+            </a:r>
+            <a:endParaRPr lang="en-US" sz="2800" dirty="0"/>
           </a:p>
         </p:txBody>
       </p:sp>
@@ -10432,7 +10536,7 @@
     <p:bg>
       <p:bgPr>
         <a:solidFill>
-          <a:srgbClr val="0A2540"/>
+          <a:srgbClr val="FFFFFF"/>
         </a:solidFill>
       </p:bgPr>
     </p:bg>
@@ -10452,36 +10556,14 @@
       </p:grpSpPr>
       <p:sp>
         <p:nvSpPr>
-          <p:cNvPr id="2" name="Shape 0"/>
+          <p:cNvPr id="2" name="Text 0"/>
           <p:cNvSpPr/>
           <p:nvPr/>
         </p:nvSpPr>
         <p:spPr>
           <a:xfrm>
-            <a:off x="4572000" y="2286000"/>
-            <a:ext cx="7315200" cy="5486400"/>
-          </a:xfrm>
-          <a:prstGeom prst="ellipse">
-            <a:avLst/>
-          </a:prstGeom>
-          <a:solidFill>
-            <a:srgbClr val="635BFF">
-              <a:alpha val="4000"/>
-            </a:srgbClr>
-          </a:solidFill>
-          <a:ln/>
-        </p:spPr>
-      </p:sp>
-      <p:sp>
-        <p:nvSpPr>
-          <p:cNvPr id="3" name="Text 1"/>
-          <p:cNvSpPr/>
-          <p:nvPr/>
-        </p:nvSpPr>
-        <p:spPr>
-          <a:xfrm>
-            <a:off x="457200" y="1463040"/>
-            <a:ext cx="8229600" cy="1097280"/>
+            <a:off x="457200" y="137160"/>
+            <a:ext cx="8229600" cy="914400"/>
           </a:xfrm>
           <a:prstGeom prst="rect">
             <a:avLst/>
@@ -10493,34 +10575,51 @@
           <a:bodyPr wrap="square" lIns="0" tIns="0" rIns="0" bIns="0" rtlCol="0" anchor="ctr"/>
           <a:lstStyle/>
           <a:p>
-            <a:pPr algn="ctr" indent="0" marL="0">
-              <a:buNone/>
-            </a:pPr>
-            <a:r>
-              <a:rPr lang="en-US" sz="5400" b="1" dirty="0">
-                <a:solidFill>
-                  <a:srgbClr val="FFFFFF"/>
+            <a:pPr indent="0" marL="0">
+              <a:buNone/>
+            </a:pPr>
+            <a:r>
+              <a:rPr lang="en-US" sz="3400" b="1" dirty="0">
+                <a:solidFill>
+                  <a:srgbClr val="1A1F36"/>
                 </a:solidFill>
                 <a:latin typeface="Georgia" pitchFamily="34" charset="0"/>
                 <a:ea typeface="Georgia" pitchFamily="34" charset="-122"/>
                 <a:cs typeface="Georgia" pitchFamily="34" charset="-120"/>
               </a:rPr>
-              <a:t>The Recommended Setup</a:t>
-            </a:r>
-            <a:endParaRPr lang="en-US" sz="5400" dirty="0"/>
-          </a:p>
-        </p:txBody>
-      </p:sp>
-      <p:sp>
-        <p:nvSpPr>
-          <p:cNvPr id="4" name="Text 2"/>
+              <a:t>Five questions to ask</a:t>
+            </a:r>
+            <a:endParaRPr lang="en-US" sz="3400" dirty="0"/>
+          </a:p>
+          <a:p>
+            <a:pPr indent="0" marL="0">
+              <a:buNone/>
+            </a:pPr>
+            <a:r>
+              <a:rPr lang="en-US" sz="3400" b="1" dirty="0">
+                <a:solidFill>
+                  <a:srgbClr val="1A1F36"/>
+                </a:solidFill>
+                <a:latin typeface="Georgia" pitchFamily="34" charset="0"/>
+                <a:ea typeface="Georgia" pitchFamily="34" charset="-122"/>
+                <a:cs typeface="Georgia" pitchFamily="34" charset="-120"/>
+              </a:rPr>
+              <a:t>before any vendor conversation</a:t>
+            </a:r>
+            <a:endParaRPr lang="en-US" sz="3400" dirty="0"/>
+          </a:p>
+        </p:txBody>
+      </p:sp>
+      <p:sp>
+        <p:nvSpPr>
+          <p:cNvPr id="3" name="Text 1"/>
           <p:cNvSpPr/>
           <p:nvPr/>
         </p:nvSpPr>
         <p:spPr>
           <a:xfrm>
-            <a:off x="914400" y="2651760"/>
-            <a:ext cx="7315200" cy="548640"/>
+            <a:off x="640080" y="1188720"/>
+            <a:ext cx="7863840" cy="3749040"/>
           </a:xfrm>
           <a:prstGeom prst="rect">
             <a:avLst/>
@@ -10529,14 +10628,14 @@
           <a:ln/>
         </p:spPr>
         <p:txBody>
-          <a:bodyPr wrap="square" lIns="0" tIns="0" rIns="0" bIns="0" rtlCol="0" anchor="ctr"/>
-          <a:lstStyle/>
-          <a:p>
-            <a:pPr algn="ctr" indent="0" marL="0">
-              <a:buNone/>
-            </a:pPr>
-            <a:r>
-              <a:rPr lang="en-US" sz="2800" i="1" dirty="0">
+          <a:bodyPr wrap="square" lIns="0" tIns="0" rIns="0" bIns="0" rtlCol="0" anchor="t"/>
+          <a:lstStyle/>
+          <a:p>
+            <a:pPr indent="0" marL="0">
+              <a:buNone/>
+            </a:pPr>
+            <a:r>
+              <a:rPr lang="en-US" sz="1800" b="1" dirty="0">
                 <a:solidFill>
                   <a:srgbClr val="635BFF"/>
                 </a:solidFill>
@@ -10544,9 +10643,241 @@
                 <a:ea typeface="Verdana" pitchFamily="34" charset="-122"/>
                 <a:cs typeface="Verdana" pitchFamily="34" charset="-120"/>
               </a:rPr>
-              <a:t>A concrete starting point</a:t>
-            </a:r>
-            <a:endParaRPr lang="en-US" sz="2800" dirty="0"/>
+              <a:t>1  </a:t>
+            </a:r>
+            <a:pPr indent="0" marL="0">
+              <a:buNone/>
+            </a:pPr>
+            <a:r>
+              <a:rPr lang="en-US" sz="1800" b="1" dirty="0">
+                <a:solidFill>
+                  <a:srgbClr val="1A1F36"/>
+                </a:solidFill>
+                <a:latin typeface="Verdana" pitchFamily="34" charset="0"/>
+                <a:ea typeface="Verdana" pitchFamily="34" charset="-122"/>
+                <a:cs typeface="Verdana" pitchFamily="34" charset="-120"/>
+              </a:rPr>
+              <a:t>What data touches the tool?</a:t>
+            </a:r>
+            <a:pPr indent="0" marL="0">
+              <a:buNone/>
+            </a:pPr>
+            <a:r>
+              <a:rPr lang="en-US" sz="1600" dirty="0">
+                <a:solidFill>
+                  <a:srgbClr val="8B95A5"/>
+                </a:solidFill>
+                <a:latin typeface="Verdana" pitchFamily="34" charset="0"/>
+                <a:ea typeface="Verdana" pitchFamily="34" charset="-122"/>
+                <a:cs typeface="Verdana" pitchFamily="34" charset="-120"/>
+              </a:rPr>
+              <a:t>  PII = enterprise tier minimum. Sensitive + EU = EU residency.</a:t>
+            </a:r>
+            <a:endParaRPr lang="en-US" sz="1800" dirty="0"/>
+          </a:p>
+          <a:p>
+            <a:pPr indent="0" marL="0">
+              <a:buNone/>
+            </a:pPr>
+            <a:endParaRPr lang="en-US" sz="1800" dirty="0"/>
+          </a:p>
+          <a:p>
+            <a:pPr indent="0" marL="0">
+              <a:buNone/>
+            </a:pPr>
+            <a:r>
+              <a:rPr lang="en-US" sz="1800" b="1" dirty="0">
+                <a:solidFill>
+                  <a:srgbClr val="635BFF"/>
+                </a:solidFill>
+                <a:latin typeface="Verdana" pitchFamily="34" charset="0"/>
+                <a:ea typeface="Verdana" pitchFamily="34" charset="-122"/>
+                <a:cs typeface="Verdana" pitchFamily="34" charset="-120"/>
+              </a:rPr>
+              <a:t>2  </a:t>
+            </a:r>
+            <a:pPr indent="0" marL="0">
+              <a:buNone/>
+            </a:pPr>
+            <a:r>
+              <a:rPr lang="en-US" sz="1800" b="1" dirty="0">
+                <a:solidFill>
+                  <a:srgbClr val="1A1F36"/>
+                </a:solidFill>
+                <a:latin typeface="Verdana" pitchFamily="34" charset="0"/>
+                <a:ea typeface="Verdana" pitchFamily="34" charset="-122"/>
+                <a:cs typeface="Verdana" pitchFamily="34" charset="-120"/>
+              </a:rPr>
+              <a:t>Where are your customers?</a:t>
+            </a:r>
+            <a:pPr indent="0" marL="0">
+              <a:buNone/>
+            </a:pPr>
+            <a:r>
+              <a:rPr lang="en-US" sz="1600" dirty="0">
+                <a:solidFill>
+                  <a:srgbClr val="8B95A5"/>
+                </a:solidFill>
+                <a:latin typeface="Verdana" pitchFamily="34" charset="0"/>
+                <a:ea typeface="Verdana" pitchFamily="34" charset="-122"/>
+                <a:cs typeface="Verdana" pitchFamily="34" charset="-120"/>
+              </a:rPr>
+              <a:t>  EU customers = GDPR applies. Consider residency, not just SCCs.</a:t>
+            </a:r>
+            <a:endParaRPr lang="en-US" sz="1800" dirty="0"/>
+          </a:p>
+          <a:p>
+            <a:pPr indent="0" marL="0">
+              <a:buNone/>
+            </a:pPr>
+            <a:endParaRPr lang="en-US" sz="1800" dirty="0"/>
+          </a:p>
+          <a:p>
+            <a:pPr indent="0" marL="0">
+              <a:buNone/>
+            </a:pPr>
+            <a:r>
+              <a:rPr lang="en-US" sz="1800" b="1" dirty="0">
+                <a:solidFill>
+                  <a:srgbClr val="635BFF"/>
+                </a:solidFill>
+                <a:latin typeface="Verdana" pitchFamily="34" charset="0"/>
+                <a:ea typeface="Verdana" pitchFamily="34" charset="-122"/>
+                <a:cs typeface="Verdana" pitchFamily="34" charset="-120"/>
+              </a:rPr>
+              <a:t>3  </a:t>
+            </a:r>
+            <a:pPr indent="0" marL="0">
+              <a:buNone/>
+            </a:pPr>
+            <a:r>
+              <a:rPr lang="en-US" sz="1800" b="1" dirty="0">
+                <a:solidFill>
+                  <a:srgbClr val="1A1F36"/>
+                </a:solidFill>
+                <a:latin typeface="Verdana" pitchFamily="34" charset="0"/>
+                <a:ea typeface="Verdana" pitchFamily="34" charset="-122"/>
+                <a:cs typeface="Verdana" pitchFamily="34" charset="-120"/>
+              </a:rPr>
+              <a:t>Engineering vs everyone else?</a:t>
+            </a:r>
+            <a:pPr indent="0" marL="0">
+              <a:buNone/>
+            </a:pPr>
+            <a:r>
+              <a:rPr lang="en-US" sz="1600" dirty="0">
+                <a:solidFill>
+                  <a:srgbClr val="8B95A5"/>
+                </a:solidFill>
+                <a:latin typeface="Verdana" pitchFamily="34" charset="0"/>
+                <a:ea typeface="Verdana" pitchFamily="34" charset="-122"/>
+                <a:cs typeface="Verdana" pitchFamily="34" charset="-120"/>
+              </a:rPr>
+              <a:t>  Different departments = different risk profiles.</a:t>
+            </a:r>
+            <a:endParaRPr lang="en-US" sz="1800" dirty="0"/>
+          </a:p>
+          <a:p>
+            <a:pPr indent="0" marL="0">
+              <a:buNone/>
+            </a:pPr>
+            <a:endParaRPr lang="en-US" sz="1800" dirty="0"/>
+          </a:p>
+          <a:p>
+            <a:pPr indent="0" marL="0">
+              <a:buNone/>
+            </a:pPr>
+            <a:r>
+              <a:rPr lang="en-US" sz="1800" b="1" dirty="0">
+                <a:solidFill>
+                  <a:srgbClr val="635BFF"/>
+                </a:solidFill>
+                <a:latin typeface="Verdana" pitchFamily="34" charset="0"/>
+                <a:ea typeface="Verdana" pitchFamily="34" charset="-122"/>
+                <a:cs typeface="Verdana" pitchFamily="34" charset="-120"/>
+              </a:rPr>
+              <a:t>4  </a:t>
+            </a:r>
+            <a:pPr indent="0" marL="0">
+              <a:buNone/>
+            </a:pPr>
+            <a:r>
+              <a:rPr lang="en-US" sz="1800" b="1" dirty="0">
+                <a:solidFill>
+                  <a:srgbClr val="1A1F36"/>
+                </a:solidFill>
+                <a:latin typeface="Verdana" pitchFamily="34" charset="0"/>
+                <a:ea typeface="Verdana" pitchFamily="34" charset="-122"/>
+                <a:cs typeface="Verdana" pitchFamily="34" charset="-120"/>
+              </a:rPr>
+              <a:t>How many tools can you manage?</a:t>
+            </a:r>
+            <a:pPr indent="0" marL="0">
+              <a:buNone/>
+            </a:pPr>
+            <a:r>
+              <a:rPr lang="en-US" sz="1600" dirty="0">
+                <a:solidFill>
+                  <a:srgbClr val="8B95A5"/>
+                </a:solidFill>
+                <a:latin typeface="Verdana" pitchFamily="34" charset="0"/>
+                <a:ea typeface="Verdana" pitchFamily="34" charset="-122"/>
+                <a:cs typeface="Verdana" pitchFamily="34" charset="-120"/>
+              </a:rPr>
+              <a:t>  Every direct provider = a DPA, a tier distinction, training. Platform approach: one DPA, all models.</a:t>
+            </a:r>
+            <a:endParaRPr lang="en-US" sz="1800" dirty="0"/>
+          </a:p>
+          <a:p>
+            <a:pPr indent="0" marL="0">
+              <a:buNone/>
+            </a:pPr>
+            <a:endParaRPr lang="en-US" sz="1800" dirty="0"/>
+          </a:p>
+          <a:p>
+            <a:pPr indent="0" marL="0">
+              <a:buNone/>
+            </a:pPr>
+            <a:r>
+              <a:rPr lang="en-US" sz="1800" b="1" dirty="0">
+                <a:solidFill>
+                  <a:srgbClr val="635BFF"/>
+                </a:solidFill>
+                <a:latin typeface="Verdana" pitchFamily="34" charset="0"/>
+                <a:ea typeface="Verdana" pitchFamily="34" charset="-122"/>
+                <a:cs typeface="Verdana" pitchFamily="34" charset="-120"/>
+              </a:rPr>
+              <a:t>5  </a:t>
+            </a:r>
+            <a:pPr indent="0" marL="0">
+              <a:buNone/>
+            </a:pPr>
+            <a:r>
+              <a:rPr lang="en-US" sz="1800" b="1" dirty="0">
+                <a:solidFill>
+                  <a:srgbClr val="1A1F36"/>
+                </a:solidFill>
+                <a:latin typeface="Verdana" pitchFamily="34" charset="0"/>
+                <a:ea typeface="Verdana" pitchFamily="34" charset="-122"/>
+                <a:cs typeface="Verdana" pitchFamily="34" charset="-120"/>
+              </a:rPr>
+              <a:t>What’s your compliance maturity?</a:t>
+            </a:r>
+            <a:pPr indent="0" marL="0">
+              <a:buNone/>
+            </a:pPr>
+            <a:r>
+              <a:rPr lang="en-US" sz="1600" dirty="0">
+                <a:solidFill>
+                  <a:srgbClr val="8B95A5"/>
+                </a:solidFill>
+                <a:latin typeface="Verdana" pitchFamily="34" charset="0"/>
+                <a:ea typeface="Verdana" pitchFamily="34" charset="-122"/>
+                <a:cs typeface="Verdana" pitchFamily="34" charset="-120"/>
+              </a:rPr>
+              <a:t>  No DPO? Pick the simplest path.</a:t>
+            </a:r>
+            <a:endParaRPr lang="en-US" sz="1800" dirty="0"/>
           </a:p>
         </p:txBody>
       </p:sp>
@@ -10612,8 +10943,8 @@
         </p:nvSpPr>
         <p:spPr>
           <a:xfrm>
-            <a:off x="457200" y="731520"/>
-            <a:ext cx="3840480" cy="640080"/>
+            <a:off x="457200" y="1463040"/>
+            <a:ext cx="8229600" cy="1097280"/>
           </a:xfrm>
           <a:prstGeom prst="rect">
             <a:avLst/>
@@ -10629,17 +10960,17 @@
               <a:buNone/>
             </a:pPr>
             <a:r>
-              <a:rPr lang="en-US" sz="3600" b="1" dirty="0">
-                <a:solidFill>
-                  <a:srgbClr val="635BFF"/>
+              <a:rPr lang="en-US" sz="5400" b="1" dirty="0">
+                <a:solidFill>
+                  <a:srgbClr val="FFFFFF"/>
                 </a:solidFill>
                 <a:latin typeface="Georgia" pitchFamily="34" charset="0"/>
                 <a:ea typeface="Georgia" pitchFamily="34" charset="-122"/>
                 <a:cs typeface="Georgia" pitchFamily="34" charset="-120"/>
               </a:rPr>
-              <a:t>EU Companies</a:t>
-            </a:r>
-            <a:endParaRPr lang="en-US" sz="3600" dirty="0"/>
+              <a:t>The Recommended Setup</a:t>
+            </a:r>
+            <a:endParaRPr lang="en-US" sz="5400" dirty="0"/>
           </a:p>
         </p:txBody>
       </p:sp>
@@ -10651,8 +10982,8 @@
         </p:nvSpPr>
         <p:spPr>
           <a:xfrm>
-            <a:off x="457200" y="1737360"/>
-            <a:ext cx="3840480" cy="2286000"/>
+            <a:off x="914400" y="2651760"/>
+            <a:ext cx="7315200" cy="548640"/>
           </a:xfrm>
           <a:prstGeom prst="rect">
             <a:avLst/>
@@ -10661,336 +10992,24 @@
           <a:ln/>
         </p:spPr>
         <p:txBody>
-          <a:bodyPr wrap="square" lIns="0" tIns="0" rIns="0" bIns="0" rtlCol="0" anchor="t"/>
+          <a:bodyPr wrap="square" lIns="0" tIns="0" rIns="0" bIns="0" rtlCol="0" anchor="ctr"/>
           <a:lstStyle/>
           <a:p>
             <a:pPr algn="ctr" indent="0" marL="0">
               <a:buNone/>
             </a:pPr>
             <a:r>
-              <a:rPr lang="en-US" sz="2200" dirty="0">
-                <a:solidFill>
-                  <a:srgbClr val="8B95A5"/>
+              <a:rPr lang="en-US" sz="2800" i="1" dirty="0">
+                <a:solidFill>
+                  <a:srgbClr val="635BFF"/>
                 </a:solidFill>
                 <a:latin typeface="Verdana" pitchFamily="34" charset="0"/>
                 <a:ea typeface="Verdana" pitchFamily="34" charset="-122"/>
                 <a:cs typeface="Verdana" pitchFamily="34" charset="-120"/>
               </a:rPr>
-              <a:t>Assume PII will enter.</a:t>
-            </a:r>
-            <a:endParaRPr lang="en-US" sz="2200" dirty="0"/>
-          </a:p>
-          <a:p>
-            <a:pPr algn="ctr" indent="0" marL="0">
-              <a:buNone/>
-            </a:pPr>
-            <a:r>
-              <a:rPr lang="en-US" sz="2200" dirty="0">
-                <a:solidFill>
-                  <a:srgbClr val="8B95A5"/>
-                </a:solidFill>
-                <a:latin typeface="Verdana" pitchFamily="34" charset="0"/>
-                <a:ea typeface="Verdana" pitchFamily="34" charset="-122"/>
-                <a:cs typeface="Verdana" pitchFamily="34" charset="-120"/>
-              </a:rPr>
-              <a:t>Default to EU-resident.</a:t>
-            </a:r>
-            <a:endParaRPr lang="en-US" sz="2200" dirty="0"/>
-          </a:p>
-          <a:p>
-            <a:pPr algn="ctr" indent="0" marL="0">
-              <a:buNone/>
-            </a:pPr>
-            <a:endParaRPr lang="en-US" sz="2200" dirty="0"/>
-          </a:p>
-          <a:p>
-            <a:pPr algn="ctr" indent="0" marL="0">
-              <a:buNone/>
-            </a:pPr>
-            <a:r>
-              <a:rPr lang="en-US" sz="2200" dirty="0">
-                <a:solidFill>
-                  <a:srgbClr val="8B95A5"/>
-                </a:solidFill>
-                <a:latin typeface="Verdana" pitchFamily="34" charset="0"/>
-                <a:ea typeface="Verdana" pitchFamily="34" charset="-122"/>
-                <a:cs typeface="Verdana" pitchFamily="34" charset="-120"/>
-              </a:rPr>
-              <a:t>General use:</a:t>
-            </a:r>
-            <a:endParaRPr lang="en-US" sz="2200" dirty="0"/>
-          </a:p>
-          <a:p>
-            <a:pPr algn="ctr" indent="0" marL="0">
-              <a:buNone/>
-            </a:pPr>
-            <a:r>
-              <a:rPr lang="en-US" sz="2200" dirty="0">
-                <a:solidFill>
-                  <a:srgbClr val="8B95A5"/>
-                </a:solidFill>
-                <a:latin typeface="Verdana" pitchFamily="34" charset="0"/>
-                <a:ea typeface="Verdana" pitchFamily="34" charset="-122"/>
-                <a:cs typeface="Verdana" pitchFamily="34" charset="-120"/>
-              </a:rPr>
-              <a:t>Google Workspace Gemini</a:t>
-            </a:r>
-            <a:endParaRPr lang="en-US" sz="2200" dirty="0"/>
-          </a:p>
-          <a:p>
-            <a:pPr algn="ctr" indent="0" marL="0">
-              <a:buNone/>
-            </a:pPr>
-            <a:endParaRPr lang="en-US" sz="2200" dirty="0"/>
-          </a:p>
-          <a:p>
-            <a:pPr algn="ctr" indent="0" marL="0">
-              <a:buNone/>
-            </a:pPr>
-            <a:r>
-              <a:rPr lang="en-US" sz="2200" dirty="0">
-                <a:solidFill>
-                  <a:srgbClr val="8B95A5"/>
-                </a:solidFill>
-                <a:latin typeface="Verdana" pitchFamily="34" charset="0"/>
-                <a:ea typeface="Verdana" pitchFamily="34" charset="-122"/>
-                <a:cs typeface="Verdana" pitchFamily="34" charset="-120"/>
-              </a:rPr>
-              <a:t>Coding:</a:t>
-            </a:r>
-            <a:endParaRPr lang="en-US" sz="2200" dirty="0"/>
-          </a:p>
-          <a:p>
-            <a:pPr algn="ctr" indent="0" marL="0">
-              <a:buNone/>
-            </a:pPr>
-            <a:r>
-              <a:rPr lang="en-US" sz="2200" dirty="0">
-                <a:solidFill>
-                  <a:srgbClr val="8B95A5"/>
-                </a:solidFill>
-                <a:latin typeface="Verdana" pitchFamily="34" charset="0"/>
-                <a:ea typeface="Verdana" pitchFamily="34" charset="-122"/>
-                <a:cs typeface="Verdana" pitchFamily="34" charset="-120"/>
-              </a:rPr>
-              <a:t>Claude Code via Vertex AI</a:t>
-            </a:r>
-            <a:endParaRPr lang="en-US" sz="2200" dirty="0"/>
-          </a:p>
-        </p:txBody>
-      </p:sp>
-      <p:sp>
-        <p:nvSpPr>
-          <p:cNvPr id="5" name="Shape 3"/>
-          <p:cNvSpPr/>
-          <p:nvPr/>
-        </p:nvSpPr>
-        <p:spPr>
-          <a:xfrm>
-            <a:off x="4572000" y="731520"/>
-            <a:ext cx="0" cy="3291840"/>
-          </a:xfrm>
-          <a:prstGeom prst="line">
-            <a:avLst/>
-          </a:prstGeom>
-          <a:noFill/>
-          <a:ln w="12700">
-            <a:solidFill>
-              <a:srgbClr val="635BFF"/>
-            </a:solidFill>
-            <a:prstDash val="solid"/>
-          </a:ln>
-        </p:spPr>
-      </p:sp>
-      <p:sp>
-        <p:nvSpPr>
-          <p:cNvPr id="6" name="Text 4"/>
-          <p:cNvSpPr/>
-          <p:nvPr/>
-        </p:nvSpPr>
-        <p:spPr>
-          <a:xfrm>
-            <a:off x="4846320" y="731520"/>
-            <a:ext cx="3840480" cy="640080"/>
-          </a:xfrm>
-          <a:prstGeom prst="rect">
-            <a:avLst/>
-          </a:prstGeom>
-          <a:noFill/>
-          <a:ln/>
-        </p:spPr>
-        <p:txBody>
-          <a:bodyPr wrap="square" lIns="0" tIns="0" rIns="0" bIns="0" rtlCol="0" anchor="ctr"/>
-          <a:lstStyle/>
-          <a:p>
-            <a:pPr algn="ctr" indent="0" marL="0">
-              <a:buNone/>
-            </a:pPr>
-            <a:r>
-              <a:rPr lang="en-US" sz="3600" b="1" dirty="0">
-                <a:solidFill>
-                  <a:srgbClr val="635BFF"/>
-                </a:solidFill>
-                <a:latin typeface="Georgia" pitchFamily="34" charset="0"/>
-                <a:ea typeface="Georgia" pitchFamily="34" charset="-122"/>
-                <a:cs typeface="Georgia" pitchFamily="34" charset="-120"/>
-              </a:rPr>
-              <a:t>Non-EU Companies</a:t>
-            </a:r>
-            <a:endParaRPr lang="en-US" sz="3600" dirty="0"/>
-          </a:p>
-        </p:txBody>
-      </p:sp>
-      <p:sp>
-        <p:nvSpPr>
-          <p:cNvPr id="7" name="Text 5"/>
-          <p:cNvSpPr/>
-          <p:nvPr/>
-        </p:nvSpPr>
-        <p:spPr>
-          <a:xfrm>
-            <a:off x="4846320" y="1737360"/>
-            <a:ext cx="3840480" cy="2286000"/>
-          </a:xfrm>
-          <a:prstGeom prst="rect">
-            <a:avLst/>
-          </a:prstGeom>
-          <a:noFill/>
-          <a:ln/>
-        </p:spPr>
-        <p:txBody>
-          <a:bodyPr wrap="square" lIns="0" tIns="0" rIns="0" bIns="0" rtlCol="0" anchor="t"/>
-          <a:lstStyle/>
-          <a:p>
-            <a:pPr algn="ctr" indent="0" marL="0">
-              <a:buNone/>
-            </a:pPr>
-            <a:r>
-              <a:rPr lang="en-US" sz="2200" dirty="0">
-                <a:solidFill>
-                  <a:srgbClr val="8B95A5"/>
-                </a:solidFill>
-                <a:latin typeface="Verdana" pitchFamily="34" charset="0"/>
-                <a:ea typeface="Verdana" pitchFamily="34" charset="-122"/>
-                <a:cs typeface="Verdana" pitchFamily="34" charset="-120"/>
-              </a:rPr>
-              <a:t>Enterprise tier + DPA</a:t>
-            </a:r>
-            <a:endParaRPr lang="en-US" sz="2200" dirty="0"/>
-          </a:p>
-          <a:p>
-            <a:pPr algn="ctr" indent="0" marL="0">
-              <a:buNone/>
-            </a:pPr>
-            <a:r>
-              <a:rPr lang="en-US" sz="2200" dirty="0">
-                <a:solidFill>
-                  <a:srgbClr val="8B95A5"/>
-                </a:solidFill>
-                <a:latin typeface="Verdana" pitchFamily="34" charset="0"/>
-                <a:ea typeface="Verdana" pitchFamily="34" charset="-122"/>
-                <a:cs typeface="Verdana" pitchFamily="34" charset="-120"/>
-              </a:rPr>
-              <a:t>as the baseline.</a:t>
-            </a:r>
-            <a:endParaRPr lang="en-US" sz="2200" dirty="0"/>
-          </a:p>
-          <a:p>
-            <a:pPr algn="ctr" indent="0" marL="0">
-              <a:buNone/>
-            </a:pPr>
-            <a:endParaRPr lang="en-US" sz="2200" dirty="0"/>
-          </a:p>
-          <a:p>
-            <a:pPr algn="ctr" indent="0" marL="0">
-              <a:buNone/>
-            </a:pPr>
-            <a:r>
-              <a:rPr lang="en-US" sz="2200" dirty="0">
-                <a:solidFill>
-                  <a:srgbClr val="8B95A5"/>
-                </a:solidFill>
-                <a:latin typeface="Verdana" pitchFamily="34" charset="0"/>
-                <a:ea typeface="Verdana" pitchFamily="34" charset="-122"/>
-                <a:cs typeface="Verdana" pitchFamily="34" charset="-120"/>
-              </a:rPr>
-              <a:t>General use:</a:t>
-            </a:r>
-            <a:endParaRPr lang="en-US" sz="2200" dirty="0"/>
-          </a:p>
-          <a:p>
-            <a:pPr algn="ctr" indent="0" marL="0">
-              <a:buNone/>
-            </a:pPr>
-            <a:r>
-              <a:rPr lang="en-US" sz="2200" dirty="0">
-                <a:solidFill>
-                  <a:srgbClr val="8B95A5"/>
-                </a:solidFill>
-                <a:latin typeface="Verdana" pitchFamily="34" charset="0"/>
-                <a:ea typeface="Verdana" pitchFamily="34" charset="-122"/>
-                <a:cs typeface="Verdana" pitchFamily="34" charset="-120"/>
-              </a:rPr>
-              <a:t>Claude Team</a:t>
-            </a:r>
-            <a:endParaRPr lang="en-US" sz="2200" dirty="0"/>
-          </a:p>
-          <a:p>
-            <a:pPr algn="ctr" indent="0" marL="0">
-              <a:buNone/>
-            </a:pPr>
-            <a:r>
-              <a:rPr lang="en-US" sz="2200" dirty="0">
-                <a:solidFill>
-                  <a:srgbClr val="8B95A5"/>
-                </a:solidFill>
-                <a:latin typeface="Verdana" pitchFamily="34" charset="0"/>
-                <a:ea typeface="Verdana" pitchFamily="34" charset="-122"/>
-                <a:cs typeface="Verdana" pitchFamily="34" charset="-120"/>
-              </a:rPr>
-              <a:t>or ChatGPT Business</a:t>
-            </a:r>
-            <a:endParaRPr lang="en-US" sz="2200" dirty="0"/>
-          </a:p>
-          <a:p>
-            <a:pPr algn="ctr" indent="0" marL="0">
-              <a:buNone/>
-            </a:pPr>
-            <a:endParaRPr lang="en-US" sz="2200" dirty="0"/>
-          </a:p>
-          <a:p>
-            <a:pPr algn="ctr" indent="0" marL="0">
-              <a:buNone/>
-            </a:pPr>
-            <a:r>
-              <a:rPr lang="en-US" sz="2200" dirty="0">
-                <a:solidFill>
-                  <a:srgbClr val="8B95A5"/>
-                </a:solidFill>
-                <a:latin typeface="Verdana" pitchFamily="34" charset="0"/>
-                <a:ea typeface="Verdana" pitchFamily="34" charset="-122"/>
-                <a:cs typeface="Verdana" pitchFamily="34" charset="-120"/>
-              </a:rPr>
-              <a:t>Coding:</a:t>
-            </a:r>
-            <a:endParaRPr lang="en-US" sz="2200" dirty="0"/>
-          </a:p>
-          <a:p>
-            <a:pPr algn="ctr" indent="0" marL="0">
-              <a:buNone/>
-            </a:pPr>
-            <a:r>
-              <a:rPr lang="en-US" sz="2200" dirty="0">
-                <a:solidFill>
-                  <a:srgbClr val="8B95A5"/>
-                </a:solidFill>
-                <a:latin typeface="Verdana" pitchFamily="34" charset="0"/>
-                <a:ea typeface="Verdana" pitchFamily="34" charset="-122"/>
-                <a:cs typeface="Verdana" pitchFamily="34" charset="-120"/>
-              </a:rPr>
-              <a:t>Claude Code (Team/API)</a:t>
-            </a:r>
-            <a:endParaRPr lang="en-US" sz="2200" dirty="0"/>
+              <a:t>A concrete starting point</a:t>
+            </a:r>
+            <a:endParaRPr lang="en-US" sz="2800" dirty="0"/>
           </a:p>
         </p:txBody>
       </p:sp>
@@ -11008,7 +11027,7 @@
     <p:bg>
       <p:bgPr>
         <a:solidFill>
-          <a:srgbClr val="0A2540"/>
+          <a:srgbClr val="FFFFFF"/>
         </a:solidFill>
       </p:bgPr>
     </p:bg>
@@ -11028,36 +11047,14 @@
       </p:grpSpPr>
       <p:sp>
         <p:nvSpPr>
-          <p:cNvPr id="2" name="Shape 0"/>
+          <p:cNvPr id="2" name="Text 0"/>
           <p:cNvSpPr/>
           <p:nvPr/>
         </p:nvSpPr>
         <p:spPr>
           <a:xfrm>
-            <a:off x="4572000" y="2286000"/>
-            <a:ext cx="7315200" cy="5486400"/>
-          </a:xfrm>
-          <a:prstGeom prst="ellipse">
-            <a:avLst/>
-          </a:prstGeom>
-          <a:solidFill>
-            <a:srgbClr val="635BFF">
-              <a:alpha val="4000"/>
-            </a:srgbClr>
-          </a:solidFill>
-          <a:ln/>
-        </p:spPr>
-      </p:sp>
-      <p:sp>
-        <p:nvSpPr>
-          <p:cNvPr id="3" name="Text 1"/>
-          <p:cNvSpPr/>
-          <p:nvPr/>
-        </p:nvSpPr>
-        <p:spPr>
-          <a:xfrm>
-            <a:off x="914400" y="731520"/>
-            <a:ext cx="7315200" cy="2560320"/>
+            <a:off x="457200" y="137160"/>
+            <a:ext cx="8229600" cy="1097280"/>
           </a:xfrm>
           <a:prstGeom prst="rect">
             <a:avLst/>
@@ -11069,38 +11066,250 @@
           <a:bodyPr wrap="square" lIns="0" tIns="0" rIns="0" bIns="0" rtlCol="0" anchor="ctr"/>
           <a:lstStyle/>
           <a:p>
-            <a:pPr algn="ctr" indent="0" marL="0">
-              <a:buNone/>
-            </a:pPr>
-            <a:r>
-              <a:rPr lang="en-US" sz="4400" b="1" dirty="0">
-                <a:solidFill>
-                  <a:srgbClr val="FF6B8A"/>
+            <a:pPr indent="0" marL="0">
+              <a:buNone/>
+            </a:pPr>
+            <a:r>
+              <a:rPr lang="en-US" sz="3800" b="1" dirty="0">
+                <a:solidFill>
+                  <a:srgbClr val="1A1F36"/>
                 </a:solidFill>
                 <a:latin typeface="Georgia" pitchFamily="34" charset="0"/>
                 <a:ea typeface="Georgia" pitchFamily="34" charset="-122"/>
                 <a:cs typeface="Georgia" pitchFamily="34" charset="-120"/>
               </a:rPr>
-              <a:t>Free tiers are not approved</a:t>
-            </a:r>
-            <a:endParaRPr lang="en-US" sz="4400" dirty="0"/>
-          </a:p>
-          <a:p>
-            <a:pPr algn="ctr" indent="0" marL="0">
-              <a:buNone/>
-            </a:pPr>
-            <a:r>
-              <a:rPr lang="en-US" sz="4400" b="1" dirty="0">
-                <a:solidFill>
-                  <a:srgbClr val="FF6B8A"/>
-                </a:solidFill>
-                <a:latin typeface="Georgia" pitchFamily="34" charset="0"/>
-                <a:ea typeface="Georgia" pitchFamily="34" charset="-122"/>
-                <a:cs typeface="Georgia" pitchFamily="34" charset="-120"/>
-              </a:rPr>
-              <a:t>for work. Full stop.</a:t>
-            </a:r>
-            <a:endParaRPr lang="en-US" sz="4400" dirty="0"/>
+              <a:t>The recommended setup for EU companies</a:t>
+            </a:r>
+            <a:endParaRPr lang="en-US" sz="3800" dirty="0"/>
+          </a:p>
+        </p:txBody>
+      </p:sp>
+      <p:sp>
+        <p:nvSpPr>
+          <p:cNvPr id="3" name="Text 1"/>
+          <p:cNvSpPr/>
+          <p:nvPr/>
+        </p:nvSpPr>
+        <p:spPr>
+          <a:xfrm>
+            <a:off x="457200" y="1325880"/>
+            <a:ext cx="8229600" cy="2834640"/>
+          </a:xfrm>
+          <a:prstGeom prst="rect">
+            <a:avLst/>
+          </a:prstGeom>
+          <a:noFill/>
+          <a:ln/>
+        </p:spPr>
+        <p:txBody>
+          <a:bodyPr wrap="square" lIns="0" tIns="0" rIns="0" bIns="0" rtlCol="0" anchor="t"/>
+          <a:lstStyle/>
+          <a:p>
+            <a:pPr indent="0" marL="0">
+              <a:buNone/>
+            </a:pPr>
+            <a:r>
+              <a:rPr lang="en-US" sz="1800" b="1" dirty="0">
+                <a:solidFill>
+                  <a:srgbClr val="635BFF"/>
+                </a:solidFill>
+                <a:latin typeface="Verdana" pitchFamily="34" charset="0"/>
+                <a:ea typeface="Verdana" pitchFamily="34" charset="-122"/>
+                <a:cs typeface="Verdana" pitchFamily="34" charset="-120"/>
+              </a:rPr>
+              <a:t>A — EU-native platform</a:t>
+            </a:r>
+            <a:pPr indent="0" marL="0">
+              <a:buNone/>
+            </a:pPr>
+            <a:r>
+              <a:rPr lang="en-US" sz="1400" dirty="0">
+                <a:solidFill>
+                  <a:srgbClr val="635BFF"/>
+                </a:solidFill>
+                <a:latin typeface="Verdana" pitchFamily="34" charset="0"/>
+                <a:ea typeface="Verdana" pitchFamily="34" charset="-122"/>
+                <a:cs typeface="Verdana" pitchFamily="34" charset="-120"/>
+              </a:rPr>
+              <a:t>  (recommended)</a:t>
+            </a:r>
+            <a:endParaRPr lang="en-US" sz="1800" dirty="0"/>
+          </a:p>
+          <a:p>
+            <a:pPr indent="0" marL="0">
+              <a:buNone/>
+            </a:pPr>
+            <a:r>
+              <a:rPr lang="en-US" sz="1600" dirty="0">
+                <a:solidFill>
+                  <a:srgbClr val="1A1F36"/>
+                </a:solidFill>
+                <a:latin typeface="Verdana" pitchFamily="34" charset="0"/>
+                <a:ea typeface="Verdana" pitchFamily="34" charset="-122"/>
+                <a:cs typeface="Verdana" pitchFamily="34" charset="-120"/>
+              </a:rPr>
+              <a:t>Langdock — German GmbH, Azure Frankfurt, EU residency by default, ~€23.20/user/month</a:t>
+            </a:r>
+            <a:endParaRPr lang="en-US" sz="1800" dirty="0"/>
+          </a:p>
+          <a:p>
+            <a:pPr indent="0" marL="0">
+              <a:buNone/>
+            </a:pPr>
+            <a:endParaRPr lang="en-US" sz="1800" dirty="0"/>
+          </a:p>
+          <a:p>
+            <a:pPr indent="0" marL="0">
+              <a:buNone/>
+            </a:pPr>
+            <a:r>
+              <a:rPr lang="en-US" sz="1800" b="1" dirty="0">
+                <a:solidFill>
+                  <a:srgbClr val="1A1F36"/>
+                </a:solidFill>
+                <a:latin typeface="Verdana" pitchFamily="34" charset="0"/>
+                <a:ea typeface="Verdana" pitchFamily="34" charset="-122"/>
+                <a:cs typeface="Verdana" pitchFamily="34" charset="-120"/>
+              </a:rPr>
+              <a:t>B — Embedded AI</a:t>
+            </a:r>
+            <a:endParaRPr lang="en-US" sz="1800" dirty="0"/>
+          </a:p>
+          <a:p>
+            <a:pPr indent="0" marL="0">
+              <a:buNone/>
+            </a:pPr>
+            <a:r>
+              <a:rPr lang="en-US" sz="1600" dirty="0">
+                <a:solidFill>
+                  <a:srgbClr val="1A1F36"/>
+                </a:solidFill>
+                <a:latin typeface="Verdana" pitchFamily="34" charset="0"/>
+                <a:ea typeface="Verdana" pitchFamily="34" charset="-122"/>
+                <a:cs typeface="Verdana" pitchFamily="34" charset="-120"/>
+              </a:rPr>
+              <a:t>M365 Copilot (~$30/user/month, EU Data Boundary) · Workspace Gemini (native EU, CDPA)</a:t>
+            </a:r>
+            <a:endParaRPr lang="en-US" sz="1800" dirty="0"/>
+          </a:p>
+          <a:p>
+            <a:pPr indent="0" marL="0">
+              <a:buNone/>
+            </a:pPr>
+            <a:endParaRPr lang="en-US" sz="1800" dirty="0"/>
+          </a:p>
+          <a:p>
+            <a:pPr indent="0" marL="0">
+              <a:buNone/>
+            </a:pPr>
+            <a:r>
+              <a:rPr lang="en-US" sz="1800" b="1" dirty="0">
+                <a:solidFill>
+                  <a:srgbClr val="8B95A5"/>
+                </a:solidFill>
+                <a:latin typeface="Verdana" pitchFamily="34" charset="0"/>
+                <a:ea typeface="Verdana" pitchFamily="34" charset="-122"/>
+                <a:cs typeface="Verdana" pitchFamily="34" charset="-120"/>
+              </a:rPr>
+              <a:t>C — Direct provider</a:t>
+            </a:r>
+            <a:endParaRPr lang="en-US" sz="1800" dirty="0"/>
+          </a:p>
+          <a:p>
+            <a:pPr indent="0" marL="0">
+              <a:buNone/>
+            </a:pPr>
+            <a:r>
+              <a:rPr lang="en-US" sz="1600" dirty="0">
+                <a:solidFill>
+                  <a:srgbClr val="8B95A5"/>
+                </a:solidFill>
+                <a:latin typeface="Verdana" pitchFamily="34" charset="0"/>
+                <a:ea typeface="Verdana" pitchFamily="34" charset="-122"/>
+                <a:cs typeface="Verdana" pitchFamily="34" charset="-120"/>
+              </a:rPr>
+              <a:t>ChatGPT Enterprise (EU residency available) · Claude Team (DPA + EU SCCs, no EU residency)</a:t>
+            </a:r>
+            <a:endParaRPr lang="en-US" sz="1800" dirty="0"/>
+          </a:p>
+        </p:txBody>
+      </p:sp>
+      <p:sp>
+        <p:nvSpPr>
+          <p:cNvPr id="4" name="Shape 2"/>
+          <p:cNvSpPr/>
+          <p:nvPr/>
+        </p:nvSpPr>
+        <p:spPr>
+          <a:xfrm>
+            <a:off x="457200" y="4206240"/>
+            <a:ext cx="8229600" cy="0"/>
+          </a:xfrm>
+          <a:prstGeom prst="line">
+            <a:avLst/>
+          </a:prstGeom>
+          <a:noFill/>
+          <a:ln w="12700">
+            <a:solidFill>
+              <a:srgbClr val="8B95A5"/>
+            </a:solidFill>
+            <a:prstDash val="solid"/>
+          </a:ln>
+        </p:spPr>
+      </p:sp>
+      <p:sp>
+        <p:nvSpPr>
+          <p:cNvPr id="5" name="Text 3"/>
+          <p:cNvSpPr/>
+          <p:nvPr/>
+        </p:nvSpPr>
+        <p:spPr>
+          <a:xfrm>
+            <a:off x="457200" y="4297680"/>
+            <a:ext cx="8229600" cy="640080"/>
+          </a:xfrm>
+          <a:prstGeom prst="rect">
+            <a:avLst/>
+          </a:prstGeom>
+          <a:noFill/>
+          <a:ln/>
+        </p:spPr>
+        <p:txBody>
+          <a:bodyPr wrap="square" lIns="0" tIns="0" rIns="0" bIns="0" rtlCol="0" anchor="t"/>
+          <a:lstStyle/>
+          <a:p>
+            <a:pPr indent="0" marL="0">
+              <a:buNone/>
+            </a:pPr>
+            <a:r>
+              <a:rPr lang="en-US" sz="1400" dirty="0">
+                <a:solidFill>
+                  <a:srgbClr val="8B95A5"/>
+                </a:solidFill>
+                <a:latin typeface="Verdana" pitchFamily="34" charset="0"/>
+                <a:ea typeface="Verdana" pitchFamily="34" charset="-122"/>
+                <a:cs typeface="Verdana" pitchFamily="34" charset="-120"/>
+              </a:rPr>
+              <a:t>Non-EU: Claude Team or ChatGPT Business with DPA</a:t>
+            </a:r>
+            <a:endParaRPr lang="en-US" sz="1400" dirty="0"/>
+          </a:p>
+          <a:p>
+            <a:pPr indent="0" marL="0">
+              <a:buNone/>
+            </a:pPr>
+            <a:r>
+              <a:rPr lang="en-US" sz="1400" dirty="0">
+                <a:solidFill>
+                  <a:srgbClr val="8B95A5"/>
+                </a:solidFill>
+                <a:latin typeface="Verdana" pitchFamily="34" charset="0"/>
+                <a:ea typeface="Verdana" pitchFamily="34" charset="-122"/>
+                <a:cs typeface="Verdana" pitchFamily="34" charset="-120"/>
+              </a:rPr>
+              <a:t>Coding: Claude Code via Vertex/Bedrock in EU region · GitHub Copilot Business</a:t>
+            </a:r>
+            <a:endParaRPr lang="en-US" sz="1400" dirty="0"/>
           </a:p>
         </p:txBody>
       </p:sp>
@@ -11501,8 +11710,8 @@
         </p:nvSpPr>
         <p:spPr>
           <a:xfrm>
-            <a:off x="457200" y="228600"/>
-            <a:ext cx="6400800" cy="548640"/>
+            <a:off x="914400" y="731520"/>
+            <a:ext cx="7315200" cy="2560320"/>
           </a:xfrm>
           <a:prstGeom prst="rect">
             <a:avLst/>
@@ -11514,382 +11723,38 @@
           <a:bodyPr wrap="square" lIns="0" tIns="0" rIns="0" bIns="0" rtlCol="0" anchor="ctr"/>
           <a:lstStyle/>
           <a:p>
-            <a:pPr indent="0" marL="0">
-              <a:buNone/>
-            </a:pPr>
-            <a:r>
-              <a:rPr lang="en-US" sz="3400" b="1" dirty="0">
-                <a:solidFill>
-                  <a:srgbClr val="FFFFFF"/>
+            <a:pPr algn="ctr" indent="0" marL="0">
+              <a:buNone/>
+            </a:pPr>
+            <a:r>
+              <a:rPr lang="en-US" sz="4400" b="1" dirty="0">
+                <a:solidFill>
+                  <a:srgbClr val="FF6B8A"/>
                 </a:solidFill>
                 <a:latin typeface="Georgia" pitchFamily="34" charset="0"/>
                 <a:ea typeface="Georgia" pitchFamily="34" charset="-122"/>
                 <a:cs typeface="Georgia" pitchFamily="34" charset="-120"/>
               </a:rPr>
-              <a:t>What your AI policy needs</a:t>
-            </a:r>
-            <a:endParaRPr lang="en-US" sz="3400" dirty="0"/>
-          </a:p>
-        </p:txBody>
-      </p:sp>
-      <p:sp>
-        <p:nvSpPr>
-          <p:cNvPr id="4" name="Text 2"/>
-          <p:cNvSpPr/>
-          <p:nvPr/>
-        </p:nvSpPr>
-        <p:spPr>
-          <a:xfrm>
-            <a:off x="457200" y="868680"/>
-            <a:ext cx="6400800" cy="320040"/>
-          </a:xfrm>
-          <a:prstGeom prst="rect">
-            <a:avLst/>
-          </a:prstGeom>
-          <a:noFill/>
-          <a:ln/>
-        </p:spPr>
-        <p:txBody>
-          <a:bodyPr wrap="square" lIns="0" tIns="0" rIns="0" bIns="0" rtlCol="0" anchor="ctr"/>
-          <a:lstStyle/>
-          <a:p>
-            <a:pPr indent="0" marL="0">
-              <a:buNone/>
-            </a:pPr>
-            <a:r>
-              <a:rPr lang="en-US" sz="1400" i="1" dirty="0">
-                <a:solidFill>
-                  <a:srgbClr val="635BFF"/>
-                </a:solidFill>
-                <a:latin typeface="Verdana" pitchFamily="34" charset="0"/>
-                <a:ea typeface="Verdana" pitchFamily="34" charset="-122"/>
-                <a:cs typeface="Verdana" pitchFamily="34" charset="-120"/>
-              </a:rPr>
-              <a:t>A starting point — adapt with your legal team</a:t>
-            </a:r>
-            <a:endParaRPr lang="en-US" sz="1400" dirty="0"/>
-          </a:p>
-        </p:txBody>
-      </p:sp>
-      <p:sp>
-        <p:nvSpPr>
-          <p:cNvPr id="5" name="Text 3"/>
-          <p:cNvSpPr/>
-          <p:nvPr/>
-        </p:nvSpPr>
-        <p:spPr>
-          <a:xfrm>
-            <a:off x="640080" y="1280160"/>
-            <a:ext cx="7863840" cy="3566160"/>
-          </a:xfrm>
-          <a:prstGeom prst="rect">
-            <a:avLst/>
-          </a:prstGeom>
-          <a:noFill/>
-          <a:ln/>
-        </p:spPr>
-        <p:txBody>
-          <a:bodyPr wrap="square" lIns="0" tIns="0" rIns="0" bIns="0" rtlCol="0" anchor="t"/>
-          <a:lstStyle/>
-          <a:p>
-            <a:pPr indent="0" marL="0">
-              <a:buNone/>
-            </a:pPr>
-            <a:r>
-              <a:rPr lang="en-US" sz="1600" b="1" dirty="0">
-                <a:solidFill>
-                  <a:srgbClr val="635BFF"/>
-                </a:solidFill>
-                <a:latin typeface="Verdana" pitchFamily="34" charset="0"/>
-                <a:ea typeface="Verdana" pitchFamily="34" charset="-122"/>
-                <a:cs typeface="Verdana" pitchFamily="34" charset="-120"/>
-              </a:rPr>
-              <a:t>1  </a:t>
-            </a:r>
-            <a:pPr indent="0" marL="0">
-              <a:buNone/>
-            </a:pPr>
-            <a:r>
-              <a:rPr lang="en-US" sz="1500" b="1" dirty="0">
-                <a:solidFill>
-                  <a:srgbClr val="FFFFFF"/>
-                </a:solidFill>
-                <a:latin typeface="Verdana" pitchFamily="34" charset="0"/>
-                <a:ea typeface="Verdana" pitchFamily="34" charset="-122"/>
-                <a:cs typeface="Verdana" pitchFamily="34" charset="-120"/>
-              </a:rPr>
-              <a:t>Approved tools list</a:t>
-            </a:r>
-            <a:pPr indent="0" marL="0">
-              <a:buNone/>
-            </a:pPr>
-            <a:r>
-              <a:rPr lang="en-US" sz="1300" dirty="0">
-                <a:solidFill>
-                  <a:srgbClr val="8B95A5"/>
-                </a:solidFill>
-                <a:latin typeface="Verdana" pitchFamily="34" charset="0"/>
-                <a:ea typeface="Verdana" pitchFamily="34" charset="-122"/>
-                <a:cs typeface="Verdana" pitchFamily="34" charset="-120"/>
-              </a:rPr>
-              <a:t>  Which tools, which tiers. Living document.</a:t>
-            </a:r>
-            <a:endParaRPr lang="en-US" sz="1600" dirty="0"/>
-          </a:p>
-          <a:p>
-            <a:pPr indent="0" marL="0">
-              <a:buNone/>
-            </a:pPr>
-            <a:endParaRPr lang="en-US" sz="1600" dirty="0"/>
-          </a:p>
-          <a:p>
-            <a:pPr indent="0" marL="0">
-              <a:buNone/>
-            </a:pPr>
-            <a:r>
-              <a:rPr lang="en-US" sz="1600" b="1" dirty="0">
-                <a:solidFill>
-                  <a:srgbClr val="635BFF"/>
-                </a:solidFill>
-                <a:latin typeface="Verdana" pitchFamily="34" charset="0"/>
-                <a:ea typeface="Verdana" pitchFamily="34" charset="-122"/>
-                <a:cs typeface="Verdana" pitchFamily="34" charset="-120"/>
-              </a:rPr>
-              <a:t>2  </a:t>
-            </a:r>
-            <a:pPr indent="0" marL="0">
-              <a:buNone/>
-            </a:pPr>
-            <a:r>
-              <a:rPr lang="en-US" sz="1500" b="1" dirty="0">
-                <a:solidFill>
-                  <a:srgbClr val="FFFFFF"/>
-                </a:solidFill>
-                <a:latin typeface="Verdana" pitchFamily="34" charset="0"/>
-                <a:ea typeface="Verdana" pitchFamily="34" charset="-122"/>
-                <a:cs typeface="Verdana" pitchFamily="34" charset="-120"/>
-              </a:rPr>
-              <a:t>Data classification</a:t>
-            </a:r>
-            <a:pPr indent="0" marL="0">
-              <a:buNone/>
-            </a:pPr>
-            <a:r>
-              <a:rPr lang="en-US" sz="1300" dirty="0">
-                <a:solidFill>
-                  <a:srgbClr val="8B95A5"/>
-                </a:solidFill>
-                <a:latin typeface="Verdana" pitchFamily="34" charset="0"/>
-                <a:ea typeface="Verdana" pitchFamily="34" charset="-122"/>
-                <a:cs typeface="Verdana" pitchFamily="34" charset="-120"/>
-              </a:rPr>
-              <a:t>  What can vs cannot go into AI tools.</a:t>
-            </a:r>
-            <a:endParaRPr lang="en-US" sz="1600" dirty="0"/>
-          </a:p>
-          <a:p>
-            <a:pPr indent="0" marL="0">
-              <a:buNone/>
-            </a:pPr>
-            <a:endParaRPr lang="en-US" sz="1600" dirty="0"/>
-          </a:p>
-          <a:p>
-            <a:pPr indent="0" marL="0">
-              <a:buNone/>
-            </a:pPr>
-            <a:r>
-              <a:rPr lang="en-US" sz="1600" b="1" dirty="0">
-                <a:solidFill>
-                  <a:srgbClr val="635BFF"/>
-                </a:solidFill>
-                <a:latin typeface="Verdana" pitchFamily="34" charset="0"/>
-                <a:ea typeface="Verdana" pitchFamily="34" charset="-122"/>
-                <a:cs typeface="Verdana" pitchFamily="34" charset="-120"/>
-              </a:rPr>
-              <a:t>3  </a:t>
-            </a:r>
-            <a:pPr indent="0" marL="0">
-              <a:buNone/>
-            </a:pPr>
-            <a:r>
-              <a:rPr lang="en-US" sz="1500" b="1" dirty="0">
-                <a:solidFill>
-                  <a:srgbClr val="FFFFFF"/>
-                </a:solidFill>
-                <a:latin typeface="Verdana" pitchFamily="34" charset="0"/>
-                <a:ea typeface="Verdana" pitchFamily="34" charset="-122"/>
-                <a:cs typeface="Verdana" pitchFamily="34" charset="-120"/>
-              </a:rPr>
-              <a:t>The two-path rule</a:t>
-            </a:r>
-            <a:pPr indent="0" marL="0">
-              <a:buNone/>
-            </a:pPr>
-            <a:r>
-              <a:rPr lang="en-US" sz="1300" dirty="0">
-                <a:solidFill>
-                  <a:srgbClr val="8B95A5"/>
-                </a:solidFill>
-                <a:latin typeface="Verdana" pitchFamily="34" charset="0"/>
-                <a:ea typeface="Verdana" pitchFamily="34" charset="-122"/>
-                <a:cs typeface="Verdana" pitchFamily="34" charset="-120"/>
-              </a:rPr>
-              <a:t>  General work vs PII-safe setup.</a:t>
-            </a:r>
-            <a:endParaRPr lang="en-US" sz="1600" dirty="0"/>
-          </a:p>
-          <a:p>
-            <a:pPr indent="0" marL="0">
-              <a:buNone/>
-            </a:pPr>
-            <a:endParaRPr lang="en-US" sz="1600" dirty="0"/>
-          </a:p>
-          <a:p>
-            <a:pPr indent="0" marL="0">
-              <a:buNone/>
-            </a:pPr>
-            <a:r>
-              <a:rPr lang="en-US" sz="1600" b="1" dirty="0">
-                <a:solidFill>
-                  <a:srgbClr val="635BFF"/>
-                </a:solidFill>
-                <a:latin typeface="Verdana" pitchFamily="34" charset="0"/>
-                <a:ea typeface="Verdana" pitchFamily="34" charset="-122"/>
-                <a:cs typeface="Verdana" pitchFamily="34" charset="-120"/>
-              </a:rPr>
-              <a:t>4  </a:t>
-            </a:r>
-            <a:pPr indent="0" marL="0">
-              <a:buNone/>
-            </a:pPr>
-            <a:r>
-              <a:rPr lang="en-US" sz="1500" b="1" dirty="0">
-                <a:solidFill>
-                  <a:srgbClr val="FFFFFF"/>
-                </a:solidFill>
-                <a:latin typeface="Verdana" pitchFamily="34" charset="0"/>
-                <a:ea typeface="Verdana" pitchFamily="34" charset="-122"/>
-                <a:cs typeface="Verdana" pitchFamily="34" charset="-120"/>
-              </a:rPr>
-              <a:t>Incident reporting</a:t>
-            </a:r>
-            <a:pPr indent="0" marL="0">
-              <a:buNone/>
-            </a:pPr>
-            <a:r>
-              <a:rPr lang="en-US" sz="1300" dirty="0">
-                <a:solidFill>
-                  <a:srgbClr val="8B95A5"/>
-                </a:solidFill>
-                <a:latin typeface="Verdana" pitchFamily="34" charset="0"/>
-                <a:ea typeface="Verdana" pitchFamily="34" charset="-122"/>
-                <a:cs typeface="Verdana" pitchFamily="34" charset="-120"/>
-              </a:rPr>
-              <a:t>  PII in unapproved tool = potential breach. 72-hour notification.</a:t>
-            </a:r>
-            <a:endParaRPr lang="en-US" sz="1600" dirty="0"/>
-          </a:p>
-          <a:p>
-            <a:pPr indent="0" marL="0">
-              <a:buNone/>
-            </a:pPr>
-            <a:endParaRPr lang="en-US" sz="1600" dirty="0"/>
-          </a:p>
-          <a:p>
-            <a:pPr indent="0" marL="0">
-              <a:buNone/>
-            </a:pPr>
-            <a:r>
-              <a:rPr lang="en-US" sz="1600" b="1" dirty="0">
-                <a:solidFill>
-                  <a:srgbClr val="635BFF"/>
-                </a:solidFill>
-                <a:latin typeface="Verdana" pitchFamily="34" charset="0"/>
-                <a:ea typeface="Verdana" pitchFamily="34" charset="-122"/>
-                <a:cs typeface="Verdana" pitchFamily="34" charset="-120"/>
-              </a:rPr>
-              <a:t>5  </a:t>
-            </a:r>
-            <a:pPr indent="0" marL="0">
-              <a:buNone/>
-            </a:pPr>
-            <a:r>
-              <a:rPr lang="en-US" sz="1500" b="1" dirty="0">
-                <a:solidFill>
-                  <a:srgbClr val="FFFFFF"/>
-                </a:solidFill>
-                <a:latin typeface="Verdana" pitchFamily="34" charset="0"/>
-                <a:ea typeface="Verdana" pitchFamily="34" charset="-122"/>
-                <a:cs typeface="Verdana" pitchFamily="34" charset="-120"/>
-              </a:rPr>
-              <a:t>AI literacy training</a:t>
-            </a:r>
-            <a:pPr indent="0" marL="0">
-              <a:buNone/>
-            </a:pPr>
-            <a:r>
-              <a:rPr lang="en-US" sz="1300" dirty="0">
-                <a:solidFill>
-                  <a:srgbClr val="8B95A5"/>
-                </a:solidFill>
-                <a:latin typeface="Verdana" pitchFamily="34" charset="0"/>
-                <a:ea typeface="Verdana" pitchFamily="34" charset="-122"/>
-                <a:cs typeface="Verdana" pitchFamily="34" charset="-120"/>
-              </a:rPr>
-              <a:t>  EU AI Act Article 4. Legal requirement.</a:t>
-            </a:r>
-            <a:endParaRPr lang="en-US" sz="1600" dirty="0"/>
-          </a:p>
-          <a:p>
-            <a:pPr indent="0" marL="0">
-              <a:buNone/>
-            </a:pPr>
-            <a:endParaRPr lang="en-US" sz="1600" dirty="0"/>
-          </a:p>
-          <a:p>
-            <a:pPr indent="0" marL="0">
-              <a:buNone/>
-            </a:pPr>
-            <a:r>
-              <a:rPr lang="en-US" sz="1600" b="1" dirty="0">
-                <a:solidFill>
-                  <a:srgbClr val="635BFF"/>
-                </a:solidFill>
-                <a:latin typeface="Verdana" pitchFamily="34" charset="0"/>
-                <a:ea typeface="Verdana" pitchFamily="34" charset="-122"/>
-                <a:cs typeface="Verdana" pitchFamily="34" charset="-120"/>
-              </a:rPr>
-              <a:t>6  </a:t>
-            </a:r>
-            <a:pPr indent="0" marL="0">
-              <a:buNone/>
-            </a:pPr>
-            <a:r>
-              <a:rPr lang="en-US" sz="1500" b="1" dirty="0">
-                <a:solidFill>
-                  <a:srgbClr val="FFFFFF"/>
-                </a:solidFill>
-                <a:latin typeface="Verdana" pitchFamily="34" charset="0"/>
-                <a:ea typeface="Verdana" pitchFamily="34" charset="-122"/>
-                <a:cs typeface="Verdana" pitchFamily="34" charset="-120"/>
-              </a:rPr>
-              <a:t>Roles &amp; responsibilities</a:t>
-            </a:r>
-            <a:pPr indent="0" marL="0">
-              <a:buNone/>
-            </a:pPr>
-            <a:r>
-              <a:rPr lang="en-US" sz="1300" dirty="0">
-                <a:solidFill>
-                  <a:srgbClr val="8B95A5"/>
-                </a:solidFill>
-                <a:latin typeface="Verdana" pitchFamily="34" charset="0"/>
-                <a:ea typeface="Verdana" pitchFamily="34" charset="-122"/>
-                <a:cs typeface="Verdana" pitchFamily="34" charset="-120"/>
-              </a:rPr>
-              <a:t>  Who approves, monitors, responds.</a:t>
-            </a:r>
-            <a:endParaRPr lang="en-US" sz="1600" dirty="0"/>
+              <a:t>Free tiers are not approved</a:t>
+            </a:r>
+            <a:endParaRPr lang="en-US" sz="4400" dirty="0"/>
+          </a:p>
+          <a:p>
+            <a:pPr algn="ctr" indent="0" marL="0">
+              <a:buNone/>
+            </a:pPr>
+            <a:r>
+              <a:rPr lang="en-US" sz="4400" b="1" dirty="0">
+                <a:solidFill>
+                  <a:srgbClr val="FF6B8A"/>
+                </a:solidFill>
+                <a:latin typeface="Georgia" pitchFamily="34" charset="0"/>
+                <a:ea typeface="Georgia" pitchFamily="34" charset="-122"/>
+                <a:cs typeface="Georgia" pitchFamily="34" charset="-120"/>
+              </a:rPr>
+              <a:t>for work. Full stop.</a:t>
+            </a:r>
+            <a:endParaRPr lang="en-US" sz="4400" dirty="0"/>
           </a:p>
         </p:txBody>
       </p:sp>
@@ -11955,8 +11820,8 @@
         </p:nvSpPr>
         <p:spPr>
           <a:xfrm>
-            <a:off x="1371600" y="1828800"/>
-            <a:ext cx="6400800" cy="1463040"/>
+            <a:off x="457200" y="228600"/>
+            <a:ext cx="6400800" cy="548640"/>
           </a:xfrm>
           <a:prstGeom prst="rect">
             <a:avLst/>
@@ -11968,21 +11833,382 @@
           <a:bodyPr wrap="square" lIns="0" tIns="0" rIns="0" bIns="0" rtlCol="0" anchor="ctr"/>
           <a:lstStyle/>
           <a:p>
-            <a:pPr algn="ctr" indent="0" marL="0">
-              <a:buNone/>
-            </a:pPr>
-            <a:r>
-              <a:rPr lang="en-US" sz="2800" i="1" dirty="0">
-                <a:solidFill>
-                  <a:srgbClr val="635BFF"/>
+            <a:pPr indent="0" marL="0">
+              <a:buNone/>
+            </a:pPr>
+            <a:r>
+              <a:rPr lang="en-US" sz="3400" b="1" dirty="0">
+                <a:solidFill>
+                  <a:srgbClr val="FFFFFF"/>
                 </a:solidFill>
                 <a:latin typeface="Georgia" pitchFamily="34" charset="0"/>
                 <a:ea typeface="Georgia" pitchFamily="34" charset="-122"/>
                 <a:cs typeface="Georgia" pitchFamily="34" charset="-120"/>
               </a:rPr>
-              <a:t>And remember...</a:t>
-            </a:r>
-            <a:endParaRPr lang="en-US" sz="2800" dirty="0"/>
+              <a:t>What your AI policy needs</a:t>
+            </a:r>
+            <a:endParaRPr lang="en-US" sz="3400" dirty="0"/>
+          </a:p>
+        </p:txBody>
+      </p:sp>
+      <p:sp>
+        <p:nvSpPr>
+          <p:cNvPr id="4" name="Text 2"/>
+          <p:cNvSpPr/>
+          <p:nvPr/>
+        </p:nvSpPr>
+        <p:spPr>
+          <a:xfrm>
+            <a:off x="457200" y="868680"/>
+            <a:ext cx="6400800" cy="320040"/>
+          </a:xfrm>
+          <a:prstGeom prst="rect">
+            <a:avLst/>
+          </a:prstGeom>
+          <a:noFill/>
+          <a:ln/>
+        </p:spPr>
+        <p:txBody>
+          <a:bodyPr wrap="square" lIns="0" tIns="0" rIns="0" bIns="0" rtlCol="0" anchor="ctr"/>
+          <a:lstStyle/>
+          <a:p>
+            <a:pPr indent="0" marL="0">
+              <a:buNone/>
+            </a:pPr>
+            <a:r>
+              <a:rPr lang="en-US" sz="1400" i="1" dirty="0">
+                <a:solidFill>
+                  <a:srgbClr val="635BFF"/>
+                </a:solidFill>
+                <a:latin typeface="Verdana" pitchFamily="34" charset="0"/>
+                <a:ea typeface="Verdana" pitchFamily="34" charset="-122"/>
+                <a:cs typeface="Verdana" pitchFamily="34" charset="-120"/>
+              </a:rPr>
+              <a:t>A starting point — adapt with your legal team</a:t>
+            </a:r>
+            <a:endParaRPr lang="en-US" sz="1400" dirty="0"/>
+          </a:p>
+        </p:txBody>
+      </p:sp>
+      <p:sp>
+        <p:nvSpPr>
+          <p:cNvPr id="5" name="Text 3"/>
+          <p:cNvSpPr/>
+          <p:nvPr/>
+        </p:nvSpPr>
+        <p:spPr>
+          <a:xfrm>
+            <a:off x="640080" y="1280160"/>
+            <a:ext cx="7863840" cy="3566160"/>
+          </a:xfrm>
+          <a:prstGeom prst="rect">
+            <a:avLst/>
+          </a:prstGeom>
+          <a:noFill/>
+          <a:ln/>
+        </p:spPr>
+        <p:txBody>
+          <a:bodyPr wrap="square" lIns="0" tIns="0" rIns="0" bIns="0" rtlCol="0" anchor="t"/>
+          <a:lstStyle/>
+          <a:p>
+            <a:pPr indent="0" marL="0">
+              <a:buNone/>
+            </a:pPr>
+            <a:r>
+              <a:rPr lang="en-US" sz="1600" b="1" dirty="0">
+                <a:solidFill>
+                  <a:srgbClr val="635BFF"/>
+                </a:solidFill>
+                <a:latin typeface="Verdana" pitchFamily="34" charset="0"/>
+                <a:ea typeface="Verdana" pitchFamily="34" charset="-122"/>
+                <a:cs typeface="Verdana" pitchFamily="34" charset="-120"/>
+              </a:rPr>
+              <a:t>1  </a:t>
+            </a:r>
+            <a:pPr indent="0" marL="0">
+              <a:buNone/>
+            </a:pPr>
+            <a:r>
+              <a:rPr lang="en-US" sz="1500" b="1" dirty="0">
+                <a:solidFill>
+                  <a:srgbClr val="FFFFFF"/>
+                </a:solidFill>
+                <a:latin typeface="Verdana" pitchFamily="34" charset="0"/>
+                <a:ea typeface="Verdana" pitchFamily="34" charset="-122"/>
+                <a:cs typeface="Verdana" pitchFamily="34" charset="-120"/>
+              </a:rPr>
+              <a:t>Approved tools list</a:t>
+            </a:r>
+            <a:pPr indent="0" marL="0">
+              <a:buNone/>
+            </a:pPr>
+            <a:r>
+              <a:rPr lang="en-US" sz="1300" dirty="0">
+                <a:solidFill>
+                  <a:srgbClr val="8B95A5"/>
+                </a:solidFill>
+                <a:latin typeface="Verdana" pitchFamily="34" charset="0"/>
+                <a:ea typeface="Verdana" pitchFamily="34" charset="-122"/>
+                <a:cs typeface="Verdana" pitchFamily="34" charset="-120"/>
+              </a:rPr>
+              <a:t>  Which tools, which tiers. Living document.</a:t>
+            </a:r>
+            <a:endParaRPr lang="en-US" sz="1600" dirty="0"/>
+          </a:p>
+          <a:p>
+            <a:pPr indent="0" marL="0">
+              <a:buNone/>
+            </a:pPr>
+            <a:endParaRPr lang="en-US" sz="1600" dirty="0"/>
+          </a:p>
+          <a:p>
+            <a:pPr indent="0" marL="0">
+              <a:buNone/>
+            </a:pPr>
+            <a:r>
+              <a:rPr lang="en-US" sz="1600" b="1" dirty="0">
+                <a:solidFill>
+                  <a:srgbClr val="635BFF"/>
+                </a:solidFill>
+                <a:latin typeface="Verdana" pitchFamily="34" charset="0"/>
+                <a:ea typeface="Verdana" pitchFamily="34" charset="-122"/>
+                <a:cs typeface="Verdana" pitchFamily="34" charset="-120"/>
+              </a:rPr>
+              <a:t>2  </a:t>
+            </a:r>
+            <a:pPr indent="0" marL="0">
+              <a:buNone/>
+            </a:pPr>
+            <a:r>
+              <a:rPr lang="en-US" sz="1500" b="1" dirty="0">
+                <a:solidFill>
+                  <a:srgbClr val="FFFFFF"/>
+                </a:solidFill>
+                <a:latin typeface="Verdana" pitchFamily="34" charset="0"/>
+                <a:ea typeface="Verdana" pitchFamily="34" charset="-122"/>
+                <a:cs typeface="Verdana" pitchFamily="34" charset="-120"/>
+              </a:rPr>
+              <a:t>Data classification</a:t>
+            </a:r>
+            <a:pPr indent="0" marL="0">
+              <a:buNone/>
+            </a:pPr>
+            <a:r>
+              <a:rPr lang="en-US" sz="1300" dirty="0">
+                <a:solidFill>
+                  <a:srgbClr val="8B95A5"/>
+                </a:solidFill>
+                <a:latin typeface="Verdana" pitchFamily="34" charset="0"/>
+                <a:ea typeface="Verdana" pitchFamily="34" charset="-122"/>
+                <a:cs typeface="Verdana" pitchFamily="34" charset="-120"/>
+              </a:rPr>
+              <a:t>  What can vs cannot go into AI tools.</a:t>
+            </a:r>
+            <a:endParaRPr lang="en-US" sz="1600" dirty="0"/>
+          </a:p>
+          <a:p>
+            <a:pPr indent="0" marL="0">
+              <a:buNone/>
+            </a:pPr>
+            <a:endParaRPr lang="en-US" sz="1600" dirty="0"/>
+          </a:p>
+          <a:p>
+            <a:pPr indent="0" marL="0">
+              <a:buNone/>
+            </a:pPr>
+            <a:r>
+              <a:rPr lang="en-US" sz="1600" b="1" dirty="0">
+                <a:solidFill>
+                  <a:srgbClr val="635BFF"/>
+                </a:solidFill>
+                <a:latin typeface="Verdana" pitchFamily="34" charset="0"/>
+                <a:ea typeface="Verdana" pitchFamily="34" charset="-122"/>
+                <a:cs typeface="Verdana" pitchFamily="34" charset="-120"/>
+              </a:rPr>
+              <a:t>3  </a:t>
+            </a:r>
+            <a:pPr indent="0" marL="0">
+              <a:buNone/>
+            </a:pPr>
+            <a:r>
+              <a:rPr lang="en-US" sz="1500" b="1" dirty="0">
+                <a:solidFill>
+                  <a:srgbClr val="FFFFFF"/>
+                </a:solidFill>
+                <a:latin typeface="Verdana" pitchFamily="34" charset="0"/>
+                <a:ea typeface="Verdana" pitchFamily="34" charset="-122"/>
+                <a:cs typeface="Verdana" pitchFamily="34" charset="-120"/>
+              </a:rPr>
+              <a:t>The two-path rule</a:t>
+            </a:r>
+            <a:pPr indent="0" marL="0">
+              <a:buNone/>
+            </a:pPr>
+            <a:r>
+              <a:rPr lang="en-US" sz="1300" dirty="0">
+                <a:solidFill>
+                  <a:srgbClr val="8B95A5"/>
+                </a:solidFill>
+                <a:latin typeface="Verdana" pitchFamily="34" charset="0"/>
+                <a:ea typeface="Verdana" pitchFamily="34" charset="-122"/>
+                <a:cs typeface="Verdana" pitchFamily="34" charset="-120"/>
+              </a:rPr>
+              <a:t>  General work vs PII-safe setup.</a:t>
+            </a:r>
+            <a:endParaRPr lang="en-US" sz="1600" dirty="0"/>
+          </a:p>
+          <a:p>
+            <a:pPr indent="0" marL="0">
+              <a:buNone/>
+            </a:pPr>
+            <a:endParaRPr lang="en-US" sz="1600" dirty="0"/>
+          </a:p>
+          <a:p>
+            <a:pPr indent="0" marL="0">
+              <a:buNone/>
+            </a:pPr>
+            <a:r>
+              <a:rPr lang="en-US" sz="1600" b="1" dirty="0">
+                <a:solidFill>
+                  <a:srgbClr val="635BFF"/>
+                </a:solidFill>
+                <a:latin typeface="Verdana" pitchFamily="34" charset="0"/>
+                <a:ea typeface="Verdana" pitchFamily="34" charset="-122"/>
+                <a:cs typeface="Verdana" pitchFamily="34" charset="-120"/>
+              </a:rPr>
+              <a:t>4  </a:t>
+            </a:r>
+            <a:pPr indent="0" marL="0">
+              <a:buNone/>
+            </a:pPr>
+            <a:r>
+              <a:rPr lang="en-US" sz="1500" b="1" dirty="0">
+                <a:solidFill>
+                  <a:srgbClr val="FFFFFF"/>
+                </a:solidFill>
+                <a:latin typeface="Verdana" pitchFamily="34" charset="0"/>
+                <a:ea typeface="Verdana" pitchFamily="34" charset="-122"/>
+                <a:cs typeface="Verdana" pitchFamily="34" charset="-120"/>
+              </a:rPr>
+              <a:t>Incident reporting</a:t>
+            </a:r>
+            <a:pPr indent="0" marL="0">
+              <a:buNone/>
+            </a:pPr>
+            <a:r>
+              <a:rPr lang="en-US" sz="1300" dirty="0">
+                <a:solidFill>
+                  <a:srgbClr val="8B95A5"/>
+                </a:solidFill>
+                <a:latin typeface="Verdana" pitchFamily="34" charset="0"/>
+                <a:ea typeface="Verdana" pitchFamily="34" charset="-122"/>
+                <a:cs typeface="Verdana" pitchFamily="34" charset="-120"/>
+              </a:rPr>
+              <a:t>  PII in unapproved tool = potential breach. 72-hour notification.</a:t>
+            </a:r>
+            <a:endParaRPr lang="en-US" sz="1600" dirty="0"/>
+          </a:p>
+          <a:p>
+            <a:pPr indent="0" marL="0">
+              <a:buNone/>
+            </a:pPr>
+            <a:endParaRPr lang="en-US" sz="1600" dirty="0"/>
+          </a:p>
+          <a:p>
+            <a:pPr indent="0" marL="0">
+              <a:buNone/>
+            </a:pPr>
+            <a:r>
+              <a:rPr lang="en-US" sz="1600" b="1" dirty="0">
+                <a:solidFill>
+                  <a:srgbClr val="635BFF"/>
+                </a:solidFill>
+                <a:latin typeface="Verdana" pitchFamily="34" charset="0"/>
+                <a:ea typeface="Verdana" pitchFamily="34" charset="-122"/>
+                <a:cs typeface="Verdana" pitchFamily="34" charset="-120"/>
+              </a:rPr>
+              <a:t>5  </a:t>
+            </a:r>
+            <a:pPr indent="0" marL="0">
+              <a:buNone/>
+            </a:pPr>
+            <a:r>
+              <a:rPr lang="en-US" sz="1500" b="1" dirty="0">
+                <a:solidFill>
+                  <a:srgbClr val="FFFFFF"/>
+                </a:solidFill>
+                <a:latin typeface="Verdana" pitchFamily="34" charset="0"/>
+                <a:ea typeface="Verdana" pitchFamily="34" charset="-122"/>
+                <a:cs typeface="Verdana" pitchFamily="34" charset="-120"/>
+              </a:rPr>
+              <a:t>AI literacy training</a:t>
+            </a:r>
+            <a:pPr indent="0" marL="0">
+              <a:buNone/>
+            </a:pPr>
+            <a:r>
+              <a:rPr lang="en-US" sz="1300" dirty="0">
+                <a:solidFill>
+                  <a:srgbClr val="8B95A5"/>
+                </a:solidFill>
+                <a:latin typeface="Verdana" pitchFamily="34" charset="0"/>
+                <a:ea typeface="Verdana" pitchFamily="34" charset="-122"/>
+                <a:cs typeface="Verdana" pitchFamily="34" charset="-120"/>
+              </a:rPr>
+              <a:t>  EU AI Act Article 4. Legal requirement.</a:t>
+            </a:r>
+            <a:endParaRPr lang="en-US" sz="1600" dirty="0"/>
+          </a:p>
+          <a:p>
+            <a:pPr indent="0" marL="0">
+              <a:buNone/>
+            </a:pPr>
+            <a:endParaRPr lang="en-US" sz="1600" dirty="0"/>
+          </a:p>
+          <a:p>
+            <a:pPr indent="0" marL="0">
+              <a:buNone/>
+            </a:pPr>
+            <a:r>
+              <a:rPr lang="en-US" sz="1600" b="1" dirty="0">
+                <a:solidFill>
+                  <a:srgbClr val="635BFF"/>
+                </a:solidFill>
+                <a:latin typeface="Verdana" pitchFamily="34" charset="0"/>
+                <a:ea typeface="Verdana" pitchFamily="34" charset="-122"/>
+                <a:cs typeface="Verdana" pitchFamily="34" charset="-120"/>
+              </a:rPr>
+              <a:t>6  </a:t>
+            </a:r>
+            <a:pPr indent="0" marL="0">
+              <a:buNone/>
+            </a:pPr>
+            <a:r>
+              <a:rPr lang="en-US" sz="1500" b="1" dirty="0">
+                <a:solidFill>
+                  <a:srgbClr val="FFFFFF"/>
+                </a:solidFill>
+                <a:latin typeface="Verdana" pitchFamily="34" charset="0"/>
+                <a:ea typeface="Verdana" pitchFamily="34" charset="-122"/>
+                <a:cs typeface="Verdana" pitchFamily="34" charset="-120"/>
+              </a:rPr>
+              <a:t>Roles &amp; responsibilities</a:t>
+            </a:r>
+            <a:pPr indent="0" marL="0">
+              <a:buNone/>
+            </a:pPr>
+            <a:r>
+              <a:rPr lang="en-US" sz="1300" dirty="0">
+                <a:solidFill>
+                  <a:srgbClr val="8B95A5"/>
+                </a:solidFill>
+                <a:latin typeface="Verdana" pitchFamily="34" charset="0"/>
+                <a:ea typeface="Verdana" pitchFamily="34" charset="-122"/>
+                <a:cs typeface="Verdana" pitchFamily="34" charset="-120"/>
+              </a:rPr>
+              <a:t>  Who approves, monitors, responds.</a:t>
+            </a:r>
+            <a:endParaRPr lang="en-US" sz="1600" dirty="0"/>
           </a:p>
         </p:txBody>
       </p:sp>
@@ -12048,8 +12274,8 @@
         </p:nvSpPr>
         <p:spPr>
           <a:xfrm>
-            <a:off x="914400" y="731520"/>
-            <a:ext cx="7315200" cy="2560320"/>
+            <a:off x="1371600" y="1828800"/>
+            <a:ext cx="6400800" cy="1463040"/>
           </a:xfrm>
           <a:prstGeom prst="rect">
             <a:avLst/>
@@ -12065,68 +12291,17 @@
               <a:buNone/>
             </a:pPr>
             <a:r>
-              <a:rPr lang="en-US" sz="4000" b="1" dirty="0">
-                <a:solidFill>
-                  <a:srgbClr val="FFFFFF"/>
+              <a:rPr lang="en-US" sz="2800" i="1" dirty="0">
+                <a:solidFill>
+                  <a:srgbClr val="635BFF"/>
                 </a:solidFill>
                 <a:latin typeface="Georgia" pitchFamily="34" charset="0"/>
                 <a:ea typeface="Georgia" pitchFamily="34" charset="-122"/>
                 <a:cs typeface="Georgia" pitchFamily="34" charset="-120"/>
               </a:rPr>
-              <a:t>The gap between using AI safely</a:t>
-            </a:r>
-            <a:endParaRPr lang="en-US" sz="4000" dirty="0"/>
-          </a:p>
-          <a:p>
-            <a:pPr algn="ctr" indent="0" marL="0">
-              <a:buNone/>
-            </a:pPr>
-            <a:r>
-              <a:rPr lang="en-US" sz="4000" b="1" dirty="0">
-                <a:solidFill>
-                  <a:srgbClr val="FFFFFF"/>
-                </a:solidFill>
-                <a:latin typeface="Georgia" pitchFamily="34" charset="0"/>
-                <a:ea typeface="Georgia" pitchFamily="34" charset="-122"/>
-                <a:cs typeface="Georgia" pitchFamily="34" charset="-120"/>
-              </a:rPr>
-              <a:t>and using AI recklessly</a:t>
-            </a:r>
-            <a:endParaRPr lang="en-US" sz="4000" dirty="0"/>
-          </a:p>
-          <a:p>
-            <a:pPr algn="ctr" indent="0" marL="0">
-              <a:buNone/>
-            </a:pPr>
-            <a:r>
-              <a:rPr lang="en-US" sz="4000" b="1" dirty="0">
-                <a:solidFill>
-                  <a:srgbClr val="FFFFFF"/>
-                </a:solidFill>
-                <a:latin typeface="Georgia" pitchFamily="34" charset="0"/>
-                <a:ea typeface="Georgia" pitchFamily="34" charset="-122"/>
-                <a:cs typeface="Georgia" pitchFamily="34" charset="-120"/>
-              </a:rPr>
-              <a:t>isn’t about which model</a:t>
-            </a:r>
-            <a:endParaRPr lang="en-US" sz="4000" dirty="0"/>
-          </a:p>
-          <a:p>
-            <a:pPr algn="ctr" indent="0" marL="0">
-              <a:buNone/>
-            </a:pPr>
-            <a:r>
-              <a:rPr lang="en-US" sz="4000" b="1" dirty="0">
-                <a:solidFill>
-                  <a:srgbClr val="FFFFFF"/>
-                </a:solidFill>
-                <a:latin typeface="Georgia" pitchFamily="34" charset="0"/>
-                <a:ea typeface="Georgia" pitchFamily="34" charset="-122"/>
-                <a:cs typeface="Georgia" pitchFamily="34" charset="-120"/>
-              </a:rPr>
-              <a:t>is smartest.</a:t>
-            </a:r>
-            <a:endParaRPr lang="en-US" sz="4000" dirty="0"/>
+              <a:t>And remember...</a:t>
+            </a:r>
+            <a:endParaRPr lang="en-US" sz="2800" dirty="0"/>
           </a:p>
         </p:txBody>
       </p:sp>
@@ -12141,6 +12316,150 @@
 <file path=ppt/slides/slide33.xml><?xml version="1.0" encoding="utf-8"?>
 <p:sld xmlns:a="http://schemas.openxmlformats.org/drawingml/2006/main" xmlns:r="http://schemas.openxmlformats.org/officeDocument/2006/relationships" xmlns:p="http://schemas.openxmlformats.org/presentationml/2006/main">
   <p:cSld name="Slide 33">
+    <p:bg>
+      <p:bgPr>
+        <a:solidFill>
+          <a:srgbClr val="0A2540"/>
+        </a:solidFill>
+      </p:bgPr>
+    </p:bg>
+    <p:spTree>
+      <p:nvGrpSpPr>
+        <p:cNvPr id="1" name=""/>
+        <p:cNvGrpSpPr/>
+        <p:nvPr/>
+      </p:nvGrpSpPr>
+      <p:grpSpPr>
+        <a:xfrm>
+          <a:off x="0" y="0"/>
+          <a:ext cx="0" cy="0"/>
+          <a:chOff x="0" y="0"/>
+          <a:chExt cx="0" cy="0"/>
+        </a:xfrm>
+      </p:grpSpPr>
+      <p:sp>
+        <p:nvSpPr>
+          <p:cNvPr id="2" name="Shape 0"/>
+          <p:cNvSpPr/>
+          <p:nvPr/>
+        </p:nvSpPr>
+        <p:spPr>
+          <a:xfrm>
+            <a:off x="4572000" y="2286000"/>
+            <a:ext cx="7315200" cy="5486400"/>
+          </a:xfrm>
+          <a:prstGeom prst="ellipse">
+            <a:avLst/>
+          </a:prstGeom>
+          <a:solidFill>
+            <a:srgbClr val="635BFF">
+              <a:alpha val="4000"/>
+            </a:srgbClr>
+          </a:solidFill>
+          <a:ln/>
+        </p:spPr>
+      </p:sp>
+      <p:sp>
+        <p:nvSpPr>
+          <p:cNvPr id="3" name="Text 1"/>
+          <p:cNvSpPr/>
+          <p:nvPr/>
+        </p:nvSpPr>
+        <p:spPr>
+          <a:xfrm>
+            <a:off x="914400" y="731520"/>
+            <a:ext cx="7315200" cy="2560320"/>
+          </a:xfrm>
+          <a:prstGeom prst="rect">
+            <a:avLst/>
+          </a:prstGeom>
+          <a:noFill/>
+          <a:ln/>
+        </p:spPr>
+        <p:txBody>
+          <a:bodyPr wrap="square" lIns="0" tIns="0" rIns="0" bIns="0" rtlCol="0" anchor="ctr"/>
+          <a:lstStyle/>
+          <a:p>
+            <a:pPr algn="ctr" indent="0" marL="0">
+              <a:buNone/>
+            </a:pPr>
+            <a:r>
+              <a:rPr lang="en-US" sz="4000" b="1" dirty="0">
+                <a:solidFill>
+                  <a:srgbClr val="FFFFFF"/>
+                </a:solidFill>
+                <a:latin typeface="Georgia" pitchFamily="34" charset="0"/>
+                <a:ea typeface="Georgia" pitchFamily="34" charset="-122"/>
+                <a:cs typeface="Georgia" pitchFamily="34" charset="-120"/>
+              </a:rPr>
+              <a:t>The gap between using AI safely</a:t>
+            </a:r>
+            <a:endParaRPr lang="en-US" sz="4000" dirty="0"/>
+          </a:p>
+          <a:p>
+            <a:pPr algn="ctr" indent="0" marL="0">
+              <a:buNone/>
+            </a:pPr>
+            <a:r>
+              <a:rPr lang="en-US" sz="4000" b="1" dirty="0">
+                <a:solidFill>
+                  <a:srgbClr val="FFFFFF"/>
+                </a:solidFill>
+                <a:latin typeface="Georgia" pitchFamily="34" charset="0"/>
+                <a:ea typeface="Georgia" pitchFamily="34" charset="-122"/>
+                <a:cs typeface="Georgia" pitchFamily="34" charset="-120"/>
+              </a:rPr>
+              <a:t>and using AI recklessly</a:t>
+            </a:r>
+            <a:endParaRPr lang="en-US" sz="4000" dirty="0"/>
+          </a:p>
+          <a:p>
+            <a:pPr algn="ctr" indent="0" marL="0">
+              <a:buNone/>
+            </a:pPr>
+            <a:r>
+              <a:rPr lang="en-US" sz="4000" b="1" dirty="0">
+                <a:solidFill>
+                  <a:srgbClr val="FFFFFF"/>
+                </a:solidFill>
+                <a:latin typeface="Georgia" pitchFamily="34" charset="0"/>
+                <a:ea typeface="Georgia" pitchFamily="34" charset="-122"/>
+                <a:cs typeface="Georgia" pitchFamily="34" charset="-120"/>
+              </a:rPr>
+              <a:t>isn’t about which model</a:t>
+            </a:r>
+            <a:endParaRPr lang="en-US" sz="4000" dirty="0"/>
+          </a:p>
+          <a:p>
+            <a:pPr algn="ctr" indent="0" marL="0">
+              <a:buNone/>
+            </a:pPr>
+            <a:r>
+              <a:rPr lang="en-US" sz="4000" b="1" dirty="0">
+                <a:solidFill>
+                  <a:srgbClr val="FFFFFF"/>
+                </a:solidFill>
+                <a:latin typeface="Georgia" pitchFamily="34" charset="0"/>
+                <a:ea typeface="Georgia" pitchFamily="34" charset="-122"/>
+                <a:cs typeface="Georgia" pitchFamily="34" charset="-120"/>
+              </a:rPr>
+              <a:t>is smartest.</a:t>
+            </a:r>
+            <a:endParaRPr lang="en-US" sz="4000" dirty="0"/>
+          </a:p>
+        </p:txBody>
+      </p:sp>
+    </p:spTree>
+  </p:cSld>
+  <p:clrMapOvr>
+    <a:masterClrMapping/>
+  </p:clrMapOvr>
+</p:sld>
+</file>
+
+<file path=ppt/slides/slide34.xml><?xml version="1.0" encoding="utf-8"?>
+<p:sld xmlns:a="http://schemas.openxmlformats.org/drawingml/2006/main" xmlns:r="http://schemas.openxmlformats.org/officeDocument/2006/relationships" xmlns:p="http://schemas.openxmlformats.org/presentationml/2006/main">
+  <p:cSld name="Slide 34">
     <p:bg>
       <p:bgPr>
         <a:solidFill>

</xml_diff>